<commit_message>
docs: add LangChain + LangGraph slide (slide 6)
Slide 6: LangChain + LangGraph in the PoC

Left card (LangGraph - blue):
- State machine orchestration via StateGraph
- Actual code snippet showing node definitions and conditional edges
- phi_mask -> pick_lane -> cache_lookup -> [emergency_agent | route_dept] -> retrieve -> generate -> cache_write -> END

Right card (LangChain - purple):
- langchain-text-splitters: SemanticChunker for clinical trial PDFs
- langchain-community: Redis cache integration
- langchain-core: base types used by LangGraph

Bottom: full node graph visualization with color-coded nodes
- Orange: pipeline nodes (phi_mask, pick_lane, cache_lookup, cache_write)
- Blue: routing nodes (emergency_agent, route_dept)
- Green: core processing (retrieve, generate)

Footer note: LangGraph = orchestration, LangChain = utilities,
neither replaces Bedrock Agents for tool calling
</commit_message>
<xml_diff>
--- a/docs/Technology_Explanation_Slides.pptx
+++ b/docs/Technology_Explanation_Slides.pptx
@@ -10,6 +10,7 @@
     <p:sldId id="258" r:id="rId9"/>
     <p:sldId id="259" r:id="rId10"/>
     <p:sldId id="260" r:id="rId11"/>
+    <p:sldId id="261" r:id="rId12"/>
   </p:sldIdLst>
   <p:sldSz cx="12191695" cy="6858000" type="screen4x3"/>
   <p:notesSz cx="6858000" cy="9144000"/>
@@ -13599,6 +13600,2430 @@
                 <a:latin typeface="Calibri"/>
               </a:rPr>
               <a:t>Key insight: RAG handles all factual updates (WHO, PubMed, trials). Fine-tuning is ONLY for tone, phrasing, and clinical vocabulary. Never for facts.</a:t>
+            </a:r>
+          </a:p>
+        </p:txBody>
+      </p:sp>
+    </p:spTree>
+  </p:cSld>
+  <p:clrMapOvr>
+    <a:masterClrMapping/>
+  </p:clrMapOvr>
+</p:sld>
+</file>
+
+<file path=ppt/slides/slide6.xml><?xml version="1.0" encoding="utf-8"?>
+<p:sld xmlns:a="http://schemas.openxmlformats.org/drawingml/2006/main" xmlns:p="http://schemas.openxmlformats.org/presentationml/2006/main" xmlns:r="http://schemas.openxmlformats.org/officeDocument/2006/relationships">
+  <p:cSld>
+    <p:spTree>
+      <p:nvGrpSpPr>
+        <p:cNvPr id="1" name=""/>
+        <p:cNvGrpSpPr/>
+        <p:nvPr/>
+      </p:nvGrpSpPr>
+      <p:grpSpPr/>
+      <p:sp>
+        <p:nvSpPr>
+          <p:cNvPr id="2" name="Rectangle 1"/>
+          <p:cNvSpPr/>
+          <p:nvPr/>
+        </p:nvSpPr>
+        <p:spPr>
+          <a:xfrm>
+            <a:off x="0" y="0"/>
+            <a:ext cx="12191695" cy="6858000"/>
+          </a:xfrm>
+          <a:prstGeom prst="rect">
+            <a:avLst/>
+          </a:prstGeom>
+          <a:solidFill>
+            <a:srgbClr val="FFFFFF"/>
+          </a:solidFill>
+          <a:ln>
+            <a:noFill/>
+          </a:ln>
+        </p:spPr>
+        <p:style>
+          <a:lnRef idx="1">
+            <a:schemeClr val="accent1"/>
+          </a:lnRef>
+          <a:fillRef idx="3">
+            <a:schemeClr val="accent1"/>
+          </a:fillRef>
+          <a:effectRef idx="2">
+            <a:schemeClr val="accent1"/>
+          </a:effectRef>
+          <a:fontRef idx="minor">
+            <a:schemeClr val="lt1"/>
+          </a:fontRef>
+        </p:style>
+        <p:txBody>
+          <a:bodyPr rtlCol="0" anchor="ctr"/>
+          <a:lstStyle/>
+          <a:p>
+            <a:pPr algn="ctr"/>
+          </a:p>
+        </p:txBody>
+      </p:sp>
+      <p:sp>
+        <p:nvSpPr>
+          <p:cNvPr id="3" name="Rectangle 2"/>
+          <p:cNvSpPr/>
+          <p:nvPr/>
+        </p:nvSpPr>
+        <p:spPr>
+          <a:xfrm>
+            <a:off x="0" y="0"/>
+            <a:ext cx="12191695" cy="109728"/>
+          </a:xfrm>
+          <a:prstGeom prst="rect">
+            <a:avLst/>
+          </a:prstGeom>
+          <a:solidFill>
+            <a:srgbClr val="FF6B35"/>
+          </a:solidFill>
+          <a:ln>
+            <a:noFill/>
+          </a:ln>
+        </p:spPr>
+        <p:style>
+          <a:lnRef idx="1">
+            <a:schemeClr val="accent1"/>
+          </a:lnRef>
+          <a:fillRef idx="3">
+            <a:schemeClr val="accent1"/>
+          </a:fillRef>
+          <a:effectRef idx="2">
+            <a:schemeClr val="accent1"/>
+          </a:effectRef>
+          <a:fontRef idx="minor">
+            <a:schemeClr val="lt1"/>
+          </a:fontRef>
+        </p:style>
+        <p:txBody>
+          <a:bodyPr rtlCol="0" anchor="ctr"/>
+          <a:lstStyle/>
+          <a:p>
+            <a:pPr algn="ctr"/>
+          </a:p>
+        </p:txBody>
+      </p:sp>
+      <p:sp>
+        <p:nvSpPr>
+          <p:cNvPr id="4" name="TextBox 3"/>
+          <p:cNvSpPr txBox="1"/>
+          <p:nvPr/>
+        </p:nvSpPr>
+        <p:spPr>
+          <a:xfrm>
+            <a:off x="457200" y="6492240"/>
+            <a:ext cx="11247120" cy="256032"/>
+          </a:xfrm>
+          <a:prstGeom prst="rect">
+            <a:avLst/>
+          </a:prstGeom>
+          <a:noFill/>
+        </p:spPr>
+        <p:txBody>
+          <a:bodyPr wrap="none">
+            <a:spAutoFit/>
+          </a:bodyPr>
+          <a:lstStyle/>
+          <a:p>
+            <a:pPr algn="r"/>
+            <a:r>
+              <a:rPr sz="900" i="1">
+                <a:solidFill>
+                  <a:srgbClr val="646464"/>
+                </a:solidFill>
+                <a:latin typeface="Calibri"/>
+              </a:rPr>
+              <a:t>Nova Health Tech  ·  Clinical GenAI Assistant  ·  AWS Singapore</a:t>
+            </a:r>
+          </a:p>
+        </p:txBody>
+      </p:sp>
+      <p:sp>
+        <p:nvSpPr>
+          <p:cNvPr id="5" name="TextBox 4"/>
+          <p:cNvSpPr txBox="1"/>
+          <p:nvPr/>
+        </p:nvSpPr>
+        <p:spPr>
+          <a:xfrm>
+            <a:off x="457200" y="201168"/>
+            <a:ext cx="11247120" cy="594360"/>
+          </a:xfrm>
+          <a:prstGeom prst="rect">
+            <a:avLst/>
+          </a:prstGeom>
+          <a:noFill/>
+        </p:spPr>
+        <p:txBody>
+          <a:bodyPr wrap="none" lIns="0" tIns="0">
+            <a:spAutoFit/>
+          </a:bodyPr>
+          <a:lstStyle/>
+          <a:p>
+            <a:pPr algn="l"/>
+            <a:r>
+              <a:rPr sz="2800" b="1">
+                <a:solidFill>
+                  <a:srgbClr val="CC4F1F"/>
+                </a:solidFill>
+                <a:latin typeface="Calibri"/>
+              </a:rPr>
+              <a:t>LangChain + LangGraph in the PoC</a:t>
+            </a:r>
+          </a:p>
+        </p:txBody>
+      </p:sp>
+      <p:sp>
+        <p:nvSpPr>
+          <p:cNvPr id="6" name="Rectangle 5"/>
+          <p:cNvSpPr/>
+          <p:nvPr/>
+        </p:nvSpPr>
+        <p:spPr>
+          <a:xfrm>
+            <a:off x="457200" y="841248"/>
+            <a:ext cx="5266944" cy="36576"/>
+          </a:xfrm>
+          <a:prstGeom prst="rect">
+            <a:avLst/>
+          </a:prstGeom>
+          <a:solidFill>
+            <a:srgbClr val="FF6B35"/>
+          </a:solidFill>
+          <a:ln>
+            <a:noFill/>
+          </a:ln>
+        </p:spPr>
+        <p:style>
+          <a:lnRef idx="1">
+            <a:schemeClr val="accent1"/>
+          </a:lnRef>
+          <a:fillRef idx="3">
+            <a:schemeClr val="accent1"/>
+          </a:fillRef>
+          <a:effectRef idx="2">
+            <a:schemeClr val="accent1"/>
+          </a:effectRef>
+          <a:fontRef idx="minor">
+            <a:schemeClr val="lt1"/>
+          </a:fontRef>
+        </p:style>
+        <p:txBody>
+          <a:bodyPr rtlCol="0" anchor="ctr"/>
+          <a:lstStyle/>
+          <a:p>
+            <a:pPr algn="ctr"/>
+          </a:p>
+        </p:txBody>
+      </p:sp>
+      <p:sp>
+        <p:nvSpPr>
+          <p:cNvPr id="7" name="Rounded Rectangle 6"/>
+          <p:cNvSpPr/>
+          <p:nvPr/>
+        </p:nvSpPr>
+        <p:spPr>
+          <a:xfrm>
+            <a:off x="457200" y="1005840"/>
+            <a:ext cx="5486400" cy="2926080"/>
+          </a:xfrm>
+          <a:prstGeom prst="roundRect">
+            <a:avLst>
+              <a:gd name="adj" fmla="val 6000"/>
+            </a:avLst>
+          </a:prstGeom>
+          <a:solidFill>
+            <a:srgbClr val="E3F2FD"/>
+          </a:solidFill>
+          <a:ln w="25400">
+            <a:solidFill>
+              <a:srgbClr val="2196F3"/>
+            </a:solidFill>
+          </a:ln>
+        </p:spPr>
+        <p:style>
+          <a:lnRef idx="1">
+            <a:schemeClr val="accent1"/>
+          </a:lnRef>
+          <a:fillRef idx="3">
+            <a:schemeClr val="accent1"/>
+          </a:fillRef>
+          <a:effectRef idx="2">
+            <a:schemeClr val="accent1"/>
+          </a:effectRef>
+          <a:fontRef idx="minor">
+            <a:schemeClr val="lt1"/>
+          </a:fontRef>
+        </p:style>
+        <p:txBody>
+          <a:bodyPr rtlCol="0" anchor="ctr"/>
+          <a:lstStyle/>
+          <a:p>
+            <a:pPr algn="ctr"/>
+          </a:p>
+        </p:txBody>
+      </p:sp>
+      <p:sp>
+        <p:nvSpPr>
+          <p:cNvPr id="8" name="Rectangle 7"/>
+          <p:cNvSpPr/>
+          <p:nvPr/>
+        </p:nvSpPr>
+        <p:spPr>
+          <a:xfrm>
+            <a:off x="457200" y="1005840"/>
+            <a:ext cx="5486400" cy="457200"/>
+          </a:xfrm>
+          <a:prstGeom prst="rect">
+            <a:avLst/>
+          </a:prstGeom>
+          <a:solidFill>
+            <a:srgbClr val="2196F3"/>
+          </a:solidFill>
+          <a:ln>
+            <a:noFill/>
+          </a:ln>
+        </p:spPr>
+        <p:style>
+          <a:lnRef idx="1">
+            <a:schemeClr val="accent1"/>
+          </a:lnRef>
+          <a:fillRef idx="3">
+            <a:schemeClr val="accent1"/>
+          </a:fillRef>
+          <a:effectRef idx="2">
+            <a:schemeClr val="accent1"/>
+          </a:effectRef>
+          <a:fontRef idx="minor">
+            <a:schemeClr val="lt1"/>
+          </a:fontRef>
+        </p:style>
+        <p:txBody>
+          <a:bodyPr rtlCol="0" anchor="ctr"/>
+          <a:lstStyle/>
+          <a:p>
+            <a:pPr algn="ctr"/>
+          </a:p>
+        </p:txBody>
+      </p:sp>
+      <p:sp>
+        <p:nvSpPr>
+          <p:cNvPr id="9" name="TextBox 8"/>
+          <p:cNvSpPr txBox="1"/>
+          <p:nvPr/>
+        </p:nvSpPr>
+        <p:spPr>
+          <a:xfrm>
+            <a:off x="457200" y="1005840"/>
+            <a:ext cx="5486400" cy="457200"/>
+          </a:xfrm>
+          <a:prstGeom prst="rect">
+            <a:avLst/>
+          </a:prstGeom>
+          <a:noFill/>
+        </p:spPr>
+        <p:txBody>
+          <a:bodyPr wrap="square">
+            <a:spAutoFit/>
+          </a:bodyPr>
+          <a:lstStyle/>
+          <a:p>
+            <a:pPr algn="ctr"/>
+            <a:r>
+              <a:rPr sz="1400" b="1" i="0">
+                <a:solidFill>
+                  <a:srgbClr val="FFFFFF"/>
+                </a:solidFill>
+                <a:latin typeface="Calibri"/>
+              </a:rPr>
+              <a:t>LangGraph  -  State Machine Orchestration</a:t>
+            </a:r>
+          </a:p>
+        </p:txBody>
+      </p:sp>
+      <p:sp>
+        <p:nvSpPr>
+          <p:cNvPr id="10" name="TextBox 9"/>
+          <p:cNvSpPr txBox="1"/>
+          <p:nvPr/>
+        </p:nvSpPr>
+        <p:spPr>
+          <a:xfrm>
+            <a:off x="640080" y="1572768"/>
+            <a:ext cx="5120640" cy="411480"/>
+          </a:xfrm>
+          <a:prstGeom prst="rect">
+            <a:avLst/>
+          </a:prstGeom>
+          <a:noFill/>
+        </p:spPr>
+        <p:txBody>
+          <a:bodyPr wrap="square">
+            <a:spAutoFit/>
+          </a:bodyPr>
+          <a:lstStyle/>
+          <a:p>
+            <a:pPr algn="l"/>
+            <a:r>
+              <a:rPr sz="1050" b="0" i="0">
+                <a:solidFill>
+                  <a:srgbClr val="2C3E50"/>
+                </a:solidFill>
+                <a:latin typeface="Calibri"/>
+              </a:rPr>
+              <a:t>Defines the request pipeline as a directed graph of nodes + edges. Each node is a processing step; edges are conditional transitions.</a:t>
+            </a:r>
+          </a:p>
+        </p:txBody>
+      </p:sp>
+      <p:sp>
+        <p:nvSpPr>
+          <p:cNvPr id="11" name="Rectangle 10"/>
+          <p:cNvSpPr/>
+          <p:nvPr/>
+        </p:nvSpPr>
+        <p:spPr>
+          <a:xfrm>
+            <a:off x="640080" y="2057400"/>
+            <a:ext cx="5120640" cy="1645920"/>
+          </a:xfrm>
+          <a:prstGeom prst="rect">
+            <a:avLst/>
+          </a:prstGeom>
+          <a:solidFill>
+            <a:srgbClr val="F5F5F5"/>
+          </a:solidFill>
+          <a:ln w="9525">
+            <a:solidFill>
+              <a:srgbClr val="CBD5E1"/>
+            </a:solidFill>
+          </a:ln>
+        </p:spPr>
+        <p:style>
+          <a:lnRef idx="1">
+            <a:schemeClr val="accent1"/>
+          </a:lnRef>
+          <a:fillRef idx="3">
+            <a:schemeClr val="accent1"/>
+          </a:fillRef>
+          <a:effectRef idx="2">
+            <a:schemeClr val="accent1"/>
+          </a:effectRef>
+          <a:fontRef idx="minor">
+            <a:schemeClr val="lt1"/>
+          </a:fontRef>
+        </p:style>
+        <p:txBody>
+          <a:bodyPr rtlCol="0" anchor="ctr"/>
+          <a:lstStyle/>
+          <a:p>
+            <a:pPr algn="ctr"/>
+          </a:p>
+        </p:txBody>
+      </p:sp>
+      <p:sp>
+        <p:nvSpPr>
+          <p:cNvPr id="12" name="TextBox 11"/>
+          <p:cNvSpPr txBox="1"/>
+          <p:nvPr/>
+        </p:nvSpPr>
+        <p:spPr>
+          <a:xfrm>
+            <a:off x="777240" y="2121408"/>
+            <a:ext cx="4846320" cy="128016"/>
+          </a:xfrm>
+          <a:prstGeom prst="rect">
+            <a:avLst/>
+          </a:prstGeom>
+          <a:noFill/>
+        </p:spPr>
+        <p:txBody>
+          <a:bodyPr wrap="none">
+            <a:spAutoFit/>
+          </a:bodyPr>
+          <a:lstStyle/>
+          <a:p>
+            <a:r>
+              <a:rPr sz="850">
+                <a:solidFill>
+                  <a:srgbClr val="2196F3"/>
+                </a:solidFill>
+                <a:latin typeface="Courier New"/>
+              </a:rPr>
+              <a:t>from langgraph.graph import END, StateGraph</a:t>
+            </a:r>
+          </a:p>
+        </p:txBody>
+      </p:sp>
+      <p:sp>
+        <p:nvSpPr>
+          <p:cNvPr id="13" name="TextBox 12"/>
+          <p:cNvSpPr txBox="1"/>
+          <p:nvPr/>
+        </p:nvSpPr>
+        <p:spPr>
+          <a:xfrm>
+            <a:off x="777240" y="2240279"/>
+            <a:ext cx="4846320" cy="128016"/>
+          </a:xfrm>
+          <a:prstGeom prst="rect">
+            <a:avLst/>
+          </a:prstGeom>
+          <a:noFill/>
+        </p:spPr>
+        <p:txBody>
+          <a:bodyPr wrap="none">
+            <a:spAutoFit/>
+          </a:bodyPr>
+          <a:lstStyle/>
+          <a:p>
+            <a:r>
+              <a:rPr sz="850">
+                <a:solidFill>
+                  <a:srgbClr val="2C3E50"/>
+                </a:solidFill>
+                <a:latin typeface="Courier New"/>
+              </a:rPr>
+              <a:t/>
+            </a:r>
+          </a:p>
+        </p:txBody>
+      </p:sp>
+      <p:sp>
+        <p:nvSpPr>
+          <p:cNvPr id="14" name="TextBox 13"/>
+          <p:cNvSpPr txBox="1"/>
+          <p:nvPr/>
+        </p:nvSpPr>
+        <p:spPr>
+          <a:xfrm>
+            <a:off x="777240" y="2359152"/>
+            <a:ext cx="4846320" cy="128016"/>
+          </a:xfrm>
+          <a:prstGeom prst="rect">
+            <a:avLst/>
+          </a:prstGeom>
+          <a:noFill/>
+        </p:spPr>
+        <p:txBody>
+          <a:bodyPr wrap="none">
+            <a:spAutoFit/>
+          </a:bodyPr>
+          <a:lstStyle/>
+          <a:p>
+            <a:r>
+              <a:rPr sz="850">
+                <a:solidFill>
+                  <a:srgbClr val="2C3E50"/>
+                </a:solidFill>
+                <a:latin typeface="Courier New"/>
+              </a:rPr>
+              <a:t>g = StateGraph(ChatState)</a:t>
+            </a:r>
+          </a:p>
+        </p:txBody>
+      </p:sp>
+      <p:sp>
+        <p:nvSpPr>
+          <p:cNvPr id="15" name="TextBox 14"/>
+          <p:cNvSpPr txBox="1"/>
+          <p:nvPr/>
+        </p:nvSpPr>
+        <p:spPr>
+          <a:xfrm>
+            <a:off x="777240" y="2478024"/>
+            <a:ext cx="4846320" cy="128016"/>
+          </a:xfrm>
+          <a:prstGeom prst="rect">
+            <a:avLst/>
+          </a:prstGeom>
+          <a:noFill/>
+        </p:spPr>
+        <p:txBody>
+          <a:bodyPr wrap="none">
+            <a:spAutoFit/>
+          </a:bodyPr>
+          <a:lstStyle/>
+          <a:p>
+            <a:r>
+              <a:rPr sz="850">
+                <a:solidFill>
+                  <a:srgbClr val="2196F3"/>
+                </a:solidFill>
+                <a:latin typeface="Courier New"/>
+              </a:rPr>
+              <a:t>g.add_node("phi_mask",  _node_phi_mask)</a:t>
+            </a:r>
+          </a:p>
+        </p:txBody>
+      </p:sp>
+      <p:sp>
+        <p:nvSpPr>
+          <p:cNvPr id="16" name="TextBox 15"/>
+          <p:cNvSpPr txBox="1"/>
+          <p:nvPr/>
+        </p:nvSpPr>
+        <p:spPr>
+          <a:xfrm>
+            <a:off x="777240" y="2596896"/>
+            <a:ext cx="4846320" cy="128016"/>
+          </a:xfrm>
+          <a:prstGeom prst="rect">
+            <a:avLst/>
+          </a:prstGeom>
+          <a:noFill/>
+        </p:spPr>
+        <p:txBody>
+          <a:bodyPr wrap="none">
+            <a:spAutoFit/>
+          </a:bodyPr>
+          <a:lstStyle/>
+          <a:p>
+            <a:r>
+              <a:rPr sz="850">
+                <a:solidFill>
+                  <a:srgbClr val="2196F3"/>
+                </a:solidFill>
+                <a:latin typeface="Courier New"/>
+              </a:rPr>
+              <a:t>g.add_node("pick_lane", _node_pick_lane)</a:t>
+            </a:r>
+          </a:p>
+        </p:txBody>
+      </p:sp>
+      <p:sp>
+        <p:nvSpPr>
+          <p:cNvPr id="17" name="TextBox 16"/>
+          <p:cNvSpPr txBox="1"/>
+          <p:nvPr/>
+        </p:nvSpPr>
+        <p:spPr>
+          <a:xfrm>
+            <a:off x="777240" y="2715768"/>
+            <a:ext cx="4846320" cy="128016"/>
+          </a:xfrm>
+          <a:prstGeom prst="rect">
+            <a:avLst/>
+          </a:prstGeom>
+          <a:noFill/>
+        </p:spPr>
+        <p:txBody>
+          <a:bodyPr wrap="none">
+            <a:spAutoFit/>
+          </a:bodyPr>
+          <a:lstStyle/>
+          <a:p>
+            <a:r>
+              <a:rPr sz="850">
+                <a:solidFill>
+                  <a:srgbClr val="2196F3"/>
+                </a:solidFill>
+                <a:latin typeface="Courier New"/>
+              </a:rPr>
+              <a:t>g.add_node("retrieve",  _node_retrieve)</a:t>
+            </a:r>
+          </a:p>
+        </p:txBody>
+      </p:sp>
+      <p:sp>
+        <p:nvSpPr>
+          <p:cNvPr id="18" name="TextBox 17"/>
+          <p:cNvSpPr txBox="1"/>
+          <p:nvPr/>
+        </p:nvSpPr>
+        <p:spPr>
+          <a:xfrm>
+            <a:off x="777240" y="2834639"/>
+            <a:ext cx="4846320" cy="128016"/>
+          </a:xfrm>
+          <a:prstGeom prst="rect">
+            <a:avLst/>
+          </a:prstGeom>
+          <a:noFill/>
+        </p:spPr>
+        <p:txBody>
+          <a:bodyPr wrap="none">
+            <a:spAutoFit/>
+          </a:bodyPr>
+          <a:lstStyle/>
+          <a:p>
+            <a:r>
+              <a:rPr sz="850">
+                <a:solidFill>
+                  <a:srgbClr val="2196F3"/>
+                </a:solidFill>
+                <a:latin typeface="Courier New"/>
+              </a:rPr>
+              <a:t>g.add_node("generate",  _node_generate)</a:t>
+            </a:r>
+          </a:p>
+        </p:txBody>
+      </p:sp>
+      <p:sp>
+        <p:nvSpPr>
+          <p:cNvPr id="19" name="TextBox 18"/>
+          <p:cNvSpPr txBox="1"/>
+          <p:nvPr/>
+        </p:nvSpPr>
+        <p:spPr>
+          <a:xfrm>
+            <a:off x="777240" y="2953512"/>
+            <a:ext cx="4846320" cy="128016"/>
+          </a:xfrm>
+          <a:prstGeom prst="rect">
+            <a:avLst/>
+          </a:prstGeom>
+          <a:noFill/>
+        </p:spPr>
+        <p:txBody>
+          <a:bodyPr wrap="none">
+            <a:spAutoFit/>
+          </a:bodyPr>
+          <a:lstStyle/>
+          <a:p>
+            <a:r>
+              <a:rPr sz="850">
+                <a:solidFill>
+                  <a:srgbClr val="2196F3"/>
+                </a:solidFill>
+                <a:latin typeface="Courier New"/>
+              </a:rPr>
+              <a:t>g.add_conditional_edges("cache_lookup",</a:t>
+            </a:r>
+          </a:p>
+        </p:txBody>
+      </p:sp>
+      <p:sp>
+        <p:nvSpPr>
+          <p:cNvPr id="20" name="TextBox 19"/>
+          <p:cNvSpPr txBox="1"/>
+          <p:nvPr/>
+        </p:nvSpPr>
+        <p:spPr>
+          <a:xfrm>
+            <a:off x="777240" y="3072384"/>
+            <a:ext cx="4846320" cy="128016"/>
+          </a:xfrm>
+          <a:prstGeom prst="rect">
+            <a:avLst/>
+          </a:prstGeom>
+          <a:noFill/>
+        </p:spPr>
+        <p:txBody>
+          <a:bodyPr wrap="none">
+            <a:spAutoFit/>
+          </a:bodyPr>
+          <a:lstStyle/>
+          <a:p>
+            <a:r>
+              <a:rPr sz="850">
+                <a:solidFill>
+                  <a:srgbClr val="2C3E50"/>
+                </a:solidFill>
+                <a:latin typeface="Courier New"/>
+              </a:rPr>
+              <a:t>    _branch_on_lane,</a:t>
+            </a:r>
+          </a:p>
+        </p:txBody>
+      </p:sp>
+      <p:sp>
+        <p:nvSpPr>
+          <p:cNvPr id="21" name="TextBox 20"/>
+          <p:cNvSpPr txBox="1"/>
+          <p:nvPr/>
+        </p:nvSpPr>
+        <p:spPr>
+          <a:xfrm>
+            <a:off x="777240" y="3191256"/>
+            <a:ext cx="4846320" cy="128016"/>
+          </a:xfrm>
+          <a:prstGeom prst="rect">
+            <a:avLst/>
+          </a:prstGeom>
+          <a:noFill/>
+        </p:spPr>
+        <p:txBody>
+          <a:bodyPr wrap="none">
+            <a:spAutoFit/>
+          </a:bodyPr>
+          <a:lstStyle/>
+          <a:p>
+            <a:r>
+              <a:rPr sz="850">
+                <a:solidFill>
+                  <a:srgbClr val="2C3E50"/>
+                </a:solidFill>
+                <a:latin typeface="Courier New"/>
+              </a:rPr>
+              <a:t>    {"emergency": "emergency_agent",</a:t>
+            </a:r>
+          </a:p>
+        </p:txBody>
+      </p:sp>
+      <p:sp>
+        <p:nvSpPr>
+          <p:cNvPr id="22" name="TextBox 21"/>
+          <p:cNvSpPr txBox="1"/>
+          <p:nvPr/>
+        </p:nvSpPr>
+        <p:spPr>
+          <a:xfrm>
+            <a:off x="777240" y="3310128"/>
+            <a:ext cx="4846320" cy="128016"/>
+          </a:xfrm>
+          <a:prstGeom prst="rect">
+            <a:avLst/>
+          </a:prstGeom>
+          <a:noFill/>
+        </p:spPr>
+        <p:txBody>
+          <a:bodyPr wrap="none">
+            <a:spAutoFit/>
+          </a:bodyPr>
+          <a:lstStyle/>
+          <a:p>
+            <a:r>
+              <a:rPr sz="850">
+                <a:solidFill>
+                  <a:srgbClr val="2C3E50"/>
+                </a:solidFill>
+                <a:latin typeface="Courier New"/>
+              </a:rPr>
+              <a:t>     "complex":   "route_department"})</a:t>
+            </a:r>
+          </a:p>
+        </p:txBody>
+      </p:sp>
+      <p:sp>
+        <p:nvSpPr>
+          <p:cNvPr id="23" name="TextBox 22"/>
+          <p:cNvSpPr txBox="1"/>
+          <p:nvPr/>
+        </p:nvSpPr>
+        <p:spPr>
+          <a:xfrm>
+            <a:off x="777240" y="3429000"/>
+            <a:ext cx="4846320" cy="128016"/>
+          </a:xfrm>
+          <a:prstGeom prst="rect">
+            <a:avLst/>
+          </a:prstGeom>
+          <a:noFill/>
+        </p:spPr>
+        <p:txBody>
+          <a:bodyPr wrap="none">
+            <a:spAutoFit/>
+          </a:bodyPr>
+          <a:lstStyle/>
+          <a:p>
+            <a:r>
+              <a:rPr sz="850">
+                <a:solidFill>
+                  <a:srgbClr val="2196F3"/>
+                </a:solidFill>
+                <a:latin typeface="Courier New"/>
+              </a:rPr>
+              <a:t>graph = g.compile()</a:t>
+            </a:r>
+          </a:p>
+        </p:txBody>
+      </p:sp>
+      <p:sp>
+        <p:nvSpPr>
+          <p:cNvPr id="24" name="Rounded Rectangle 23"/>
+          <p:cNvSpPr/>
+          <p:nvPr/>
+        </p:nvSpPr>
+        <p:spPr>
+          <a:xfrm>
+            <a:off x="6217920" y="1005840"/>
+            <a:ext cx="5486400" cy="2926080"/>
+          </a:xfrm>
+          <a:prstGeom prst="roundRect">
+            <a:avLst>
+              <a:gd name="adj" fmla="val 6000"/>
+            </a:avLst>
+          </a:prstGeom>
+          <a:solidFill>
+            <a:srgbClr val="F3E5F5"/>
+          </a:solidFill>
+          <a:ln w="25400">
+            <a:solidFill>
+              <a:srgbClr val="7B1FA2"/>
+            </a:solidFill>
+          </a:ln>
+        </p:spPr>
+        <p:style>
+          <a:lnRef idx="1">
+            <a:schemeClr val="accent1"/>
+          </a:lnRef>
+          <a:fillRef idx="3">
+            <a:schemeClr val="accent1"/>
+          </a:fillRef>
+          <a:effectRef idx="2">
+            <a:schemeClr val="accent1"/>
+          </a:effectRef>
+          <a:fontRef idx="minor">
+            <a:schemeClr val="lt1"/>
+          </a:fontRef>
+        </p:style>
+        <p:txBody>
+          <a:bodyPr rtlCol="0" anchor="ctr"/>
+          <a:lstStyle/>
+          <a:p>
+            <a:pPr algn="ctr"/>
+          </a:p>
+        </p:txBody>
+      </p:sp>
+      <p:sp>
+        <p:nvSpPr>
+          <p:cNvPr id="25" name="Rectangle 24"/>
+          <p:cNvSpPr/>
+          <p:nvPr/>
+        </p:nvSpPr>
+        <p:spPr>
+          <a:xfrm>
+            <a:off x="6217920" y="1005840"/>
+            <a:ext cx="5486400" cy="457200"/>
+          </a:xfrm>
+          <a:prstGeom prst="rect">
+            <a:avLst/>
+          </a:prstGeom>
+          <a:solidFill>
+            <a:srgbClr val="7B1FA2"/>
+          </a:solidFill>
+          <a:ln>
+            <a:noFill/>
+          </a:ln>
+        </p:spPr>
+        <p:style>
+          <a:lnRef idx="1">
+            <a:schemeClr val="accent1"/>
+          </a:lnRef>
+          <a:fillRef idx="3">
+            <a:schemeClr val="accent1"/>
+          </a:fillRef>
+          <a:effectRef idx="2">
+            <a:schemeClr val="accent1"/>
+          </a:effectRef>
+          <a:fontRef idx="minor">
+            <a:schemeClr val="lt1"/>
+          </a:fontRef>
+        </p:style>
+        <p:txBody>
+          <a:bodyPr rtlCol="0" anchor="ctr"/>
+          <a:lstStyle/>
+          <a:p>
+            <a:pPr algn="ctr"/>
+          </a:p>
+        </p:txBody>
+      </p:sp>
+      <p:sp>
+        <p:nvSpPr>
+          <p:cNvPr id="26" name="TextBox 25"/>
+          <p:cNvSpPr txBox="1"/>
+          <p:nvPr/>
+        </p:nvSpPr>
+        <p:spPr>
+          <a:xfrm>
+            <a:off x="6217920" y="1005840"/>
+            <a:ext cx="5486400" cy="457200"/>
+          </a:xfrm>
+          <a:prstGeom prst="rect">
+            <a:avLst/>
+          </a:prstGeom>
+          <a:noFill/>
+        </p:spPr>
+        <p:txBody>
+          <a:bodyPr wrap="square">
+            <a:spAutoFit/>
+          </a:bodyPr>
+          <a:lstStyle/>
+          <a:p>
+            <a:pPr algn="ctr"/>
+            <a:r>
+              <a:rPr sz="1400" b="1" i="0">
+                <a:solidFill>
+                  <a:srgbClr val="FFFFFF"/>
+                </a:solidFill>
+                <a:latin typeface="Calibri"/>
+              </a:rPr>
+              <a:t>LangChain  -  Text Splitting + Cache</a:t>
+            </a:r>
+          </a:p>
+        </p:txBody>
+      </p:sp>
+      <p:sp>
+        <p:nvSpPr>
+          <p:cNvPr id="27" name="TextBox 26"/>
+          <p:cNvSpPr txBox="1"/>
+          <p:nvPr/>
+        </p:nvSpPr>
+        <p:spPr>
+          <a:xfrm>
+            <a:off x="6400800" y="1572768"/>
+            <a:ext cx="5120640" cy="411480"/>
+          </a:xfrm>
+          <a:prstGeom prst="rect">
+            <a:avLst/>
+          </a:prstGeom>
+          <a:noFill/>
+        </p:spPr>
+        <p:txBody>
+          <a:bodyPr wrap="square">
+            <a:spAutoFit/>
+          </a:bodyPr>
+          <a:lstStyle/>
+          <a:p>
+            <a:pPr algn="l"/>
+            <a:r>
+              <a:rPr sz="1050" b="0" i="0">
+                <a:solidFill>
+                  <a:srgbClr val="2C3E50"/>
+                </a:solidFill>
+                <a:latin typeface="Calibri"/>
+              </a:rPr>
+              <a:t>Used for two specific utilities: semantic text splitting during ingestion, and the Redis semantic cache layer.</a:t>
+            </a:r>
+          </a:p>
+        </p:txBody>
+      </p:sp>
+      <p:sp>
+        <p:nvSpPr>
+          <p:cNvPr id="28" name="Rounded Rectangle 27"/>
+          <p:cNvSpPr/>
+          <p:nvPr/>
+        </p:nvSpPr>
+        <p:spPr>
+          <a:xfrm>
+            <a:off x="6400800" y="2084831"/>
+            <a:ext cx="5120640" cy="530352"/>
+          </a:xfrm>
+          <a:prstGeom prst="roundRect">
+            <a:avLst>
+              <a:gd name="adj" fmla="val 8000"/>
+            </a:avLst>
+          </a:prstGeom>
+          <a:solidFill>
+            <a:srgbClr val="FFFFFF"/>
+          </a:solidFill>
+          <a:ln w="15240">
+            <a:solidFill>
+              <a:srgbClr val="7B1FA2"/>
+            </a:solidFill>
+          </a:ln>
+        </p:spPr>
+        <p:style>
+          <a:lnRef idx="1">
+            <a:schemeClr val="accent1"/>
+          </a:lnRef>
+          <a:fillRef idx="3">
+            <a:schemeClr val="accent1"/>
+          </a:fillRef>
+          <a:effectRef idx="2">
+            <a:schemeClr val="accent1"/>
+          </a:effectRef>
+          <a:fontRef idx="minor">
+            <a:schemeClr val="lt1"/>
+          </a:fontRef>
+        </p:style>
+        <p:txBody>
+          <a:bodyPr rtlCol="0" anchor="ctr"/>
+          <a:lstStyle/>
+          <a:p>
+            <a:pPr algn="ctr"/>
+          </a:p>
+        </p:txBody>
+      </p:sp>
+      <p:sp>
+        <p:nvSpPr>
+          <p:cNvPr id="29" name="Rectangle 28"/>
+          <p:cNvSpPr/>
+          <p:nvPr/>
+        </p:nvSpPr>
+        <p:spPr>
+          <a:xfrm>
+            <a:off x="6400800" y="2084831"/>
+            <a:ext cx="54864" cy="530352"/>
+          </a:xfrm>
+          <a:prstGeom prst="rect">
+            <a:avLst/>
+          </a:prstGeom>
+          <a:solidFill>
+            <a:srgbClr val="7B1FA2"/>
+          </a:solidFill>
+          <a:ln>
+            <a:noFill/>
+          </a:ln>
+        </p:spPr>
+        <p:style>
+          <a:lnRef idx="1">
+            <a:schemeClr val="accent1"/>
+          </a:lnRef>
+          <a:fillRef idx="3">
+            <a:schemeClr val="accent1"/>
+          </a:fillRef>
+          <a:effectRef idx="2">
+            <a:schemeClr val="accent1"/>
+          </a:effectRef>
+          <a:fontRef idx="minor">
+            <a:schemeClr val="lt1"/>
+          </a:fontRef>
+        </p:style>
+        <p:txBody>
+          <a:bodyPr rtlCol="0" anchor="ctr"/>
+          <a:lstStyle/>
+          <a:p>
+            <a:pPr algn="ctr"/>
+          </a:p>
+        </p:txBody>
+      </p:sp>
+      <p:sp>
+        <p:nvSpPr>
+          <p:cNvPr id="30" name="TextBox 29"/>
+          <p:cNvSpPr txBox="1"/>
+          <p:nvPr/>
+        </p:nvSpPr>
+        <p:spPr>
+          <a:xfrm>
+            <a:off x="6537960" y="2121407"/>
+            <a:ext cx="1828800" cy="228600"/>
+          </a:xfrm>
+          <a:prstGeom prst="rect">
+            <a:avLst/>
+          </a:prstGeom>
+          <a:noFill/>
+        </p:spPr>
+        <p:txBody>
+          <a:bodyPr wrap="square">
+            <a:spAutoFit/>
+          </a:bodyPr>
+          <a:lstStyle/>
+          <a:p>
+            <a:pPr algn="l"/>
+            <a:r>
+              <a:rPr sz="950" b="1" i="0">
+                <a:solidFill>
+                  <a:srgbClr val="7B1FA2"/>
+                </a:solidFill>
+                <a:latin typeface="Calibri"/>
+              </a:rPr>
+              <a:t>langchain-text-splitters</a:t>
+            </a:r>
+          </a:p>
+        </p:txBody>
+      </p:sp>
+      <p:sp>
+        <p:nvSpPr>
+          <p:cNvPr id="31" name="TextBox 30"/>
+          <p:cNvSpPr txBox="1"/>
+          <p:nvPr/>
+        </p:nvSpPr>
+        <p:spPr>
+          <a:xfrm>
+            <a:off x="6537960" y="2340863"/>
+            <a:ext cx="4846320" cy="256032"/>
+          </a:xfrm>
+          <a:prstGeom prst="rect">
+            <a:avLst/>
+          </a:prstGeom>
+          <a:noFill/>
+        </p:spPr>
+        <p:txBody>
+          <a:bodyPr wrap="square">
+            <a:spAutoFit/>
+          </a:bodyPr>
+          <a:lstStyle/>
+          <a:p>
+            <a:pPr algn="l"/>
+            <a:r>
+              <a:rPr sz="900" b="0" i="1">
+                <a:solidFill>
+                  <a:srgbClr val="2C3E50"/>
+                </a:solidFill>
+                <a:latin typeface="Calibri"/>
+              </a:rPr>
+              <a:t>SemanticChunker for clinical trial PDFs
+(max 512 tokens, 80th percentile breakpoint)</a:t>
+            </a:r>
+          </a:p>
+        </p:txBody>
+      </p:sp>
+      <p:sp>
+        <p:nvSpPr>
+          <p:cNvPr id="32" name="Rounded Rectangle 31"/>
+          <p:cNvSpPr/>
+          <p:nvPr/>
+        </p:nvSpPr>
+        <p:spPr>
+          <a:xfrm>
+            <a:off x="6400800" y="2679191"/>
+            <a:ext cx="5120640" cy="530352"/>
+          </a:xfrm>
+          <a:prstGeom prst="roundRect">
+            <a:avLst>
+              <a:gd name="adj" fmla="val 8000"/>
+            </a:avLst>
+          </a:prstGeom>
+          <a:solidFill>
+            <a:srgbClr val="FFFFFF"/>
+          </a:solidFill>
+          <a:ln w="15240">
+            <a:solidFill>
+              <a:srgbClr val="7B1FA2"/>
+            </a:solidFill>
+          </a:ln>
+        </p:spPr>
+        <p:style>
+          <a:lnRef idx="1">
+            <a:schemeClr val="accent1"/>
+          </a:lnRef>
+          <a:fillRef idx="3">
+            <a:schemeClr val="accent1"/>
+          </a:fillRef>
+          <a:effectRef idx="2">
+            <a:schemeClr val="accent1"/>
+          </a:effectRef>
+          <a:fontRef idx="minor">
+            <a:schemeClr val="lt1"/>
+          </a:fontRef>
+        </p:style>
+        <p:txBody>
+          <a:bodyPr rtlCol="0" anchor="ctr"/>
+          <a:lstStyle/>
+          <a:p>
+            <a:pPr algn="ctr"/>
+          </a:p>
+        </p:txBody>
+      </p:sp>
+      <p:sp>
+        <p:nvSpPr>
+          <p:cNvPr id="33" name="Rectangle 32"/>
+          <p:cNvSpPr/>
+          <p:nvPr/>
+        </p:nvSpPr>
+        <p:spPr>
+          <a:xfrm>
+            <a:off x="6400800" y="2679191"/>
+            <a:ext cx="54864" cy="530352"/>
+          </a:xfrm>
+          <a:prstGeom prst="rect">
+            <a:avLst/>
+          </a:prstGeom>
+          <a:solidFill>
+            <a:srgbClr val="7B1FA2"/>
+          </a:solidFill>
+          <a:ln>
+            <a:noFill/>
+          </a:ln>
+        </p:spPr>
+        <p:style>
+          <a:lnRef idx="1">
+            <a:schemeClr val="accent1"/>
+          </a:lnRef>
+          <a:fillRef idx="3">
+            <a:schemeClr val="accent1"/>
+          </a:fillRef>
+          <a:effectRef idx="2">
+            <a:schemeClr val="accent1"/>
+          </a:effectRef>
+          <a:fontRef idx="minor">
+            <a:schemeClr val="lt1"/>
+          </a:fontRef>
+        </p:style>
+        <p:txBody>
+          <a:bodyPr rtlCol="0" anchor="ctr"/>
+          <a:lstStyle/>
+          <a:p>
+            <a:pPr algn="ctr"/>
+          </a:p>
+        </p:txBody>
+      </p:sp>
+      <p:sp>
+        <p:nvSpPr>
+          <p:cNvPr id="34" name="TextBox 33"/>
+          <p:cNvSpPr txBox="1"/>
+          <p:nvPr/>
+        </p:nvSpPr>
+        <p:spPr>
+          <a:xfrm>
+            <a:off x="6537960" y="2715767"/>
+            <a:ext cx="1828800" cy="228600"/>
+          </a:xfrm>
+          <a:prstGeom prst="rect">
+            <a:avLst/>
+          </a:prstGeom>
+          <a:noFill/>
+        </p:spPr>
+        <p:txBody>
+          <a:bodyPr wrap="square">
+            <a:spAutoFit/>
+          </a:bodyPr>
+          <a:lstStyle/>
+          <a:p>
+            <a:pPr algn="l"/>
+            <a:r>
+              <a:rPr sz="950" b="1" i="0">
+                <a:solidFill>
+                  <a:srgbClr val="7B1FA2"/>
+                </a:solidFill>
+                <a:latin typeface="Calibri"/>
+              </a:rPr>
+              <a:t>langchain-community</a:t>
+            </a:r>
+          </a:p>
+        </p:txBody>
+      </p:sp>
+      <p:sp>
+        <p:nvSpPr>
+          <p:cNvPr id="35" name="TextBox 34"/>
+          <p:cNvSpPr txBox="1"/>
+          <p:nvPr/>
+        </p:nvSpPr>
+        <p:spPr>
+          <a:xfrm>
+            <a:off x="6537960" y="2935223"/>
+            <a:ext cx="4846320" cy="256032"/>
+          </a:xfrm>
+          <a:prstGeom prst="rect">
+            <a:avLst/>
+          </a:prstGeom>
+          <a:noFill/>
+        </p:spPr>
+        <p:txBody>
+          <a:bodyPr wrap="square">
+            <a:spAutoFit/>
+          </a:bodyPr>
+          <a:lstStyle/>
+          <a:p>
+            <a:pPr algn="l"/>
+            <a:r>
+              <a:rPr sz="900" b="0" i="1">
+                <a:solidFill>
+                  <a:srgbClr val="2C3E50"/>
+                </a:solidFill>
+                <a:latin typeface="Calibri"/>
+              </a:rPr>
+              <a:t>Redis cache integration (SHA-256 key in PoC,
+vector similarity in production)</a:t>
+            </a:r>
+          </a:p>
+        </p:txBody>
+      </p:sp>
+      <p:sp>
+        <p:nvSpPr>
+          <p:cNvPr id="36" name="Rounded Rectangle 35"/>
+          <p:cNvSpPr/>
+          <p:nvPr/>
+        </p:nvSpPr>
+        <p:spPr>
+          <a:xfrm>
+            <a:off x="6400800" y="3273552"/>
+            <a:ext cx="5120640" cy="530352"/>
+          </a:xfrm>
+          <a:prstGeom prst="roundRect">
+            <a:avLst>
+              <a:gd name="adj" fmla="val 8000"/>
+            </a:avLst>
+          </a:prstGeom>
+          <a:solidFill>
+            <a:srgbClr val="FFFFFF"/>
+          </a:solidFill>
+          <a:ln w="15240">
+            <a:solidFill>
+              <a:srgbClr val="7B1FA2"/>
+            </a:solidFill>
+          </a:ln>
+        </p:spPr>
+        <p:style>
+          <a:lnRef idx="1">
+            <a:schemeClr val="accent1"/>
+          </a:lnRef>
+          <a:fillRef idx="3">
+            <a:schemeClr val="accent1"/>
+          </a:fillRef>
+          <a:effectRef idx="2">
+            <a:schemeClr val="accent1"/>
+          </a:effectRef>
+          <a:fontRef idx="minor">
+            <a:schemeClr val="lt1"/>
+          </a:fontRef>
+        </p:style>
+        <p:txBody>
+          <a:bodyPr rtlCol="0" anchor="ctr"/>
+          <a:lstStyle/>
+          <a:p>
+            <a:pPr algn="ctr"/>
+          </a:p>
+        </p:txBody>
+      </p:sp>
+      <p:sp>
+        <p:nvSpPr>
+          <p:cNvPr id="37" name="Rectangle 36"/>
+          <p:cNvSpPr/>
+          <p:nvPr/>
+        </p:nvSpPr>
+        <p:spPr>
+          <a:xfrm>
+            <a:off x="6400800" y="3273552"/>
+            <a:ext cx="54864" cy="530352"/>
+          </a:xfrm>
+          <a:prstGeom prst="rect">
+            <a:avLst/>
+          </a:prstGeom>
+          <a:solidFill>
+            <a:srgbClr val="7B1FA2"/>
+          </a:solidFill>
+          <a:ln>
+            <a:noFill/>
+          </a:ln>
+        </p:spPr>
+        <p:style>
+          <a:lnRef idx="1">
+            <a:schemeClr val="accent1"/>
+          </a:lnRef>
+          <a:fillRef idx="3">
+            <a:schemeClr val="accent1"/>
+          </a:fillRef>
+          <a:effectRef idx="2">
+            <a:schemeClr val="accent1"/>
+          </a:effectRef>
+          <a:fontRef idx="minor">
+            <a:schemeClr val="lt1"/>
+          </a:fontRef>
+        </p:style>
+        <p:txBody>
+          <a:bodyPr rtlCol="0" anchor="ctr"/>
+          <a:lstStyle/>
+          <a:p>
+            <a:pPr algn="ctr"/>
+          </a:p>
+        </p:txBody>
+      </p:sp>
+      <p:sp>
+        <p:nvSpPr>
+          <p:cNvPr id="38" name="TextBox 37"/>
+          <p:cNvSpPr txBox="1"/>
+          <p:nvPr/>
+        </p:nvSpPr>
+        <p:spPr>
+          <a:xfrm>
+            <a:off x="6537960" y="3310128"/>
+            <a:ext cx="1828800" cy="228600"/>
+          </a:xfrm>
+          <a:prstGeom prst="rect">
+            <a:avLst/>
+          </a:prstGeom>
+          <a:noFill/>
+        </p:spPr>
+        <p:txBody>
+          <a:bodyPr wrap="square">
+            <a:spAutoFit/>
+          </a:bodyPr>
+          <a:lstStyle/>
+          <a:p>
+            <a:pPr algn="l"/>
+            <a:r>
+              <a:rPr sz="950" b="1" i="0">
+                <a:solidFill>
+                  <a:srgbClr val="7B1FA2"/>
+                </a:solidFill>
+                <a:latin typeface="Calibri"/>
+              </a:rPr>
+              <a:t>langchain-core</a:t>
+            </a:r>
+          </a:p>
+        </p:txBody>
+      </p:sp>
+      <p:sp>
+        <p:nvSpPr>
+          <p:cNvPr id="39" name="TextBox 38"/>
+          <p:cNvSpPr txBox="1"/>
+          <p:nvPr/>
+        </p:nvSpPr>
+        <p:spPr>
+          <a:xfrm>
+            <a:off x="6537960" y="3529584"/>
+            <a:ext cx="4846320" cy="256032"/>
+          </a:xfrm>
+          <a:prstGeom prst="rect">
+            <a:avLst/>
+          </a:prstGeom>
+          <a:noFill/>
+        </p:spPr>
+        <p:txBody>
+          <a:bodyPr wrap="square">
+            <a:spAutoFit/>
+          </a:bodyPr>
+          <a:lstStyle/>
+          <a:p>
+            <a:pPr algn="l"/>
+            <a:r>
+              <a:rPr sz="900" b="0" i="1">
+                <a:solidFill>
+                  <a:srgbClr val="2C3E50"/>
+                </a:solidFill>
+                <a:latin typeface="Calibri"/>
+              </a:rPr>
+              <a:t>Base types and interfaces used by LangGraph</a:t>
+            </a:r>
+          </a:p>
+        </p:txBody>
+      </p:sp>
+      <p:sp>
+        <p:nvSpPr>
+          <p:cNvPr id="40" name="Rounded Rectangle 39"/>
+          <p:cNvSpPr/>
+          <p:nvPr/>
+        </p:nvSpPr>
+        <p:spPr>
+          <a:xfrm>
+            <a:off x="457200" y="4069080"/>
+            <a:ext cx="11247120" cy="1920240"/>
+          </a:xfrm>
+          <a:prstGeom prst="roundRect">
+            <a:avLst>
+              <a:gd name="adj" fmla="val 6000"/>
+            </a:avLst>
+          </a:prstGeom>
+          <a:solidFill>
+            <a:srgbClr val="FFE8DA"/>
+          </a:solidFill>
+          <a:ln w="19050">
+            <a:solidFill>
+              <a:srgbClr val="FF6B35"/>
+            </a:solidFill>
+          </a:ln>
+        </p:spPr>
+        <p:style>
+          <a:lnRef idx="1">
+            <a:schemeClr val="accent1"/>
+          </a:lnRef>
+          <a:fillRef idx="3">
+            <a:schemeClr val="accent1"/>
+          </a:fillRef>
+          <a:effectRef idx="2">
+            <a:schemeClr val="accent1"/>
+          </a:effectRef>
+          <a:fontRef idx="minor">
+            <a:schemeClr val="lt1"/>
+          </a:fontRef>
+        </p:style>
+        <p:txBody>
+          <a:bodyPr rtlCol="0" anchor="ctr"/>
+          <a:lstStyle/>
+          <a:p>
+            <a:pPr algn="ctr"/>
+          </a:p>
+        </p:txBody>
+      </p:sp>
+      <p:sp>
+        <p:nvSpPr>
+          <p:cNvPr id="41" name="TextBox 40"/>
+          <p:cNvSpPr txBox="1"/>
+          <p:nvPr/>
+        </p:nvSpPr>
+        <p:spPr>
+          <a:xfrm>
+            <a:off x="640080" y="4133087"/>
+            <a:ext cx="10972800" cy="347472"/>
+          </a:xfrm>
+          <a:prstGeom prst="rect">
+            <a:avLst/>
+          </a:prstGeom>
+          <a:noFill/>
+        </p:spPr>
+        <p:txBody>
+          <a:bodyPr wrap="square">
+            <a:spAutoFit/>
+          </a:bodyPr>
+          <a:lstStyle/>
+          <a:p>
+            <a:pPr algn="l"/>
+            <a:r>
+              <a:rPr sz="1300" b="1" i="0">
+                <a:solidFill>
+                  <a:srgbClr val="CC4F1F"/>
+                </a:solidFill>
+                <a:latin typeface="Calibri"/>
+              </a:rPr>
+              <a:t>LangGraph State Machine: Full Node Graph (PoC)</a:t>
+            </a:r>
+          </a:p>
+        </p:txBody>
+      </p:sp>
+      <p:sp>
+        <p:nvSpPr>
+          <p:cNvPr id="42" name="Rounded Rectangle 41"/>
+          <p:cNvSpPr/>
+          <p:nvPr/>
+        </p:nvSpPr>
+        <p:spPr>
+          <a:xfrm>
+            <a:off x="594360" y="4572000"/>
+            <a:ext cx="1143000" cy="411480"/>
+          </a:xfrm>
+          <a:prstGeom prst="roundRect">
+            <a:avLst>
+              <a:gd name="adj" fmla="val 15000"/>
+            </a:avLst>
+          </a:prstGeom>
+          <a:solidFill>
+            <a:srgbClr val="FF6B35"/>
+          </a:solidFill>
+          <a:ln>
+            <a:noFill/>
+          </a:ln>
+        </p:spPr>
+        <p:style>
+          <a:lnRef idx="1">
+            <a:schemeClr val="accent1"/>
+          </a:lnRef>
+          <a:fillRef idx="3">
+            <a:schemeClr val="accent1"/>
+          </a:fillRef>
+          <a:effectRef idx="2">
+            <a:schemeClr val="accent1"/>
+          </a:effectRef>
+          <a:fontRef idx="minor">
+            <a:schemeClr val="lt1"/>
+          </a:fontRef>
+        </p:style>
+        <p:txBody>
+          <a:bodyPr rtlCol="0" anchor="ctr"/>
+          <a:lstStyle/>
+          <a:p>
+            <a:pPr algn="ctr"/>
+          </a:p>
+        </p:txBody>
+      </p:sp>
+      <p:sp>
+        <p:nvSpPr>
+          <p:cNvPr id="43" name="TextBox 42"/>
+          <p:cNvSpPr txBox="1"/>
+          <p:nvPr/>
+        </p:nvSpPr>
+        <p:spPr>
+          <a:xfrm>
+            <a:off x="594360" y="4572000"/>
+            <a:ext cx="1143000" cy="411480"/>
+          </a:xfrm>
+          <a:prstGeom prst="rect">
+            <a:avLst/>
+          </a:prstGeom>
+          <a:noFill/>
+        </p:spPr>
+        <p:txBody>
+          <a:bodyPr wrap="none" anchor="ctr">
+            <a:spAutoFit/>
+          </a:bodyPr>
+          <a:lstStyle/>
+          <a:p>
+            <a:pPr algn="ctr"/>
+            <a:r>
+              <a:rPr sz="850" b="1">
+                <a:solidFill>
+                  <a:srgbClr val="FFFFFF"/>
+                </a:solidFill>
+                <a:latin typeface="Courier New"/>
+              </a:rPr>
+              <a:t>phi_mask</a:t>
+            </a:r>
+          </a:p>
+        </p:txBody>
+      </p:sp>
+      <p:sp>
+        <p:nvSpPr>
+          <p:cNvPr id="44" name="Rounded Rectangle 43"/>
+          <p:cNvSpPr/>
+          <p:nvPr/>
+        </p:nvSpPr>
+        <p:spPr>
+          <a:xfrm>
+            <a:off x="1874519" y="4572000"/>
+            <a:ext cx="1143000" cy="411480"/>
+          </a:xfrm>
+          <a:prstGeom prst="roundRect">
+            <a:avLst>
+              <a:gd name="adj" fmla="val 15000"/>
+            </a:avLst>
+          </a:prstGeom>
+          <a:solidFill>
+            <a:srgbClr val="FF6B35"/>
+          </a:solidFill>
+          <a:ln>
+            <a:noFill/>
+          </a:ln>
+        </p:spPr>
+        <p:style>
+          <a:lnRef idx="1">
+            <a:schemeClr val="accent1"/>
+          </a:lnRef>
+          <a:fillRef idx="3">
+            <a:schemeClr val="accent1"/>
+          </a:fillRef>
+          <a:effectRef idx="2">
+            <a:schemeClr val="accent1"/>
+          </a:effectRef>
+          <a:fontRef idx="minor">
+            <a:schemeClr val="lt1"/>
+          </a:fontRef>
+        </p:style>
+        <p:txBody>
+          <a:bodyPr rtlCol="0" anchor="ctr"/>
+          <a:lstStyle/>
+          <a:p>
+            <a:pPr algn="ctr"/>
+          </a:p>
+        </p:txBody>
+      </p:sp>
+      <p:sp>
+        <p:nvSpPr>
+          <p:cNvPr id="45" name="TextBox 44"/>
+          <p:cNvSpPr txBox="1"/>
+          <p:nvPr/>
+        </p:nvSpPr>
+        <p:spPr>
+          <a:xfrm>
+            <a:off x="1874519" y="4572000"/>
+            <a:ext cx="1143000" cy="411480"/>
+          </a:xfrm>
+          <a:prstGeom prst="rect">
+            <a:avLst/>
+          </a:prstGeom>
+          <a:noFill/>
+        </p:spPr>
+        <p:txBody>
+          <a:bodyPr wrap="none" anchor="ctr">
+            <a:spAutoFit/>
+          </a:bodyPr>
+          <a:lstStyle/>
+          <a:p>
+            <a:pPr algn="ctr"/>
+            <a:r>
+              <a:rPr sz="850" b="1">
+                <a:solidFill>
+                  <a:srgbClr val="FFFFFF"/>
+                </a:solidFill>
+                <a:latin typeface="Courier New"/>
+              </a:rPr>
+              <a:t>pick_lane</a:t>
+            </a:r>
+          </a:p>
+        </p:txBody>
+      </p:sp>
+      <p:sp>
+        <p:nvSpPr>
+          <p:cNvPr id="46" name="Rounded Rectangle 45"/>
+          <p:cNvSpPr/>
+          <p:nvPr/>
+        </p:nvSpPr>
+        <p:spPr>
+          <a:xfrm>
+            <a:off x="3154680" y="4572000"/>
+            <a:ext cx="1143000" cy="411480"/>
+          </a:xfrm>
+          <a:prstGeom prst="roundRect">
+            <a:avLst>
+              <a:gd name="adj" fmla="val 15000"/>
+            </a:avLst>
+          </a:prstGeom>
+          <a:solidFill>
+            <a:srgbClr val="FF6B35"/>
+          </a:solidFill>
+          <a:ln>
+            <a:noFill/>
+          </a:ln>
+        </p:spPr>
+        <p:style>
+          <a:lnRef idx="1">
+            <a:schemeClr val="accent1"/>
+          </a:lnRef>
+          <a:fillRef idx="3">
+            <a:schemeClr val="accent1"/>
+          </a:fillRef>
+          <a:effectRef idx="2">
+            <a:schemeClr val="accent1"/>
+          </a:effectRef>
+          <a:fontRef idx="minor">
+            <a:schemeClr val="lt1"/>
+          </a:fontRef>
+        </p:style>
+        <p:txBody>
+          <a:bodyPr rtlCol="0" anchor="ctr"/>
+          <a:lstStyle/>
+          <a:p>
+            <a:pPr algn="ctr"/>
+          </a:p>
+        </p:txBody>
+      </p:sp>
+      <p:sp>
+        <p:nvSpPr>
+          <p:cNvPr id="47" name="TextBox 46"/>
+          <p:cNvSpPr txBox="1"/>
+          <p:nvPr/>
+        </p:nvSpPr>
+        <p:spPr>
+          <a:xfrm>
+            <a:off x="3154680" y="4572000"/>
+            <a:ext cx="1143000" cy="411480"/>
+          </a:xfrm>
+          <a:prstGeom prst="rect">
+            <a:avLst/>
+          </a:prstGeom>
+          <a:noFill/>
+        </p:spPr>
+        <p:txBody>
+          <a:bodyPr wrap="none" anchor="ctr">
+            <a:spAutoFit/>
+          </a:bodyPr>
+          <a:lstStyle/>
+          <a:p>
+            <a:pPr algn="ctr"/>
+            <a:r>
+              <a:rPr sz="850" b="1">
+                <a:solidFill>
+                  <a:srgbClr val="FFFFFF"/>
+                </a:solidFill>
+                <a:latin typeface="Courier New"/>
+              </a:rPr>
+              <a:t>cache_lookup</a:t>
+            </a:r>
+          </a:p>
+        </p:txBody>
+      </p:sp>
+      <p:sp>
+        <p:nvSpPr>
+          <p:cNvPr id="48" name="Rounded Rectangle 47"/>
+          <p:cNvSpPr/>
+          <p:nvPr/>
+        </p:nvSpPr>
+        <p:spPr>
+          <a:xfrm>
+            <a:off x="1874519" y="5230368"/>
+            <a:ext cx="1143000" cy="411480"/>
+          </a:xfrm>
+          <a:prstGeom prst="roundRect">
+            <a:avLst>
+              <a:gd name="adj" fmla="val 15000"/>
+            </a:avLst>
+          </a:prstGeom>
+          <a:solidFill>
+            <a:srgbClr val="2196F3"/>
+          </a:solidFill>
+          <a:ln>
+            <a:noFill/>
+          </a:ln>
+        </p:spPr>
+        <p:style>
+          <a:lnRef idx="1">
+            <a:schemeClr val="accent1"/>
+          </a:lnRef>
+          <a:fillRef idx="3">
+            <a:schemeClr val="accent1"/>
+          </a:fillRef>
+          <a:effectRef idx="2">
+            <a:schemeClr val="accent1"/>
+          </a:effectRef>
+          <a:fontRef idx="minor">
+            <a:schemeClr val="lt1"/>
+          </a:fontRef>
+        </p:style>
+        <p:txBody>
+          <a:bodyPr rtlCol="0" anchor="ctr"/>
+          <a:lstStyle/>
+          <a:p>
+            <a:pPr algn="ctr"/>
+          </a:p>
+        </p:txBody>
+      </p:sp>
+      <p:sp>
+        <p:nvSpPr>
+          <p:cNvPr id="49" name="TextBox 48"/>
+          <p:cNvSpPr txBox="1"/>
+          <p:nvPr/>
+        </p:nvSpPr>
+        <p:spPr>
+          <a:xfrm>
+            <a:off x="1874519" y="5230368"/>
+            <a:ext cx="1143000" cy="411480"/>
+          </a:xfrm>
+          <a:prstGeom prst="rect">
+            <a:avLst/>
+          </a:prstGeom>
+          <a:noFill/>
+        </p:spPr>
+        <p:txBody>
+          <a:bodyPr wrap="none" anchor="ctr">
+            <a:spAutoFit/>
+          </a:bodyPr>
+          <a:lstStyle/>
+          <a:p>
+            <a:pPr algn="ctr"/>
+            <a:r>
+              <a:rPr sz="850" b="1">
+                <a:solidFill>
+                  <a:srgbClr val="FFFFFF"/>
+                </a:solidFill>
+                <a:latin typeface="Courier New"/>
+              </a:rPr>
+              <a:t>emergency_agent</a:t>
+            </a:r>
+          </a:p>
+        </p:txBody>
+      </p:sp>
+      <p:sp>
+        <p:nvSpPr>
+          <p:cNvPr id="50" name="Rounded Rectangle 49"/>
+          <p:cNvSpPr/>
+          <p:nvPr/>
+        </p:nvSpPr>
+        <p:spPr>
+          <a:xfrm>
+            <a:off x="4434840" y="5230368"/>
+            <a:ext cx="1143000" cy="411480"/>
+          </a:xfrm>
+          <a:prstGeom prst="roundRect">
+            <a:avLst>
+              <a:gd name="adj" fmla="val 15000"/>
+            </a:avLst>
+          </a:prstGeom>
+          <a:solidFill>
+            <a:srgbClr val="2196F3"/>
+          </a:solidFill>
+          <a:ln>
+            <a:noFill/>
+          </a:ln>
+        </p:spPr>
+        <p:style>
+          <a:lnRef idx="1">
+            <a:schemeClr val="accent1"/>
+          </a:lnRef>
+          <a:fillRef idx="3">
+            <a:schemeClr val="accent1"/>
+          </a:fillRef>
+          <a:effectRef idx="2">
+            <a:schemeClr val="accent1"/>
+          </a:effectRef>
+          <a:fontRef idx="minor">
+            <a:schemeClr val="lt1"/>
+          </a:fontRef>
+        </p:style>
+        <p:txBody>
+          <a:bodyPr rtlCol="0" anchor="ctr"/>
+          <a:lstStyle/>
+          <a:p>
+            <a:pPr algn="ctr"/>
+          </a:p>
+        </p:txBody>
+      </p:sp>
+      <p:sp>
+        <p:nvSpPr>
+          <p:cNvPr id="51" name="TextBox 50"/>
+          <p:cNvSpPr txBox="1"/>
+          <p:nvPr/>
+        </p:nvSpPr>
+        <p:spPr>
+          <a:xfrm>
+            <a:off x="4434840" y="5230368"/>
+            <a:ext cx="1143000" cy="411480"/>
+          </a:xfrm>
+          <a:prstGeom prst="rect">
+            <a:avLst/>
+          </a:prstGeom>
+          <a:noFill/>
+        </p:spPr>
+        <p:txBody>
+          <a:bodyPr wrap="none" anchor="ctr">
+            <a:spAutoFit/>
+          </a:bodyPr>
+          <a:lstStyle/>
+          <a:p>
+            <a:pPr algn="ctr"/>
+            <a:r>
+              <a:rPr sz="850" b="1">
+                <a:solidFill>
+                  <a:srgbClr val="FFFFFF"/>
+                </a:solidFill>
+                <a:latin typeface="Courier New"/>
+              </a:rPr>
+              <a:t>route_dept</a:t>
+            </a:r>
+          </a:p>
+        </p:txBody>
+      </p:sp>
+      <p:sp>
+        <p:nvSpPr>
+          <p:cNvPr id="52" name="Rounded Rectangle 51"/>
+          <p:cNvSpPr/>
+          <p:nvPr/>
+        </p:nvSpPr>
+        <p:spPr>
+          <a:xfrm>
+            <a:off x="5715000" y="4572000"/>
+            <a:ext cx="1143000" cy="411480"/>
+          </a:xfrm>
+          <a:prstGeom prst="roundRect">
+            <a:avLst>
+              <a:gd name="adj" fmla="val 15000"/>
+            </a:avLst>
+          </a:prstGeom>
+          <a:solidFill>
+            <a:srgbClr val="27AE60"/>
+          </a:solidFill>
+          <a:ln>
+            <a:noFill/>
+          </a:ln>
+        </p:spPr>
+        <p:style>
+          <a:lnRef idx="1">
+            <a:schemeClr val="accent1"/>
+          </a:lnRef>
+          <a:fillRef idx="3">
+            <a:schemeClr val="accent1"/>
+          </a:fillRef>
+          <a:effectRef idx="2">
+            <a:schemeClr val="accent1"/>
+          </a:effectRef>
+          <a:fontRef idx="minor">
+            <a:schemeClr val="lt1"/>
+          </a:fontRef>
+        </p:style>
+        <p:txBody>
+          <a:bodyPr rtlCol="0" anchor="ctr"/>
+          <a:lstStyle/>
+          <a:p>
+            <a:pPr algn="ctr"/>
+          </a:p>
+        </p:txBody>
+      </p:sp>
+      <p:sp>
+        <p:nvSpPr>
+          <p:cNvPr id="53" name="TextBox 52"/>
+          <p:cNvSpPr txBox="1"/>
+          <p:nvPr/>
+        </p:nvSpPr>
+        <p:spPr>
+          <a:xfrm>
+            <a:off x="5715000" y="4572000"/>
+            <a:ext cx="1143000" cy="411480"/>
+          </a:xfrm>
+          <a:prstGeom prst="rect">
+            <a:avLst/>
+          </a:prstGeom>
+          <a:noFill/>
+        </p:spPr>
+        <p:txBody>
+          <a:bodyPr wrap="none" anchor="ctr">
+            <a:spAutoFit/>
+          </a:bodyPr>
+          <a:lstStyle/>
+          <a:p>
+            <a:pPr algn="ctr"/>
+            <a:r>
+              <a:rPr sz="850" b="1">
+                <a:solidFill>
+                  <a:srgbClr val="FFFFFF"/>
+                </a:solidFill>
+                <a:latin typeface="Courier New"/>
+              </a:rPr>
+              <a:t>retrieve</a:t>
+            </a:r>
+          </a:p>
+        </p:txBody>
+      </p:sp>
+      <p:sp>
+        <p:nvSpPr>
+          <p:cNvPr id="54" name="Rounded Rectangle 53"/>
+          <p:cNvSpPr/>
+          <p:nvPr/>
+        </p:nvSpPr>
+        <p:spPr>
+          <a:xfrm>
+            <a:off x="7178040" y="4572000"/>
+            <a:ext cx="1143000" cy="411480"/>
+          </a:xfrm>
+          <a:prstGeom prst="roundRect">
+            <a:avLst>
+              <a:gd name="adj" fmla="val 15000"/>
+            </a:avLst>
+          </a:prstGeom>
+          <a:solidFill>
+            <a:srgbClr val="27AE60"/>
+          </a:solidFill>
+          <a:ln>
+            <a:noFill/>
+          </a:ln>
+        </p:spPr>
+        <p:style>
+          <a:lnRef idx="1">
+            <a:schemeClr val="accent1"/>
+          </a:lnRef>
+          <a:fillRef idx="3">
+            <a:schemeClr val="accent1"/>
+          </a:fillRef>
+          <a:effectRef idx="2">
+            <a:schemeClr val="accent1"/>
+          </a:effectRef>
+          <a:fontRef idx="minor">
+            <a:schemeClr val="lt1"/>
+          </a:fontRef>
+        </p:style>
+        <p:txBody>
+          <a:bodyPr rtlCol="0" anchor="ctr"/>
+          <a:lstStyle/>
+          <a:p>
+            <a:pPr algn="ctr"/>
+          </a:p>
+        </p:txBody>
+      </p:sp>
+      <p:sp>
+        <p:nvSpPr>
+          <p:cNvPr id="55" name="TextBox 54"/>
+          <p:cNvSpPr txBox="1"/>
+          <p:nvPr/>
+        </p:nvSpPr>
+        <p:spPr>
+          <a:xfrm>
+            <a:off x="7178040" y="4572000"/>
+            <a:ext cx="1143000" cy="411480"/>
+          </a:xfrm>
+          <a:prstGeom prst="rect">
+            <a:avLst/>
+          </a:prstGeom>
+          <a:noFill/>
+        </p:spPr>
+        <p:txBody>
+          <a:bodyPr wrap="none" anchor="ctr">
+            <a:spAutoFit/>
+          </a:bodyPr>
+          <a:lstStyle/>
+          <a:p>
+            <a:pPr algn="ctr"/>
+            <a:r>
+              <a:rPr sz="850" b="1">
+                <a:solidFill>
+                  <a:srgbClr val="FFFFFF"/>
+                </a:solidFill>
+                <a:latin typeface="Courier New"/>
+              </a:rPr>
+              <a:t>generate</a:t>
+            </a:r>
+          </a:p>
+        </p:txBody>
+      </p:sp>
+      <p:sp>
+        <p:nvSpPr>
+          <p:cNvPr id="56" name="Rounded Rectangle 55"/>
+          <p:cNvSpPr/>
+          <p:nvPr/>
+        </p:nvSpPr>
+        <p:spPr>
+          <a:xfrm>
+            <a:off x="8641080" y="4572000"/>
+            <a:ext cx="1143000" cy="411480"/>
+          </a:xfrm>
+          <a:prstGeom prst="roundRect">
+            <a:avLst>
+              <a:gd name="adj" fmla="val 15000"/>
+            </a:avLst>
+          </a:prstGeom>
+          <a:solidFill>
+            <a:srgbClr val="FF6B35"/>
+          </a:solidFill>
+          <a:ln>
+            <a:noFill/>
+          </a:ln>
+        </p:spPr>
+        <p:style>
+          <a:lnRef idx="1">
+            <a:schemeClr val="accent1"/>
+          </a:lnRef>
+          <a:fillRef idx="3">
+            <a:schemeClr val="accent1"/>
+          </a:fillRef>
+          <a:effectRef idx="2">
+            <a:schemeClr val="accent1"/>
+          </a:effectRef>
+          <a:fontRef idx="minor">
+            <a:schemeClr val="lt1"/>
+          </a:fontRef>
+        </p:style>
+        <p:txBody>
+          <a:bodyPr rtlCol="0" anchor="ctr"/>
+          <a:lstStyle/>
+          <a:p>
+            <a:pPr algn="ctr"/>
+          </a:p>
+        </p:txBody>
+      </p:sp>
+      <p:sp>
+        <p:nvSpPr>
+          <p:cNvPr id="57" name="TextBox 56"/>
+          <p:cNvSpPr txBox="1"/>
+          <p:nvPr/>
+        </p:nvSpPr>
+        <p:spPr>
+          <a:xfrm>
+            <a:off x="8641080" y="4572000"/>
+            <a:ext cx="1143000" cy="411480"/>
+          </a:xfrm>
+          <a:prstGeom prst="rect">
+            <a:avLst/>
+          </a:prstGeom>
+          <a:noFill/>
+        </p:spPr>
+        <p:txBody>
+          <a:bodyPr wrap="none" anchor="ctr">
+            <a:spAutoFit/>
+          </a:bodyPr>
+          <a:lstStyle/>
+          <a:p>
+            <a:pPr algn="ctr"/>
+            <a:r>
+              <a:rPr sz="850" b="1">
+                <a:solidFill>
+                  <a:srgbClr val="FFFFFF"/>
+                </a:solidFill>
+                <a:latin typeface="Courier New"/>
+              </a:rPr>
+              <a:t>cache_write</a:t>
+            </a:r>
+          </a:p>
+        </p:txBody>
+      </p:sp>
+      <p:sp>
+        <p:nvSpPr>
+          <p:cNvPr id="58" name="Rounded Rectangle 57"/>
+          <p:cNvSpPr/>
+          <p:nvPr/>
+        </p:nvSpPr>
+        <p:spPr>
+          <a:xfrm>
+            <a:off x="10104120" y="4572000"/>
+            <a:ext cx="1143000" cy="411480"/>
+          </a:xfrm>
+          <a:prstGeom prst="roundRect">
+            <a:avLst>
+              <a:gd name="adj" fmla="val 15000"/>
+            </a:avLst>
+          </a:prstGeom>
+          <a:solidFill>
+            <a:srgbClr val="646464"/>
+          </a:solidFill>
+          <a:ln>
+            <a:noFill/>
+          </a:ln>
+        </p:spPr>
+        <p:style>
+          <a:lnRef idx="1">
+            <a:schemeClr val="accent1"/>
+          </a:lnRef>
+          <a:fillRef idx="3">
+            <a:schemeClr val="accent1"/>
+          </a:fillRef>
+          <a:effectRef idx="2">
+            <a:schemeClr val="accent1"/>
+          </a:effectRef>
+          <a:fontRef idx="minor">
+            <a:schemeClr val="lt1"/>
+          </a:fontRef>
+        </p:style>
+        <p:txBody>
+          <a:bodyPr rtlCol="0" anchor="ctr"/>
+          <a:lstStyle/>
+          <a:p>
+            <a:pPr algn="ctr"/>
+          </a:p>
+        </p:txBody>
+      </p:sp>
+      <p:sp>
+        <p:nvSpPr>
+          <p:cNvPr id="59" name="TextBox 58"/>
+          <p:cNvSpPr txBox="1"/>
+          <p:nvPr/>
+        </p:nvSpPr>
+        <p:spPr>
+          <a:xfrm>
+            <a:off x="10104120" y="4572000"/>
+            <a:ext cx="1143000" cy="411480"/>
+          </a:xfrm>
+          <a:prstGeom prst="rect">
+            <a:avLst/>
+          </a:prstGeom>
+          <a:noFill/>
+        </p:spPr>
+        <p:txBody>
+          <a:bodyPr wrap="none" anchor="ctr">
+            <a:spAutoFit/>
+          </a:bodyPr>
+          <a:lstStyle/>
+          <a:p>
+            <a:pPr algn="ctr"/>
+            <a:r>
+              <a:rPr sz="850" b="1">
+                <a:solidFill>
+                  <a:srgbClr val="FFFFFF"/>
+                </a:solidFill>
+                <a:latin typeface="Courier New"/>
+              </a:rPr>
+              <a:t>END</a:t>
+            </a:r>
+          </a:p>
+        </p:txBody>
+      </p:sp>
+      <p:sp>
+        <p:nvSpPr>
+          <p:cNvPr id="60" name="TextBox 59"/>
+          <p:cNvSpPr txBox="1"/>
+          <p:nvPr/>
+        </p:nvSpPr>
+        <p:spPr>
+          <a:xfrm>
+            <a:off x="3154680" y="5029200"/>
+            <a:ext cx="1371600" cy="201168"/>
+          </a:xfrm>
+          <a:prstGeom prst="rect">
+            <a:avLst/>
+          </a:prstGeom>
+          <a:noFill/>
+        </p:spPr>
+        <p:txBody>
+          <a:bodyPr wrap="square">
+            <a:spAutoFit/>
+          </a:bodyPr>
+          <a:lstStyle/>
+          <a:p>
+            <a:pPr algn="l"/>
+            <a:r>
+              <a:rPr sz="800" b="0" i="1">
+                <a:solidFill>
+                  <a:srgbClr val="2196F3"/>
+                </a:solidFill>
+                <a:latin typeface="Calibri"/>
+              </a:rPr>
+              <a:t>emergency</a:t>
+            </a:r>
+          </a:p>
+        </p:txBody>
+      </p:sp>
+      <p:sp>
+        <p:nvSpPr>
+          <p:cNvPr id="61" name="TextBox 60"/>
+          <p:cNvSpPr txBox="1"/>
+          <p:nvPr/>
+        </p:nvSpPr>
+        <p:spPr>
+          <a:xfrm>
+            <a:off x="3154680" y="5166360"/>
+            <a:ext cx="1371600" cy="201168"/>
+          </a:xfrm>
+          <a:prstGeom prst="rect">
+            <a:avLst/>
+          </a:prstGeom>
+          <a:noFill/>
+        </p:spPr>
+        <p:txBody>
+          <a:bodyPr wrap="square">
+            <a:spAutoFit/>
+          </a:bodyPr>
+          <a:lstStyle/>
+          <a:p>
+            <a:pPr algn="l"/>
+            <a:r>
+              <a:rPr sz="800" b="0" i="1">
+                <a:solidFill>
+                  <a:srgbClr val="2196F3"/>
+                </a:solidFill>
+                <a:latin typeface="Calibri"/>
+              </a:rPr>
+              <a:t>complex</a:t>
+            </a:r>
+          </a:p>
+        </p:txBody>
+      </p:sp>
+      <p:sp>
+        <p:nvSpPr>
+          <p:cNvPr id="62" name="Rounded Rectangle 61"/>
+          <p:cNvSpPr/>
+          <p:nvPr/>
+        </p:nvSpPr>
+        <p:spPr>
+          <a:xfrm>
+            <a:off x="457200" y="6080760"/>
+            <a:ext cx="11247120" cy="347472"/>
+          </a:xfrm>
+          <a:prstGeom prst="roundRect">
+            <a:avLst>
+              <a:gd name="adj" fmla="val 20000"/>
+            </a:avLst>
+          </a:prstGeom>
+          <a:solidFill>
+            <a:srgbClr val="FF6B35"/>
+          </a:solidFill>
+          <a:ln>
+            <a:noFill/>
+          </a:ln>
+        </p:spPr>
+        <p:style>
+          <a:lnRef idx="1">
+            <a:schemeClr val="accent1"/>
+          </a:lnRef>
+          <a:fillRef idx="3">
+            <a:schemeClr val="accent1"/>
+          </a:fillRef>
+          <a:effectRef idx="2">
+            <a:schemeClr val="accent1"/>
+          </a:effectRef>
+          <a:fontRef idx="minor">
+            <a:schemeClr val="lt1"/>
+          </a:fontRef>
+        </p:style>
+        <p:txBody>
+          <a:bodyPr rtlCol="0" anchor="ctr"/>
+          <a:lstStyle/>
+          <a:p>
+            <a:pPr algn="ctr"/>
+          </a:p>
+        </p:txBody>
+      </p:sp>
+      <p:sp>
+        <p:nvSpPr>
+          <p:cNvPr id="63" name="TextBox 62"/>
+          <p:cNvSpPr txBox="1"/>
+          <p:nvPr/>
+        </p:nvSpPr>
+        <p:spPr>
+          <a:xfrm>
+            <a:off x="640080" y="6117336"/>
+            <a:ext cx="10881360" cy="292608"/>
+          </a:xfrm>
+          <a:prstGeom prst="rect">
+            <a:avLst/>
+          </a:prstGeom>
+          <a:noFill/>
+        </p:spPr>
+        <p:txBody>
+          <a:bodyPr wrap="square">
+            <a:spAutoFit/>
+          </a:bodyPr>
+          <a:lstStyle/>
+          <a:p>
+            <a:pPr algn="ctr"/>
+            <a:r>
+              <a:rPr sz="1100" b="1" i="0">
+                <a:solidFill>
+                  <a:srgbClr val="FFFFFF"/>
+                </a:solidFill>
+                <a:latin typeface="Calibri"/>
+              </a:rPr>
+              <a:t>LangGraph = orchestration (state machine).  LangChain = utilities (text splitting, cache).  Neither replaces Bedrock Agents for tool calling.</a:t>
             </a:r>
           </a:p>
         </p:txBody>

</xml_diff>

<commit_message>
docs: add compliance + security slide (slide 7)
</commit_message>
<xml_diff>
--- a/docs/Technology_Explanation_Slides.pptx
+++ b/docs/Technology_Explanation_Slides.pptx
@@ -11,6 +11,7 @@
     <p:sldId id="259" r:id="rId10"/>
     <p:sldId id="260" r:id="rId11"/>
     <p:sldId id="261" r:id="rId12"/>
+    <p:sldId id="262" r:id="rId13"/>
   </p:sldIdLst>
   <p:sldSz cx="12191695" cy="6858000" type="screen4x3"/>
   <p:notesSz cx="6858000" cy="9144000"/>
@@ -16024,6 +16025,4100 @@
                 <a:latin typeface="Calibri"/>
               </a:rPr>
               <a:t>LangGraph = orchestration (state machine).  LangChain = utilities (text splitting, cache).  Neither replaces Bedrock Agents for tool calling.</a:t>
+            </a:r>
+          </a:p>
+        </p:txBody>
+      </p:sp>
+    </p:spTree>
+  </p:cSld>
+  <p:clrMapOvr>
+    <a:masterClrMapping/>
+  </p:clrMapOvr>
+</p:sld>
+</file>
+
+<file path=ppt/slides/slide7.xml><?xml version="1.0" encoding="utf-8"?>
+<p:sld xmlns:a="http://schemas.openxmlformats.org/drawingml/2006/main" xmlns:p="http://schemas.openxmlformats.org/presentationml/2006/main" xmlns:r="http://schemas.openxmlformats.org/officeDocument/2006/relationships">
+  <p:cSld>
+    <p:spTree>
+      <p:nvGrpSpPr>
+        <p:cNvPr id="1" name=""/>
+        <p:cNvGrpSpPr/>
+        <p:nvPr/>
+      </p:nvGrpSpPr>
+      <p:grpSpPr/>
+      <p:sp>
+        <p:nvSpPr>
+          <p:cNvPr id="2" name="Rectangle 1"/>
+          <p:cNvSpPr/>
+          <p:nvPr/>
+        </p:nvSpPr>
+        <p:spPr>
+          <a:xfrm>
+            <a:off x="0" y="0"/>
+            <a:ext cx="12191695" cy="6858000"/>
+          </a:xfrm>
+          <a:prstGeom prst="rect">
+            <a:avLst/>
+          </a:prstGeom>
+          <a:solidFill>
+            <a:srgbClr val="FFFFFF"/>
+          </a:solidFill>
+          <a:ln>
+            <a:noFill/>
+          </a:ln>
+        </p:spPr>
+        <p:style>
+          <a:lnRef idx="1">
+            <a:schemeClr val="accent1"/>
+          </a:lnRef>
+          <a:fillRef idx="3">
+            <a:schemeClr val="accent1"/>
+          </a:fillRef>
+          <a:effectRef idx="2">
+            <a:schemeClr val="accent1"/>
+          </a:effectRef>
+          <a:fontRef idx="minor">
+            <a:schemeClr val="lt1"/>
+          </a:fontRef>
+        </p:style>
+        <p:txBody>
+          <a:bodyPr rtlCol="0" anchor="ctr"/>
+          <a:lstStyle/>
+          <a:p>
+            <a:pPr algn="ctr"/>
+          </a:p>
+        </p:txBody>
+      </p:sp>
+      <p:sp>
+        <p:nvSpPr>
+          <p:cNvPr id="3" name="Rectangle 2"/>
+          <p:cNvSpPr/>
+          <p:nvPr/>
+        </p:nvSpPr>
+        <p:spPr>
+          <a:xfrm>
+            <a:off x="0" y="0"/>
+            <a:ext cx="12191695" cy="109728"/>
+          </a:xfrm>
+          <a:prstGeom prst="rect">
+            <a:avLst/>
+          </a:prstGeom>
+          <a:solidFill>
+            <a:srgbClr val="FF6B35"/>
+          </a:solidFill>
+          <a:ln>
+            <a:noFill/>
+          </a:ln>
+        </p:spPr>
+        <p:style>
+          <a:lnRef idx="1">
+            <a:schemeClr val="accent1"/>
+          </a:lnRef>
+          <a:fillRef idx="3">
+            <a:schemeClr val="accent1"/>
+          </a:fillRef>
+          <a:effectRef idx="2">
+            <a:schemeClr val="accent1"/>
+          </a:effectRef>
+          <a:fontRef idx="minor">
+            <a:schemeClr val="lt1"/>
+          </a:fontRef>
+        </p:style>
+        <p:txBody>
+          <a:bodyPr rtlCol="0" anchor="ctr"/>
+          <a:lstStyle/>
+          <a:p>
+            <a:pPr algn="ctr"/>
+          </a:p>
+        </p:txBody>
+      </p:sp>
+      <p:sp>
+        <p:nvSpPr>
+          <p:cNvPr id="4" name="TextBox 3"/>
+          <p:cNvSpPr txBox="1"/>
+          <p:nvPr/>
+        </p:nvSpPr>
+        <p:spPr>
+          <a:xfrm>
+            <a:off x="457200" y="6492240"/>
+            <a:ext cx="11247120" cy="256032"/>
+          </a:xfrm>
+          <a:prstGeom prst="rect">
+            <a:avLst/>
+          </a:prstGeom>
+          <a:noFill/>
+        </p:spPr>
+        <p:txBody>
+          <a:bodyPr wrap="none">
+            <a:spAutoFit/>
+          </a:bodyPr>
+          <a:lstStyle/>
+          <a:p>
+            <a:pPr algn="r"/>
+            <a:r>
+              <a:rPr sz="900" i="1">
+                <a:solidFill>
+                  <a:srgbClr val="646464"/>
+                </a:solidFill>
+                <a:latin typeface="Calibri"/>
+              </a:rPr>
+              <a:t>Nova Health Tech  ·  Clinical GenAI Assistant  ·  AWS Singapore</a:t>
+            </a:r>
+          </a:p>
+        </p:txBody>
+      </p:sp>
+      <p:sp>
+        <p:nvSpPr>
+          <p:cNvPr id="5" name="TextBox 4"/>
+          <p:cNvSpPr txBox="1"/>
+          <p:nvPr/>
+        </p:nvSpPr>
+        <p:spPr>
+          <a:xfrm>
+            <a:off x="457200" y="201168"/>
+            <a:ext cx="11247120" cy="594360"/>
+          </a:xfrm>
+          <a:prstGeom prst="rect">
+            <a:avLst/>
+          </a:prstGeom>
+          <a:noFill/>
+        </p:spPr>
+        <p:txBody>
+          <a:bodyPr wrap="none" lIns="0" tIns="0">
+            <a:spAutoFit/>
+          </a:bodyPr>
+          <a:lstStyle/>
+          <a:p>
+            <a:pPr algn="l"/>
+            <a:r>
+              <a:rPr sz="2800" b="1">
+                <a:solidFill>
+                  <a:srgbClr val="CC4F1F"/>
+                </a:solidFill>
+                <a:latin typeface="Calibri"/>
+              </a:rPr>
+              <a:t>Compliance, Regulations &amp; Security</a:t>
+            </a:r>
+          </a:p>
+        </p:txBody>
+      </p:sp>
+      <p:sp>
+        <p:nvSpPr>
+          <p:cNvPr id="6" name="Rectangle 5"/>
+          <p:cNvSpPr/>
+          <p:nvPr/>
+        </p:nvSpPr>
+        <p:spPr>
+          <a:xfrm>
+            <a:off x="457200" y="841248"/>
+            <a:ext cx="5596128" cy="36576"/>
+          </a:xfrm>
+          <a:prstGeom prst="rect">
+            <a:avLst/>
+          </a:prstGeom>
+          <a:solidFill>
+            <a:srgbClr val="FF6B35"/>
+          </a:solidFill>
+          <a:ln>
+            <a:noFill/>
+          </a:ln>
+        </p:spPr>
+        <p:style>
+          <a:lnRef idx="1">
+            <a:schemeClr val="accent1"/>
+          </a:lnRef>
+          <a:fillRef idx="3">
+            <a:schemeClr val="accent1"/>
+          </a:fillRef>
+          <a:effectRef idx="2">
+            <a:schemeClr val="accent1"/>
+          </a:effectRef>
+          <a:fontRef idx="minor">
+            <a:schemeClr val="lt1"/>
+          </a:fontRef>
+        </p:style>
+        <p:txBody>
+          <a:bodyPr rtlCol="0" anchor="ctr"/>
+          <a:lstStyle/>
+          <a:p>
+            <a:pPr algn="ctr"/>
+          </a:p>
+        </p:txBody>
+      </p:sp>
+      <p:sp>
+        <p:nvSpPr>
+          <p:cNvPr id="7" name="Rectangle 6"/>
+          <p:cNvSpPr/>
+          <p:nvPr/>
+        </p:nvSpPr>
+        <p:spPr>
+          <a:xfrm>
+            <a:off x="457200" y="1005840"/>
+            <a:ext cx="7132320" cy="347472"/>
+          </a:xfrm>
+          <a:prstGeom prst="rect">
+            <a:avLst/>
+          </a:prstGeom>
+          <a:solidFill>
+            <a:srgbClr val="00897B"/>
+          </a:solidFill>
+          <a:ln>
+            <a:noFill/>
+          </a:ln>
+        </p:spPr>
+        <p:style>
+          <a:lnRef idx="1">
+            <a:schemeClr val="accent1"/>
+          </a:lnRef>
+          <a:fillRef idx="3">
+            <a:schemeClr val="accent1"/>
+          </a:fillRef>
+          <a:effectRef idx="2">
+            <a:schemeClr val="accent1"/>
+          </a:effectRef>
+          <a:fontRef idx="minor">
+            <a:schemeClr val="lt1"/>
+          </a:fontRef>
+        </p:style>
+        <p:txBody>
+          <a:bodyPr rtlCol="0" anchor="ctr"/>
+          <a:lstStyle/>
+          <a:p>
+            <a:pPr algn="ctr"/>
+          </a:p>
+        </p:txBody>
+      </p:sp>
+      <p:sp>
+        <p:nvSpPr>
+          <p:cNvPr id="8" name="TextBox 7"/>
+          <p:cNvSpPr txBox="1"/>
+          <p:nvPr/>
+        </p:nvSpPr>
+        <p:spPr>
+          <a:xfrm>
+            <a:off x="457200" y="1005840"/>
+            <a:ext cx="7132320" cy="347472"/>
+          </a:xfrm>
+          <a:prstGeom prst="rect">
+            <a:avLst/>
+          </a:prstGeom>
+          <a:noFill/>
+        </p:spPr>
+        <p:txBody>
+          <a:bodyPr wrap="square">
+            <a:spAutoFit/>
+          </a:bodyPr>
+          <a:lstStyle/>
+          <a:p>
+            <a:pPr algn="ctr"/>
+            <a:r>
+              <a:rPr sz="1200" b="1" i="0">
+                <a:solidFill>
+                  <a:srgbClr val="FFFFFF"/>
+                </a:solidFill>
+                <a:latin typeface="Calibri"/>
+              </a:rPr>
+              <a:t>Singapore Healthcare Regulations</a:t>
+            </a:r>
+          </a:p>
+        </p:txBody>
+      </p:sp>
+      <p:sp>
+        <p:nvSpPr>
+          <p:cNvPr id="9" name="Rounded Rectangle 8"/>
+          <p:cNvSpPr/>
+          <p:nvPr/>
+        </p:nvSpPr>
+        <p:spPr>
+          <a:xfrm>
+            <a:off x="457200" y="1417320"/>
+            <a:ext cx="1691640" cy="1417320"/>
+          </a:xfrm>
+          <a:prstGeom prst="roundRect">
+            <a:avLst>
+              <a:gd name="adj" fmla="val 6000"/>
+            </a:avLst>
+          </a:prstGeom>
+          <a:solidFill>
+            <a:srgbClr val="E0F2F1"/>
+          </a:solidFill>
+          <a:ln w="19050">
+            <a:solidFill>
+              <a:srgbClr val="00897B"/>
+            </a:solidFill>
+          </a:ln>
+        </p:spPr>
+        <p:style>
+          <a:lnRef idx="1">
+            <a:schemeClr val="accent1"/>
+          </a:lnRef>
+          <a:fillRef idx="3">
+            <a:schemeClr val="accent1"/>
+          </a:fillRef>
+          <a:effectRef idx="2">
+            <a:schemeClr val="accent1"/>
+          </a:effectRef>
+          <a:fontRef idx="minor">
+            <a:schemeClr val="lt1"/>
+          </a:fontRef>
+        </p:style>
+        <p:txBody>
+          <a:bodyPr rtlCol="0" anchor="ctr"/>
+          <a:lstStyle/>
+          <a:p>
+            <a:pPr algn="ctr"/>
+          </a:p>
+        </p:txBody>
+      </p:sp>
+      <p:sp>
+        <p:nvSpPr>
+          <p:cNvPr id="10" name="Rectangle 9"/>
+          <p:cNvSpPr/>
+          <p:nvPr/>
+        </p:nvSpPr>
+        <p:spPr>
+          <a:xfrm>
+            <a:off x="457200" y="1417320"/>
+            <a:ext cx="1691640" cy="347472"/>
+          </a:xfrm>
+          <a:prstGeom prst="rect">
+            <a:avLst/>
+          </a:prstGeom>
+          <a:solidFill>
+            <a:srgbClr val="00897B"/>
+          </a:solidFill>
+          <a:ln>
+            <a:noFill/>
+          </a:ln>
+        </p:spPr>
+        <p:style>
+          <a:lnRef idx="1">
+            <a:schemeClr val="accent1"/>
+          </a:lnRef>
+          <a:fillRef idx="3">
+            <a:schemeClr val="accent1"/>
+          </a:fillRef>
+          <a:effectRef idx="2">
+            <a:schemeClr val="accent1"/>
+          </a:effectRef>
+          <a:fontRef idx="minor">
+            <a:schemeClr val="lt1"/>
+          </a:fontRef>
+        </p:style>
+        <p:txBody>
+          <a:bodyPr rtlCol="0" anchor="ctr"/>
+          <a:lstStyle/>
+          <a:p>
+            <a:pPr algn="ctr"/>
+          </a:p>
+        </p:txBody>
+      </p:sp>
+      <p:sp>
+        <p:nvSpPr>
+          <p:cNvPr id="11" name="TextBox 10"/>
+          <p:cNvSpPr txBox="1"/>
+          <p:nvPr/>
+        </p:nvSpPr>
+        <p:spPr>
+          <a:xfrm>
+            <a:off x="457200" y="1417320"/>
+            <a:ext cx="1691640" cy="347472"/>
+          </a:xfrm>
+          <a:prstGeom prst="rect">
+            <a:avLst/>
+          </a:prstGeom>
+          <a:noFill/>
+        </p:spPr>
+        <p:txBody>
+          <a:bodyPr wrap="square">
+            <a:spAutoFit/>
+          </a:bodyPr>
+          <a:lstStyle/>
+          <a:p>
+            <a:pPr algn="ctr"/>
+            <a:r>
+              <a:rPr sz="1300" b="1" i="0">
+                <a:solidFill>
+                  <a:srgbClr val="FFFFFF"/>
+                </a:solidFill>
+                <a:latin typeface="Calibri"/>
+              </a:rPr>
+              <a:t>PDPA</a:t>
+            </a:r>
+          </a:p>
+        </p:txBody>
+      </p:sp>
+      <p:sp>
+        <p:nvSpPr>
+          <p:cNvPr id="12" name="TextBox 11"/>
+          <p:cNvSpPr txBox="1"/>
+          <p:nvPr/>
+        </p:nvSpPr>
+        <p:spPr>
+          <a:xfrm>
+            <a:off x="530352" y="1801368"/>
+            <a:ext cx="1545336" cy="292608"/>
+          </a:xfrm>
+          <a:prstGeom prst="rect">
+            <a:avLst/>
+          </a:prstGeom>
+          <a:noFill/>
+        </p:spPr>
+        <p:txBody>
+          <a:bodyPr wrap="square">
+            <a:spAutoFit/>
+          </a:bodyPr>
+          <a:lstStyle/>
+          <a:p>
+            <a:pPr algn="l"/>
+            <a:r>
+              <a:rPr sz="850" b="1" i="0">
+                <a:solidFill>
+                  <a:srgbClr val="00897B"/>
+                </a:solidFill>
+                <a:latin typeface="Calibri"/>
+              </a:rPr>
+              <a:t>Personal Data Protection Act</a:t>
+            </a:r>
+          </a:p>
+        </p:txBody>
+      </p:sp>
+      <p:sp>
+        <p:nvSpPr>
+          <p:cNvPr id="13" name="TextBox 12"/>
+          <p:cNvSpPr txBox="1"/>
+          <p:nvPr/>
+        </p:nvSpPr>
+        <p:spPr>
+          <a:xfrm>
+            <a:off x="530352" y="2112264"/>
+            <a:ext cx="1545336" cy="347472"/>
+          </a:xfrm>
+          <a:prstGeom prst="rect">
+            <a:avLst/>
+          </a:prstGeom>
+          <a:noFill/>
+        </p:spPr>
+        <p:txBody>
+          <a:bodyPr wrap="square">
+            <a:spAutoFit/>
+          </a:bodyPr>
+          <a:lstStyle/>
+          <a:p>
+            <a:pPr algn="l"/>
+            <a:r>
+              <a:rPr sz="800" b="0" i="1">
+                <a:solidFill>
+                  <a:srgbClr val="2C3E50"/>
+                </a:solidFill>
+                <a:latin typeface="Calibri"/>
+              </a:rPr>
+              <a:t>Patient data protection, 72h breach notification, DPO required</a:t>
+            </a:r>
+          </a:p>
+        </p:txBody>
+      </p:sp>
+      <p:sp>
+        <p:nvSpPr>
+          <p:cNvPr id="14" name="TextBox 13"/>
+          <p:cNvSpPr txBox="1"/>
+          <p:nvPr/>
+        </p:nvSpPr>
+        <p:spPr>
+          <a:xfrm>
+            <a:off x="530352" y="2496312"/>
+            <a:ext cx="1545336" cy="292608"/>
+          </a:xfrm>
+          <a:prstGeom prst="rect">
+            <a:avLst/>
+          </a:prstGeom>
+          <a:noFill/>
+        </p:spPr>
+        <p:txBody>
+          <a:bodyPr wrap="square">
+            <a:spAutoFit/>
+          </a:bodyPr>
+          <a:lstStyle/>
+          <a:p>
+            <a:pPr algn="l"/>
+            <a:r>
+              <a:rPr sz="800" b="1" i="0">
+                <a:solidFill>
+                  <a:srgbClr val="27AE60"/>
+                </a:solidFill>
+                <a:latin typeface="Calibri"/>
+              </a:rPr>
+              <a:t>PHI mask + KMS BYOK + audit trail</a:t>
+            </a:r>
+          </a:p>
+        </p:txBody>
+      </p:sp>
+      <p:sp>
+        <p:nvSpPr>
+          <p:cNvPr id="15" name="Rounded Rectangle 14"/>
+          <p:cNvSpPr/>
+          <p:nvPr/>
+        </p:nvSpPr>
+        <p:spPr>
+          <a:xfrm>
+            <a:off x="2221992" y="1417320"/>
+            <a:ext cx="1691640" cy="1417320"/>
+          </a:xfrm>
+          <a:prstGeom prst="roundRect">
+            <a:avLst>
+              <a:gd name="adj" fmla="val 6000"/>
+            </a:avLst>
+          </a:prstGeom>
+          <a:solidFill>
+            <a:srgbClr val="E0F2F1"/>
+          </a:solidFill>
+          <a:ln w="19050">
+            <a:solidFill>
+              <a:srgbClr val="00897B"/>
+            </a:solidFill>
+          </a:ln>
+        </p:spPr>
+        <p:style>
+          <a:lnRef idx="1">
+            <a:schemeClr val="accent1"/>
+          </a:lnRef>
+          <a:fillRef idx="3">
+            <a:schemeClr val="accent1"/>
+          </a:fillRef>
+          <a:effectRef idx="2">
+            <a:schemeClr val="accent1"/>
+          </a:effectRef>
+          <a:fontRef idx="minor">
+            <a:schemeClr val="lt1"/>
+          </a:fontRef>
+        </p:style>
+        <p:txBody>
+          <a:bodyPr rtlCol="0" anchor="ctr"/>
+          <a:lstStyle/>
+          <a:p>
+            <a:pPr algn="ctr"/>
+          </a:p>
+        </p:txBody>
+      </p:sp>
+      <p:sp>
+        <p:nvSpPr>
+          <p:cNvPr id="16" name="Rectangle 15"/>
+          <p:cNvSpPr/>
+          <p:nvPr/>
+        </p:nvSpPr>
+        <p:spPr>
+          <a:xfrm>
+            <a:off x="2221992" y="1417320"/>
+            <a:ext cx="1691640" cy="347472"/>
+          </a:xfrm>
+          <a:prstGeom prst="rect">
+            <a:avLst/>
+          </a:prstGeom>
+          <a:solidFill>
+            <a:srgbClr val="00897B"/>
+          </a:solidFill>
+          <a:ln>
+            <a:noFill/>
+          </a:ln>
+        </p:spPr>
+        <p:style>
+          <a:lnRef idx="1">
+            <a:schemeClr val="accent1"/>
+          </a:lnRef>
+          <a:fillRef idx="3">
+            <a:schemeClr val="accent1"/>
+          </a:fillRef>
+          <a:effectRef idx="2">
+            <a:schemeClr val="accent1"/>
+          </a:effectRef>
+          <a:fontRef idx="minor">
+            <a:schemeClr val="lt1"/>
+          </a:fontRef>
+        </p:style>
+        <p:txBody>
+          <a:bodyPr rtlCol="0" anchor="ctr"/>
+          <a:lstStyle/>
+          <a:p>
+            <a:pPr algn="ctr"/>
+          </a:p>
+        </p:txBody>
+      </p:sp>
+      <p:sp>
+        <p:nvSpPr>
+          <p:cNvPr id="17" name="TextBox 16"/>
+          <p:cNvSpPr txBox="1"/>
+          <p:nvPr/>
+        </p:nvSpPr>
+        <p:spPr>
+          <a:xfrm>
+            <a:off x="2221992" y="1417320"/>
+            <a:ext cx="1691640" cy="347472"/>
+          </a:xfrm>
+          <a:prstGeom prst="rect">
+            <a:avLst/>
+          </a:prstGeom>
+          <a:noFill/>
+        </p:spPr>
+        <p:txBody>
+          <a:bodyPr wrap="square">
+            <a:spAutoFit/>
+          </a:bodyPr>
+          <a:lstStyle/>
+          <a:p>
+            <a:pPr algn="ctr"/>
+            <a:r>
+              <a:rPr sz="1300" b="1" i="0">
+                <a:solidFill>
+                  <a:srgbClr val="FFFFFF"/>
+                </a:solidFill>
+                <a:latin typeface="Calibri"/>
+              </a:rPr>
+              <a:t>HCSA 2020</a:t>
+            </a:r>
+          </a:p>
+        </p:txBody>
+      </p:sp>
+      <p:sp>
+        <p:nvSpPr>
+          <p:cNvPr id="18" name="TextBox 17"/>
+          <p:cNvSpPr txBox="1"/>
+          <p:nvPr/>
+        </p:nvSpPr>
+        <p:spPr>
+          <a:xfrm>
+            <a:off x="2295144" y="1801368"/>
+            <a:ext cx="1545336" cy="292608"/>
+          </a:xfrm>
+          <a:prstGeom prst="rect">
+            <a:avLst/>
+          </a:prstGeom>
+          <a:noFill/>
+        </p:spPr>
+        <p:txBody>
+          <a:bodyPr wrap="square">
+            <a:spAutoFit/>
+          </a:bodyPr>
+          <a:lstStyle/>
+          <a:p>
+            <a:pPr algn="l"/>
+            <a:r>
+              <a:rPr sz="850" b="1" i="0">
+                <a:solidFill>
+                  <a:srgbClr val="00897B"/>
+                </a:solidFill>
+                <a:latin typeface="Calibri"/>
+              </a:rPr>
+              <a:t>Healthcare Services Act</a:t>
+            </a:r>
+          </a:p>
+        </p:txBody>
+      </p:sp>
+      <p:sp>
+        <p:nvSpPr>
+          <p:cNvPr id="19" name="TextBox 18"/>
+          <p:cNvSpPr txBox="1"/>
+          <p:nvPr/>
+        </p:nvSpPr>
+        <p:spPr>
+          <a:xfrm>
+            <a:off x="2295144" y="2112264"/>
+            <a:ext cx="1545336" cy="347472"/>
+          </a:xfrm>
+          <a:prstGeom prst="rect">
+            <a:avLst/>
+          </a:prstGeom>
+          <a:noFill/>
+        </p:spPr>
+        <p:txBody>
+          <a:bodyPr wrap="square">
+            <a:spAutoFit/>
+          </a:bodyPr>
+          <a:lstStyle/>
+          <a:p>
+            <a:pPr algn="l"/>
+            <a:r>
+              <a:rPr sz="800" b="0" i="1">
+                <a:solidFill>
+                  <a:srgbClr val="2C3E50"/>
+                </a:solidFill>
+                <a:latin typeface="Calibri"/>
+              </a:rPr>
+              <a:t>License for clinical decision support (replaces PHMC 1980)</a:t>
+            </a:r>
+          </a:p>
+        </p:txBody>
+      </p:sp>
+      <p:sp>
+        <p:nvSpPr>
+          <p:cNvPr id="20" name="TextBox 19"/>
+          <p:cNvSpPr txBox="1"/>
+          <p:nvPr/>
+        </p:nvSpPr>
+        <p:spPr>
+          <a:xfrm>
+            <a:off x="2295144" y="2496312"/>
+            <a:ext cx="1545336" cy="292608"/>
+          </a:xfrm>
+          <a:prstGeom prst="rect">
+            <a:avLst/>
+          </a:prstGeom>
+          <a:noFill/>
+        </p:spPr>
+        <p:txBody>
+          <a:bodyPr wrap="square">
+            <a:spAutoFit/>
+          </a:bodyPr>
+          <a:lstStyle/>
+          <a:p>
+            <a:pPr algn="l"/>
+            <a:r>
+              <a:rPr sz="800" b="1" i="0">
+                <a:solidFill>
+                  <a:srgbClr val="27AE60"/>
+                </a:solidFill>
+                <a:latin typeface="Calibri"/>
+              </a:rPr>
+              <a:t>Decision support only, human-in-the-loop, audit ready</a:t>
+            </a:r>
+          </a:p>
+        </p:txBody>
+      </p:sp>
+      <p:sp>
+        <p:nvSpPr>
+          <p:cNvPr id="21" name="Rounded Rectangle 20"/>
+          <p:cNvSpPr/>
+          <p:nvPr/>
+        </p:nvSpPr>
+        <p:spPr>
+          <a:xfrm>
+            <a:off x="3986784" y="1417320"/>
+            <a:ext cx="1691640" cy="1417320"/>
+          </a:xfrm>
+          <a:prstGeom prst="roundRect">
+            <a:avLst>
+              <a:gd name="adj" fmla="val 6000"/>
+            </a:avLst>
+          </a:prstGeom>
+          <a:solidFill>
+            <a:srgbClr val="E0F2F1"/>
+          </a:solidFill>
+          <a:ln w="19050">
+            <a:solidFill>
+              <a:srgbClr val="00897B"/>
+            </a:solidFill>
+          </a:ln>
+        </p:spPr>
+        <p:style>
+          <a:lnRef idx="1">
+            <a:schemeClr val="accent1"/>
+          </a:lnRef>
+          <a:fillRef idx="3">
+            <a:schemeClr val="accent1"/>
+          </a:fillRef>
+          <a:effectRef idx="2">
+            <a:schemeClr val="accent1"/>
+          </a:effectRef>
+          <a:fontRef idx="minor">
+            <a:schemeClr val="lt1"/>
+          </a:fontRef>
+        </p:style>
+        <p:txBody>
+          <a:bodyPr rtlCol="0" anchor="ctr"/>
+          <a:lstStyle/>
+          <a:p>
+            <a:pPr algn="ctr"/>
+          </a:p>
+        </p:txBody>
+      </p:sp>
+      <p:sp>
+        <p:nvSpPr>
+          <p:cNvPr id="22" name="Rectangle 21"/>
+          <p:cNvSpPr/>
+          <p:nvPr/>
+        </p:nvSpPr>
+        <p:spPr>
+          <a:xfrm>
+            <a:off x="3986784" y="1417320"/>
+            <a:ext cx="1691640" cy="347472"/>
+          </a:xfrm>
+          <a:prstGeom prst="rect">
+            <a:avLst/>
+          </a:prstGeom>
+          <a:solidFill>
+            <a:srgbClr val="00897B"/>
+          </a:solidFill>
+          <a:ln>
+            <a:noFill/>
+          </a:ln>
+        </p:spPr>
+        <p:style>
+          <a:lnRef idx="1">
+            <a:schemeClr val="accent1"/>
+          </a:lnRef>
+          <a:fillRef idx="3">
+            <a:schemeClr val="accent1"/>
+          </a:fillRef>
+          <a:effectRef idx="2">
+            <a:schemeClr val="accent1"/>
+          </a:effectRef>
+          <a:fontRef idx="minor">
+            <a:schemeClr val="lt1"/>
+          </a:fontRef>
+        </p:style>
+        <p:txBody>
+          <a:bodyPr rtlCol="0" anchor="ctr"/>
+          <a:lstStyle/>
+          <a:p>
+            <a:pPr algn="ctr"/>
+          </a:p>
+        </p:txBody>
+      </p:sp>
+      <p:sp>
+        <p:nvSpPr>
+          <p:cNvPr id="23" name="TextBox 22"/>
+          <p:cNvSpPr txBox="1"/>
+          <p:nvPr/>
+        </p:nvSpPr>
+        <p:spPr>
+          <a:xfrm>
+            <a:off x="3986784" y="1417320"/>
+            <a:ext cx="1691640" cy="347472"/>
+          </a:xfrm>
+          <a:prstGeom prst="rect">
+            <a:avLst/>
+          </a:prstGeom>
+          <a:noFill/>
+        </p:spPr>
+        <p:txBody>
+          <a:bodyPr wrap="square">
+            <a:spAutoFit/>
+          </a:bodyPr>
+          <a:lstStyle/>
+          <a:p>
+            <a:pPr algn="ctr"/>
+            <a:r>
+              <a:rPr sz="1300" b="1" i="0">
+                <a:solidFill>
+                  <a:srgbClr val="FFFFFF"/>
+                </a:solidFill>
+                <a:latin typeface="Calibri"/>
+              </a:rPr>
+              <a:t>HIA 2026</a:t>
+            </a:r>
+          </a:p>
+        </p:txBody>
+      </p:sp>
+      <p:sp>
+        <p:nvSpPr>
+          <p:cNvPr id="24" name="TextBox 23"/>
+          <p:cNvSpPr txBox="1"/>
+          <p:nvPr/>
+        </p:nvSpPr>
+        <p:spPr>
+          <a:xfrm>
+            <a:off x="4059936" y="1801368"/>
+            <a:ext cx="1545336" cy="292608"/>
+          </a:xfrm>
+          <a:prstGeom prst="rect">
+            <a:avLst/>
+          </a:prstGeom>
+          <a:noFill/>
+        </p:spPr>
+        <p:txBody>
+          <a:bodyPr wrap="square">
+            <a:spAutoFit/>
+          </a:bodyPr>
+          <a:lstStyle/>
+          <a:p>
+            <a:pPr algn="l"/>
+            <a:r>
+              <a:rPr sz="850" b="1" i="0">
+                <a:solidFill>
+                  <a:srgbClr val="00897B"/>
+                </a:solidFill>
+                <a:latin typeface="Calibri"/>
+              </a:rPr>
+              <a:t>Health Information Act</a:t>
+            </a:r>
+          </a:p>
+        </p:txBody>
+      </p:sp>
+      <p:sp>
+        <p:nvSpPr>
+          <p:cNvPr id="25" name="TextBox 24"/>
+          <p:cNvSpPr txBox="1"/>
+          <p:nvPr/>
+        </p:nvSpPr>
+        <p:spPr>
+          <a:xfrm>
+            <a:off x="4059936" y="2112264"/>
+            <a:ext cx="1545336" cy="347472"/>
+          </a:xfrm>
+          <a:prstGeom prst="rect">
+            <a:avLst/>
+          </a:prstGeom>
+          <a:noFill/>
+        </p:spPr>
+        <p:txBody>
+          <a:bodyPr wrap="square">
+            <a:spAutoFit/>
+          </a:bodyPr>
+          <a:lstStyle/>
+          <a:p>
+            <a:pPr algn="l"/>
+            <a:r>
+              <a:rPr sz="800" b="0" i="1">
+                <a:solidFill>
+                  <a:srgbClr val="2C3E50"/>
+                </a:solidFill>
+                <a:latin typeface="Calibri"/>
+              </a:rPr>
+              <a:t>Mandatory NEHR contribution (effective early 2027)</a:t>
+            </a:r>
+          </a:p>
+        </p:txBody>
+      </p:sp>
+      <p:sp>
+        <p:nvSpPr>
+          <p:cNvPr id="26" name="TextBox 25"/>
+          <p:cNvSpPr txBox="1"/>
+          <p:nvPr/>
+        </p:nvSpPr>
+        <p:spPr>
+          <a:xfrm>
+            <a:off x="4059936" y="2496312"/>
+            <a:ext cx="1545336" cy="292608"/>
+          </a:xfrm>
+          <a:prstGeom prst="rect">
+            <a:avLst/>
+          </a:prstGeom>
+          <a:noFill/>
+        </p:spPr>
+        <p:txBody>
+          <a:bodyPr wrap="square">
+            <a:spAutoFit/>
+          </a:bodyPr>
+          <a:lstStyle/>
+          <a:p>
+            <a:pPr algn="l"/>
+            <a:r>
+              <a:rPr sz="800" b="1" i="0">
+                <a:solidFill>
+                  <a:srgbClr val="27AE60"/>
+                </a:solidFill>
+                <a:latin typeface="Calibri"/>
+              </a:rPr>
+              <a:t>NEHR connector planned Year 2, consent + audit trail</a:t>
+            </a:r>
+          </a:p>
+        </p:txBody>
+      </p:sp>
+      <p:sp>
+        <p:nvSpPr>
+          <p:cNvPr id="27" name="Rounded Rectangle 26"/>
+          <p:cNvSpPr/>
+          <p:nvPr/>
+        </p:nvSpPr>
+        <p:spPr>
+          <a:xfrm>
+            <a:off x="5751576" y="1417320"/>
+            <a:ext cx="1691640" cy="1417320"/>
+          </a:xfrm>
+          <a:prstGeom prst="roundRect">
+            <a:avLst>
+              <a:gd name="adj" fmla="val 6000"/>
+            </a:avLst>
+          </a:prstGeom>
+          <a:solidFill>
+            <a:srgbClr val="E0F2F1"/>
+          </a:solidFill>
+          <a:ln w="19050">
+            <a:solidFill>
+              <a:srgbClr val="00897B"/>
+            </a:solidFill>
+          </a:ln>
+        </p:spPr>
+        <p:style>
+          <a:lnRef idx="1">
+            <a:schemeClr val="accent1"/>
+          </a:lnRef>
+          <a:fillRef idx="3">
+            <a:schemeClr val="accent1"/>
+          </a:fillRef>
+          <a:effectRef idx="2">
+            <a:schemeClr val="accent1"/>
+          </a:effectRef>
+          <a:fontRef idx="minor">
+            <a:schemeClr val="lt1"/>
+          </a:fontRef>
+        </p:style>
+        <p:txBody>
+          <a:bodyPr rtlCol="0" anchor="ctr"/>
+          <a:lstStyle/>
+          <a:p>
+            <a:pPr algn="ctr"/>
+          </a:p>
+        </p:txBody>
+      </p:sp>
+      <p:sp>
+        <p:nvSpPr>
+          <p:cNvPr id="28" name="Rectangle 27"/>
+          <p:cNvSpPr/>
+          <p:nvPr/>
+        </p:nvSpPr>
+        <p:spPr>
+          <a:xfrm>
+            <a:off x="5751576" y="1417320"/>
+            <a:ext cx="1691640" cy="347472"/>
+          </a:xfrm>
+          <a:prstGeom prst="rect">
+            <a:avLst/>
+          </a:prstGeom>
+          <a:solidFill>
+            <a:srgbClr val="00897B"/>
+          </a:solidFill>
+          <a:ln>
+            <a:noFill/>
+          </a:ln>
+        </p:spPr>
+        <p:style>
+          <a:lnRef idx="1">
+            <a:schemeClr val="accent1"/>
+          </a:lnRef>
+          <a:fillRef idx="3">
+            <a:schemeClr val="accent1"/>
+          </a:fillRef>
+          <a:effectRef idx="2">
+            <a:schemeClr val="accent1"/>
+          </a:effectRef>
+          <a:fontRef idx="minor">
+            <a:schemeClr val="lt1"/>
+          </a:fontRef>
+        </p:style>
+        <p:txBody>
+          <a:bodyPr rtlCol="0" anchor="ctr"/>
+          <a:lstStyle/>
+          <a:p>
+            <a:pPr algn="ctr"/>
+          </a:p>
+        </p:txBody>
+      </p:sp>
+      <p:sp>
+        <p:nvSpPr>
+          <p:cNvPr id="29" name="TextBox 28"/>
+          <p:cNvSpPr txBox="1"/>
+          <p:nvPr/>
+        </p:nvSpPr>
+        <p:spPr>
+          <a:xfrm>
+            <a:off x="5751576" y="1417320"/>
+            <a:ext cx="1691640" cy="347472"/>
+          </a:xfrm>
+          <a:prstGeom prst="rect">
+            <a:avLst/>
+          </a:prstGeom>
+          <a:noFill/>
+        </p:spPr>
+        <p:txBody>
+          <a:bodyPr wrap="square">
+            <a:spAutoFit/>
+          </a:bodyPr>
+          <a:lstStyle/>
+          <a:p>
+            <a:pPr algn="ctr"/>
+            <a:r>
+              <a:rPr sz="1300" b="1" i="0">
+                <a:solidFill>
+                  <a:srgbClr val="FFFFFF"/>
+                </a:solidFill>
+                <a:latin typeface="Calibri"/>
+              </a:rPr>
+              <a:t>AIHGle 2.0</a:t>
+            </a:r>
+          </a:p>
+        </p:txBody>
+      </p:sp>
+      <p:sp>
+        <p:nvSpPr>
+          <p:cNvPr id="30" name="TextBox 29"/>
+          <p:cNvSpPr txBox="1"/>
+          <p:nvPr/>
+        </p:nvSpPr>
+        <p:spPr>
+          <a:xfrm>
+            <a:off x="5824728" y="1801368"/>
+            <a:ext cx="1545336" cy="292608"/>
+          </a:xfrm>
+          <a:prstGeom prst="rect">
+            <a:avLst/>
+          </a:prstGeom>
+          <a:noFill/>
+        </p:spPr>
+        <p:txBody>
+          <a:bodyPr wrap="square">
+            <a:spAutoFit/>
+          </a:bodyPr>
+          <a:lstStyle/>
+          <a:p>
+            <a:pPr algn="l"/>
+            <a:r>
+              <a:rPr sz="850" b="1" i="0">
+                <a:solidFill>
+                  <a:srgbClr val="00897B"/>
+                </a:solidFill>
+                <a:latin typeface="Calibri"/>
+              </a:rPr>
+              <a:t>AI in Healthcare Guidelines
+(MOH+HSA, March 2026)</a:t>
+            </a:r>
+          </a:p>
+        </p:txBody>
+      </p:sp>
+      <p:sp>
+        <p:nvSpPr>
+          <p:cNvPr id="31" name="TextBox 30"/>
+          <p:cNvSpPr txBox="1"/>
+          <p:nvPr/>
+        </p:nvSpPr>
+        <p:spPr>
+          <a:xfrm>
+            <a:off x="5824728" y="2112264"/>
+            <a:ext cx="1545336" cy="347472"/>
+          </a:xfrm>
+          <a:prstGeom prst="rect">
+            <a:avLst/>
+          </a:prstGeom>
+          <a:noFill/>
+        </p:spPr>
+        <p:txBody>
+          <a:bodyPr wrap="square">
+            <a:spAutoFit/>
+          </a:bodyPr>
+          <a:lstStyle/>
+          <a:p>
+            <a:pPr algn="l"/>
+            <a:r>
+              <a:rPr sz="800" b="0" i="1">
+                <a:solidFill>
+                  <a:srgbClr val="2C3E50"/>
+                </a:solidFill>
+                <a:latin typeface="Calibri"/>
+              </a:rPr>
+              <a:t>7 principles: safety, fairness, transparency, explainability...</a:t>
+            </a:r>
+          </a:p>
+        </p:txBody>
+      </p:sp>
+      <p:sp>
+        <p:nvSpPr>
+          <p:cNvPr id="32" name="TextBox 31"/>
+          <p:cNvSpPr txBox="1"/>
+          <p:nvPr/>
+        </p:nvSpPr>
+        <p:spPr>
+          <a:xfrm>
+            <a:off x="5824728" y="2496312"/>
+            <a:ext cx="1545336" cy="292608"/>
+          </a:xfrm>
+          <a:prstGeom prst="rect">
+            <a:avLst/>
+          </a:prstGeom>
+          <a:noFill/>
+        </p:spPr>
+        <p:txBody>
+          <a:bodyPr wrap="square">
+            <a:spAutoFit/>
+          </a:bodyPr>
+          <a:lstStyle/>
+          <a:p>
+            <a:pPr algn="l"/>
+            <a:r>
+              <a:rPr sz="800" b="1" i="0">
+                <a:solidFill>
+                  <a:srgbClr val="27AE60"/>
+                </a:solidFill>
+                <a:latin typeface="Calibri"/>
+              </a:rPr>
+              <a:t>All 7 principles addressed in architecture</a:t>
+            </a:r>
+          </a:p>
+        </p:txBody>
+      </p:sp>
+      <p:sp>
+        <p:nvSpPr>
+          <p:cNvPr id="33" name="Rectangle 32"/>
+          <p:cNvSpPr/>
+          <p:nvPr/>
+        </p:nvSpPr>
+        <p:spPr>
+          <a:xfrm>
+            <a:off x="7818120" y="1005840"/>
+            <a:ext cx="3931920" cy="347472"/>
+          </a:xfrm>
+          <a:prstGeom prst="rect">
+            <a:avLst/>
+          </a:prstGeom>
+          <a:solidFill>
+            <a:srgbClr val="2196F3"/>
+          </a:solidFill>
+          <a:ln>
+            <a:noFill/>
+          </a:ln>
+        </p:spPr>
+        <p:style>
+          <a:lnRef idx="1">
+            <a:schemeClr val="accent1"/>
+          </a:lnRef>
+          <a:fillRef idx="3">
+            <a:schemeClr val="accent1"/>
+          </a:fillRef>
+          <a:effectRef idx="2">
+            <a:schemeClr val="accent1"/>
+          </a:effectRef>
+          <a:fontRef idx="minor">
+            <a:schemeClr val="lt1"/>
+          </a:fontRef>
+        </p:style>
+        <p:txBody>
+          <a:bodyPr rtlCol="0" anchor="ctr"/>
+          <a:lstStyle/>
+          <a:p>
+            <a:pPr algn="ctr"/>
+          </a:p>
+        </p:txBody>
+      </p:sp>
+      <p:sp>
+        <p:nvSpPr>
+          <p:cNvPr id="34" name="TextBox 33"/>
+          <p:cNvSpPr txBox="1"/>
+          <p:nvPr/>
+        </p:nvSpPr>
+        <p:spPr>
+          <a:xfrm>
+            <a:off x="7818120" y="1005840"/>
+            <a:ext cx="3931920" cy="347472"/>
+          </a:xfrm>
+          <a:prstGeom prst="rect">
+            <a:avLst/>
+          </a:prstGeom>
+          <a:noFill/>
+        </p:spPr>
+        <p:txBody>
+          <a:bodyPr wrap="square">
+            <a:spAutoFit/>
+          </a:bodyPr>
+          <a:lstStyle/>
+          <a:p>
+            <a:pPr algn="ctr"/>
+            <a:r>
+              <a:rPr sz="1200" b="1" i="0">
+                <a:solidFill>
+                  <a:srgbClr val="FFFFFF"/>
+                </a:solidFill>
+                <a:latin typeface="Calibri"/>
+              </a:rPr>
+              <a:t>Clinical &amp; International Standards</a:t>
+            </a:r>
+          </a:p>
+        </p:txBody>
+      </p:sp>
+      <p:sp>
+        <p:nvSpPr>
+          <p:cNvPr id="35" name="Rounded Rectangle 34"/>
+          <p:cNvSpPr/>
+          <p:nvPr/>
+        </p:nvSpPr>
+        <p:spPr>
+          <a:xfrm>
+            <a:off x="7818120" y="1417320"/>
+            <a:ext cx="3931920" cy="320040"/>
+          </a:xfrm>
+          <a:prstGeom prst="roundRect">
+            <a:avLst>
+              <a:gd name="adj" fmla="val 8000"/>
+            </a:avLst>
+          </a:prstGeom>
+          <a:solidFill>
+            <a:srgbClr val="E3F2FD"/>
+          </a:solidFill>
+          <a:ln w="12700">
+            <a:solidFill>
+              <a:srgbClr val="2196F3"/>
+            </a:solidFill>
+          </a:ln>
+        </p:spPr>
+        <p:style>
+          <a:lnRef idx="1">
+            <a:schemeClr val="accent1"/>
+          </a:lnRef>
+          <a:fillRef idx="3">
+            <a:schemeClr val="accent1"/>
+          </a:fillRef>
+          <a:effectRef idx="2">
+            <a:schemeClr val="accent1"/>
+          </a:effectRef>
+          <a:fontRef idx="minor">
+            <a:schemeClr val="lt1"/>
+          </a:fontRef>
+        </p:style>
+        <p:txBody>
+          <a:bodyPr rtlCol="0" anchor="ctr"/>
+          <a:lstStyle/>
+          <a:p>
+            <a:pPr algn="ctr"/>
+          </a:p>
+        </p:txBody>
+      </p:sp>
+      <p:sp>
+        <p:nvSpPr>
+          <p:cNvPr id="36" name="Rectangle 35"/>
+          <p:cNvSpPr/>
+          <p:nvPr/>
+        </p:nvSpPr>
+        <p:spPr>
+          <a:xfrm>
+            <a:off x="7818120" y="1417320"/>
+            <a:ext cx="45720" cy="320040"/>
+          </a:xfrm>
+          <a:prstGeom prst="rect">
+            <a:avLst/>
+          </a:prstGeom>
+          <a:solidFill>
+            <a:srgbClr val="2196F3"/>
+          </a:solidFill>
+          <a:ln>
+            <a:noFill/>
+          </a:ln>
+        </p:spPr>
+        <p:style>
+          <a:lnRef idx="1">
+            <a:schemeClr val="accent1"/>
+          </a:lnRef>
+          <a:fillRef idx="3">
+            <a:schemeClr val="accent1"/>
+          </a:fillRef>
+          <a:effectRef idx="2">
+            <a:schemeClr val="accent1"/>
+          </a:effectRef>
+          <a:fontRef idx="minor">
+            <a:schemeClr val="lt1"/>
+          </a:fontRef>
+        </p:style>
+        <p:txBody>
+          <a:bodyPr rtlCol="0" anchor="ctr"/>
+          <a:lstStyle/>
+          <a:p>
+            <a:pPr algn="ctr"/>
+          </a:p>
+        </p:txBody>
+      </p:sp>
+      <p:sp>
+        <p:nvSpPr>
+          <p:cNvPr id="37" name="TextBox 36"/>
+          <p:cNvSpPr txBox="1"/>
+          <p:nvPr/>
+        </p:nvSpPr>
+        <p:spPr>
+          <a:xfrm>
+            <a:off x="7909560" y="1435608"/>
+            <a:ext cx="1188720" cy="164592"/>
+          </a:xfrm>
+          <a:prstGeom prst="rect">
+            <a:avLst/>
+          </a:prstGeom>
+          <a:noFill/>
+        </p:spPr>
+        <p:txBody>
+          <a:bodyPr wrap="square">
+            <a:spAutoFit/>
+          </a:bodyPr>
+          <a:lstStyle/>
+          <a:p>
+            <a:pPr algn="l"/>
+            <a:r>
+              <a:rPr sz="900" b="1" i="0">
+                <a:solidFill>
+                  <a:srgbClr val="2196F3"/>
+                </a:solidFill>
+                <a:latin typeface="Calibri"/>
+              </a:rPr>
+              <a:t>HSA SaMD Class B</a:t>
+            </a:r>
+          </a:p>
+        </p:txBody>
+      </p:sp>
+      <p:sp>
+        <p:nvSpPr>
+          <p:cNvPr id="38" name="TextBox 37"/>
+          <p:cNvSpPr txBox="1"/>
+          <p:nvPr/>
+        </p:nvSpPr>
+        <p:spPr>
+          <a:xfrm>
+            <a:off x="9144000" y="1435608"/>
+            <a:ext cx="2514600" cy="292608"/>
+          </a:xfrm>
+          <a:prstGeom prst="rect">
+            <a:avLst/>
+          </a:prstGeom>
+          <a:noFill/>
+        </p:spPr>
+        <p:txBody>
+          <a:bodyPr wrap="square">
+            <a:spAutoFit/>
+          </a:bodyPr>
+          <a:lstStyle/>
+          <a:p>
+            <a:pPr algn="l"/>
+            <a:r>
+              <a:rPr sz="800" b="0" i="1">
+                <a:solidFill>
+                  <a:srgbClr val="2C3E50"/>
+                </a:solidFill>
+                <a:latin typeface="Calibri"/>
+              </a:rPr>
+              <a:t>Software as Medical Device registration
+via SHARE platform (July 2025)</a:t>
+            </a:r>
+          </a:p>
+        </p:txBody>
+      </p:sp>
+      <p:sp>
+        <p:nvSpPr>
+          <p:cNvPr id="39" name="Rounded Rectangle 38"/>
+          <p:cNvSpPr/>
+          <p:nvPr/>
+        </p:nvSpPr>
+        <p:spPr>
+          <a:xfrm>
+            <a:off x="7818120" y="1764792"/>
+            <a:ext cx="3931920" cy="320040"/>
+          </a:xfrm>
+          <a:prstGeom prst="roundRect">
+            <a:avLst>
+              <a:gd name="adj" fmla="val 8000"/>
+            </a:avLst>
+          </a:prstGeom>
+          <a:solidFill>
+            <a:srgbClr val="FFFFFF"/>
+          </a:solidFill>
+          <a:ln w="12700">
+            <a:solidFill>
+              <a:srgbClr val="2196F3"/>
+            </a:solidFill>
+          </a:ln>
+        </p:spPr>
+        <p:style>
+          <a:lnRef idx="1">
+            <a:schemeClr val="accent1"/>
+          </a:lnRef>
+          <a:fillRef idx="3">
+            <a:schemeClr val="accent1"/>
+          </a:fillRef>
+          <a:effectRef idx="2">
+            <a:schemeClr val="accent1"/>
+          </a:effectRef>
+          <a:fontRef idx="minor">
+            <a:schemeClr val="lt1"/>
+          </a:fontRef>
+        </p:style>
+        <p:txBody>
+          <a:bodyPr rtlCol="0" anchor="ctr"/>
+          <a:lstStyle/>
+          <a:p>
+            <a:pPr algn="ctr"/>
+          </a:p>
+        </p:txBody>
+      </p:sp>
+      <p:sp>
+        <p:nvSpPr>
+          <p:cNvPr id="40" name="Rectangle 39"/>
+          <p:cNvSpPr/>
+          <p:nvPr/>
+        </p:nvSpPr>
+        <p:spPr>
+          <a:xfrm>
+            <a:off x="7818120" y="1764792"/>
+            <a:ext cx="45720" cy="320040"/>
+          </a:xfrm>
+          <a:prstGeom prst="rect">
+            <a:avLst/>
+          </a:prstGeom>
+          <a:solidFill>
+            <a:srgbClr val="2196F3"/>
+          </a:solidFill>
+          <a:ln>
+            <a:noFill/>
+          </a:ln>
+        </p:spPr>
+        <p:style>
+          <a:lnRef idx="1">
+            <a:schemeClr val="accent1"/>
+          </a:lnRef>
+          <a:fillRef idx="3">
+            <a:schemeClr val="accent1"/>
+          </a:fillRef>
+          <a:effectRef idx="2">
+            <a:schemeClr val="accent1"/>
+          </a:effectRef>
+          <a:fontRef idx="minor">
+            <a:schemeClr val="lt1"/>
+          </a:fontRef>
+        </p:style>
+        <p:txBody>
+          <a:bodyPr rtlCol="0" anchor="ctr"/>
+          <a:lstStyle/>
+          <a:p>
+            <a:pPr algn="ctr"/>
+          </a:p>
+        </p:txBody>
+      </p:sp>
+      <p:sp>
+        <p:nvSpPr>
+          <p:cNvPr id="41" name="TextBox 40"/>
+          <p:cNvSpPr txBox="1"/>
+          <p:nvPr/>
+        </p:nvSpPr>
+        <p:spPr>
+          <a:xfrm>
+            <a:off x="7909560" y="1783080"/>
+            <a:ext cx="1188720" cy="164592"/>
+          </a:xfrm>
+          <a:prstGeom prst="rect">
+            <a:avLst/>
+          </a:prstGeom>
+          <a:noFill/>
+        </p:spPr>
+        <p:txBody>
+          <a:bodyPr wrap="square">
+            <a:spAutoFit/>
+          </a:bodyPr>
+          <a:lstStyle/>
+          <a:p>
+            <a:pPr algn="l"/>
+            <a:r>
+              <a:rPr sz="900" b="1" i="0">
+                <a:solidFill>
+                  <a:srgbClr val="2196F3"/>
+                </a:solidFill>
+                <a:latin typeface="Calibri"/>
+              </a:rPr>
+              <a:t>HIPAA 164.530(j)</a:t>
+            </a:r>
+          </a:p>
+        </p:txBody>
+      </p:sp>
+      <p:sp>
+        <p:nvSpPr>
+          <p:cNvPr id="42" name="TextBox 41"/>
+          <p:cNvSpPr txBox="1"/>
+          <p:nvPr/>
+        </p:nvSpPr>
+        <p:spPr>
+          <a:xfrm>
+            <a:off x="9144000" y="1783080"/>
+            <a:ext cx="2514600" cy="292608"/>
+          </a:xfrm>
+          <a:prstGeom prst="rect">
+            <a:avLst/>
+          </a:prstGeom>
+          <a:noFill/>
+        </p:spPr>
+        <p:txBody>
+          <a:bodyPr wrap="square">
+            <a:spAutoFit/>
+          </a:bodyPr>
+          <a:lstStyle/>
+          <a:p>
+            <a:pPr algn="l"/>
+            <a:r>
+              <a:rPr sz="800" b="0" i="1">
+                <a:solidFill>
+                  <a:srgbClr val="2C3E50"/>
+                </a:solidFill>
+                <a:latin typeface="Calibri"/>
+              </a:rPr>
+              <a:t>6-year audit retention via S3 Object Lock
+Signed BAA over Bedrock + S3 + Lambda</a:t>
+            </a:r>
+          </a:p>
+        </p:txBody>
+      </p:sp>
+      <p:sp>
+        <p:nvSpPr>
+          <p:cNvPr id="43" name="Rounded Rectangle 42"/>
+          <p:cNvSpPr/>
+          <p:nvPr/>
+        </p:nvSpPr>
+        <p:spPr>
+          <a:xfrm>
+            <a:off x="7818120" y="2112264"/>
+            <a:ext cx="3931920" cy="320040"/>
+          </a:xfrm>
+          <a:prstGeom prst="roundRect">
+            <a:avLst>
+              <a:gd name="adj" fmla="val 8000"/>
+            </a:avLst>
+          </a:prstGeom>
+          <a:solidFill>
+            <a:srgbClr val="E3F2FD"/>
+          </a:solidFill>
+          <a:ln w="12700">
+            <a:solidFill>
+              <a:srgbClr val="2196F3"/>
+            </a:solidFill>
+          </a:ln>
+        </p:spPr>
+        <p:style>
+          <a:lnRef idx="1">
+            <a:schemeClr val="accent1"/>
+          </a:lnRef>
+          <a:fillRef idx="3">
+            <a:schemeClr val="accent1"/>
+          </a:fillRef>
+          <a:effectRef idx="2">
+            <a:schemeClr val="accent1"/>
+          </a:effectRef>
+          <a:fontRef idx="minor">
+            <a:schemeClr val="lt1"/>
+          </a:fontRef>
+        </p:style>
+        <p:txBody>
+          <a:bodyPr rtlCol="0" anchor="ctr"/>
+          <a:lstStyle/>
+          <a:p>
+            <a:pPr algn="ctr"/>
+          </a:p>
+        </p:txBody>
+      </p:sp>
+      <p:sp>
+        <p:nvSpPr>
+          <p:cNvPr id="44" name="Rectangle 43"/>
+          <p:cNvSpPr/>
+          <p:nvPr/>
+        </p:nvSpPr>
+        <p:spPr>
+          <a:xfrm>
+            <a:off x="7818120" y="2112264"/>
+            <a:ext cx="45720" cy="320040"/>
+          </a:xfrm>
+          <a:prstGeom prst="rect">
+            <a:avLst/>
+          </a:prstGeom>
+          <a:solidFill>
+            <a:srgbClr val="2196F3"/>
+          </a:solidFill>
+          <a:ln>
+            <a:noFill/>
+          </a:ln>
+        </p:spPr>
+        <p:style>
+          <a:lnRef idx="1">
+            <a:schemeClr val="accent1"/>
+          </a:lnRef>
+          <a:fillRef idx="3">
+            <a:schemeClr val="accent1"/>
+          </a:fillRef>
+          <a:effectRef idx="2">
+            <a:schemeClr val="accent1"/>
+          </a:effectRef>
+          <a:fontRef idx="minor">
+            <a:schemeClr val="lt1"/>
+          </a:fontRef>
+        </p:style>
+        <p:txBody>
+          <a:bodyPr rtlCol="0" anchor="ctr"/>
+          <a:lstStyle/>
+          <a:p>
+            <a:pPr algn="ctr"/>
+          </a:p>
+        </p:txBody>
+      </p:sp>
+      <p:sp>
+        <p:nvSpPr>
+          <p:cNvPr id="45" name="TextBox 44"/>
+          <p:cNvSpPr txBox="1"/>
+          <p:nvPr/>
+        </p:nvSpPr>
+        <p:spPr>
+          <a:xfrm>
+            <a:off x="7909560" y="2130552"/>
+            <a:ext cx="1188720" cy="164592"/>
+          </a:xfrm>
+          <a:prstGeom prst="rect">
+            <a:avLst/>
+          </a:prstGeom>
+          <a:noFill/>
+        </p:spPr>
+        <p:txBody>
+          <a:bodyPr wrap="square">
+            <a:spAutoFit/>
+          </a:bodyPr>
+          <a:lstStyle/>
+          <a:p>
+            <a:pPr algn="l"/>
+            <a:r>
+              <a:rPr sz="900" b="1" i="0">
+                <a:solidFill>
+                  <a:srgbClr val="2196F3"/>
+                </a:solidFill>
+                <a:latin typeface="Calibri"/>
+              </a:rPr>
+              <a:t>ISO 27001 / SOC 2</a:t>
+            </a:r>
+          </a:p>
+        </p:txBody>
+      </p:sp>
+      <p:sp>
+        <p:nvSpPr>
+          <p:cNvPr id="46" name="TextBox 45"/>
+          <p:cNvSpPr txBox="1"/>
+          <p:nvPr/>
+        </p:nvSpPr>
+        <p:spPr>
+          <a:xfrm>
+            <a:off x="9144000" y="2130552"/>
+            <a:ext cx="2514600" cy="292608"/>
+          </a:xfrm>
+          <a:prstGeom prst="rect">
+            <a:avLst/>
+          </a:prstGeom>
+          <a:noFill/>
+        </p:spPr>
+        <p:txBody>
+          <a:bodyPr wrap="square">
+            <a:spAutoFit/>
+          </a:bodyPr>
+          <a:lstStyle/>
+          <a:p>
+            <a:pPr algn="l"/>
+            <a:r>
+              <a:rPr sz="800" b="0" i="1">
+                <a:solidFill>
+                  <a:srgbClr val="2C3E50"/>
+                </a:solidFill>
+                <a:latin typeface="Calibri"/>
+              </a:rPr>
+              <a:t>Inherited from AWS Singapore
+No separate Nova certification needed</a:t>
+            </a:r>
+          </a:p>
+        </p:txBody>
+      </p:sp>
+      <p:sp>
+        <p:nvSpPr>
+          <p:cNvPr id="47" name="Rounded Rectangle 46"/>
+          <p:cNvSpPr/>
+          <p:nvPr/>
+        </p:nvSpPr>
+        <p:spPr>
+          <a:xfrm>
+            <a:off x="7818120" y="2459736"/>
+            <a:ext cx="3931920" cy="320040"/>
+          </a:xfrm>
+          <a:prstGeom prst="roundRect">
+            <a:avLst>
+              <a:gd name="adj" fmla="val 8000"/>
+            </a:avLst>
+          </a:prstGeom>
+          <a:solidFill>
+            <a:srgbClr val="FFFFFF"/>
+          </a:solidFill>
+          <a:ln w="12700">
+            <a:solidFill>
+              <a:srgbClr val="2196F3"/>
+            </a:solidFill>
+          </a:ln>
+        </p:spPr>
+        <p:style>
+          <a:lnRef idx="1">
+            <a:schemeClr val="accent1"/>
+          </a:lnRef>
+          <a:fillRef idx="3">
+            <a:schemeClr val="accent1"/>
+          </a:fillRef>
+          <a:effectRef idx="2">
+            <a:schemeClr val="accent1"/>
+          </a:effectRef>
+          <a:fontRef idx="minor">
+            <a:schemeClr val="lt1"/>
+          </a:fontRef>
+        </p:style>
+        <p:txBody>
+          <a:bodyPr rtlCol="0" anchor="ctr"/>
+          <a:lstStyle/>
+          <a:p>
+            <a:pPr algn="ctr"/>
+          </a:p>
+        </p:txBody>
+      </p:sp>
+      <p:sp>
+        <p:nvSpPr>
+          <p:cNvPr id="48" name="Rectangle 47"/>
+          <p:cNvSpPr/>
+          <p:nvPr/>
+        </p:nvSpPr>
+        <p:spPr>
+          <a:xfrm>
+            <a:off x="7818120" y="2459736"/>
+            <a:ext cx="45720" cy="320040"/>
+          </a:xfrm>
+          <a:prstGeom prst="rect">
+            <a:avLst/>
+          </a:prstGeom>
+          <a:solidFill>
+            <a:srgbClr val="2196F3"/>
+          </a:solidFill>
+          <a:ln>
+            <a:noFill/>
+          </a:ln>
+        </p:spPr>
+        <p:style>
+          <a:lnRef idx="1">
+            <a:schemeClr val="accent1"/>
+          </a:lnRef>
+          <a:fillRef idx="3">
+            <a:schemeClr val="accent1"/>
+          </a:fillRef>
+          <a:effectRef idx="2">
+            <a:schemeClr val="accent1"/>
+          </a:effectRef>
+          <a:fontRef idx="minor">
+            <a:schemeClr val="lt1"/>
+          </a:fontRef>
+        </p:style>
+        <p:txBody>
+          <a:bodyPr rtlCol="0" anchor="ctr"/>
+          <a:lstStyle/>
+          <a:p>
+            <a:pPr algn="ctr"/>
+          </a:p>
+        </p:txBody>
+      </p:sp>
+      <p:sp>
+        <p:nvSpPr>
+          <p:cNvPr id="49" name="TextBox 48"/>
+          <p:cNvSpPr txBox="1"/>
+          <p:nvPr/>
+        </p:nvSpPr>
+        <p:spPr>
+          <a:xfrm>
+            <a:off x="7909560" y="2478024"/>
+            <a:ext cx="1188720" cy="164592"/>
+          </a:xfrm>
+          <a:prstGeom prst="rect">
+            <a:avLst/>
+          </a:prstGeom>
+          <a:noFill/>
+        </p:spPr>
+        <p:txBody>
+          <a:bodyPr wrap="square">
+            <a:spAutoFit/>
+          </a:bodyPr>
+          <a:lstStyle/>
+          <a:p>
+            <a:pPr algn="l"/>
+            <a:r>
+              <a:rPr sz="900" b="1" i="0">
+                <a:solidFill>
+                  <a:srgbClr val="2196F3"/>
+                </a:solidFill>
+                <a:latin typeface="Calibri"/>
+              </a:rPr>
+              <a:t>IMDA AI Verify</a:t>
+            </a:r>
+          </a:p>
+        </p:txBody>
+      </p:sp>
+      <p:sp>
+        <p:nvSpPr>
+          <p:cNvPr id="50" name="TextBox 49"/>
+          <p:cNvSpPr txBox="1"/>
+          <p:nvPr/>
+        </p:nvSpPr>
+        <p:spPr>
+          <a:xfrm>
+            <a:off x="9144000" y="2478024"/>
+            <a:ext cx="2514600" cy="292608"/>
+          </a:xfrm>
+          <a:prstGeom prst="rect">
+            <a:avLst/>
+          </a:prstGeom>
+          <a:noFill/>
+        </p:spPr>
+        <p:txBody>
+          <a:bodyPr wrap="square">
+            <a:spAutoFit/>
+          </a:bodyPr>
+          <a:lstStyle/>
+          <a:p>
+            <a:pPr algn="l"/>
+            <a:r>
+              <a:rPr sz="800" b="0" i="1">
+                <a:solidFill>
+                  <a:srgbClr val="2C3E50"/>
+                </a:solidFill>
+                <a:latin typeface="Calibri"/>
+              </a:rPr>
+              <a:t>Responsible AI framework
+Self-assessment planned Month 5</a:t>
+            </a:r>
+          </a:p>
+        </p:txBody>
+      </p:sp>
+      <p:sp>
+        <p:nvSpPr>
+          <p:cNvPr id="51" name="Rectangle 50"/>
+          <p:cNvSpPr/>
+          <p:nvPr/>
+        </p:nvSpPr>
+        <p:spPr>
+          <a:xfrm>
+            <a:off x="457200" y="2999232"/>
+            <a:ext cx="11247120" cy="347472"/>
+          </a:xfrm>
+          <a:prstGeom prst="rect">
+            <a:avLst/>
+          </a:prstGeom>
+          <a:solidFill>
+            <a:srgbClr val="CC4F1F"/>
+          </a:solidFill>
+          <a:ln>
+            <a:noFill/>
+          </a:ln>
+        </p:spPr>
+        <p:style>
+          <a:lnRef idx="1">
+            <a:schemeClr val="accent1"/>
+          </a:lnRef>
+          <a:fillRef idx="3">
+            <a:schemeClr val="accent1"/>
+          </a:fillRef>
+          <a:effectRef idx="2">
+            <a:schemeClr val="accent1"/>
+          </a:effectRef>
+          <a:fontRef idx="minor">
+            <a:schemeClr val="lt1"/>
+          </a:fontRef>
+        </p:style>
+        <p:txBody>
+          <a:bodyPr rtlCol="0" anchor="ctr"/>
+          <a:lstStyle/>
+          <a:p>
+            <a:pPr algn="ctr"/>
+          </a:p>
+        </p:txBody>
+      </p:sp>
+      <p:sp>
+        <p:nvSpPr>
+          <p:cNvPr id="52" name="TextBox 51"/>
+          <p:cNvSpPr txBox="1"/>
+          <p:nvPr/>
+        </p:nvSpPr>
+        <p:spPr>
+          <a:xfrm>
+            <a:off x="457200" y="2999232"/>
+            <a:ext cx="11247120" cy="347472"/>
+          </a:xfrm>
+          <a:prstGeom prst="rect">
+            <a:avLst/>
+          </a:prstGeom>
+          <a:noFill/>
+        </p:spPr>
+        <p:txBody>
+          <a:bodyPr wrap="square">
+            <a:spAutoFit/>
+          </a:bodyPr>
+          <a:lstStyle/>
+          <a:p>
+            <a:pPr algn="ctr"/>
+            <a:r>
+              <a:rPr sz="1200" b="1" i="0">
+                <a:solidFill>
+                  <a:srgbClr val="FFFFFF"/>
+                </a:solidFill>
+                <a:latin typeface="Calibri"/>
+              </a:rPr>
+              <a:t>AWS Shared Responsibility Model</a:t>
+            </a:r>
+          </a:p>
+        </p:txBody>
+      </p:sp>
+      <p:sp>
+        <p:nvSpPr>
+          <p:cNvPr id="53" name="Rounded Rectangle 52"/>
+          <p:cNvSpPr/>
+          <p:nvPr/>
+        </p:nvSpPr>
+        <p:spPr>
+          <a:xfrm>
+            <a:off x="457200" y="3383280"/>
+            <a:ext cx="5303520" cy="1691640"/>
+          </a:xfrm>
+          <a:prstGeom prst="roundRect">
+            <a:avLst>
+              <a:gd name="adj" fmla="val 6000"/>
+            </a:avLst>
+          </a:prstGeom>
+          <a:solidFill>
+            <a:srgbClr val="FFE8DA"/>
+          </a:solidFill>
+          <a:ln w="19050">
+            <a:solidFill>
+              <a:srgbClr val="FF6B35"/>
+            </a:solidFill>
+          </a:ln>
+        </p:spPr>
+        <p:style>
+          <a:lnRef idx="1">
+            <a:schemeClr val="accent1"/>
+          </a:lnRef>
+          <a:fillRef idx="3">
+            <a:schemeClr val="accent1"/>
+          </a:fillRef>
+          <a:effectRef idx="2">
+            <a:schemeClr val="accent1"/>
+          </a:effectRef>
+          <a:fontRef idx="minor">
+            <a:schemeClr val="lt1"/>
+          </a:fontRef>
+        </p:style>
+        <p:txBody>
+          <a:bodyPr rtlCol="0" anchor="ctr"/>
+          <a:lstStyle/>
+          <a:p>
+            <a:pPr algn="ctr"/>
+          </a:p>
+        </p:txBody>
+      </p:sp>
+      <p:sp>
+        <p:nvSpPr>
+          <p:cNvPr id="54" name="Rectangle 53"/>
+          <p:cNvSpPr/>
+          <p:nvPr/>
+        </p:nvSpPr>
+        <p:spPr>
+          <a:xfrm>
+            <a:off x="457200" y="3383280"/>
+            <a:ext cx="5303520" cy="347472"/>
+          </a:xfrm>
+          <a:prstGeom prst="rect">
+            <a:avLst/>
+          </a:prstGeom>
+          <a:solidFill>
+            <a:srgbClr val="FF6B35"/>
+          </a:solidFill>
+          <a:ln>
+            <a:noFill/>
+          </a:ln>
+        </p:spPr>
+        <p:style>
+          <a:lnRef idx="1">
+            <a:schemeClr val="accent1"/>
+          </a:lnRef>
+          <a:fillRef idx="3">
+            <a:schemeClr val="accent1"/>
+          </a:fillRef>
+          <a:effectRef idx="2">
+            <a:schemeClr val="accent1"/>
+          </a:effectRef>
+          <a:fontRef idx="minor">
+            <a:schemeClr val="lt1"/>
+          </a:fontRef>
+        </p:style>
+        <p:txBody>
+          <a:bodyPr rtlCol="0" anchor="ctr"/>
+          <a:lstStyle/>
+          <a:p>
+            <a:pPr algn="ctr"/>
+          </a:p>
+        </p:txBody>
+      </p:sp>
+      <p:sp>
+        <p:nvSpPr>
+          <p:cNvPr id="55" name="TextBox 54"/>
+          <p:cNvSpPr txBox="1"/>
+          <p:nvPr/>
+        </p:nvSpPr>
+        <p:spPr>
+          <a:xfrm>
+            <a:off x="457200" y="3383280"/>
+            <a:ext cx="5303520" cy="347472"/>
+          </a:xfrm>
+          <a:prstGeom prst="rect">
+            <a:avLst/>
+          </a:prstGeom>
+          <a:noFill/>
+        </p:spPr>
+        <p:txBody>
+          <a:bodyPr wrap="square">
+            <a:spAutoFit/>
+          </a:bodyPr>
+          <a:lstStyle/>
+          <a:p>
+            <a:pPr algn="ctr"/>
+            <a:r>
+              <a:rPr sz="1100" b="1" i="0">
+                <a:solidFill>
+                  <a:srgbClr val="FFFFFF"/>
+                </a:solidFill>
+                <a:latin typeface="Calibri"/>
+              </a:rPr>
+              <a:t>AWS Responsibility  (Security OF the Cloud)</a:t>
+            </a:r>
+          </a:p>
+        </p:txBody>
+      </p:sp>
+      <p:sp>
+        <p:nvSpPr>
+          <p:cNvPr id="56" name="TextBox 55"/>
+          <p:cNvSpPr txBox="1"/>
+          <p:nvPr/>
+        </p:nvSpPr>
+        <p:spPr>
+          <a:xfrm>
+            <a:off x="594360" y="3803904"/>
+            <a:ext cx="5029200" cy="237744"/>
+          </a:xfrm>
+          <a:prstGeom prst="rect">
+            <a:avLst/>
+          </a:prstGeom>
+          <a:noFill/>
+        </p:spPr>
+        <p:txBody>
+          <a:bodyPr wrap="none">
+            <a:spAutoFit/>
+          </a:bodyPr>
+          <a:lstStyle/>
+          <a:p>
+            <a:r>
+              <a:rPr sz="1000" b="1">
+                <a:solidFill>
+                  <a:srgbClr val="FF6B35"/>
+                </a:solidFill>
+                <a:latin typeface="Calibri"/>
+              </a:rPr>
+              <a:t>▸ </a:t>
+            </a:r>
+            <a:r>
+              <a:rPr sz="950">
+                <a:solidFill>
+                  <a:srgbClr val="2C3E50"/>
+                </a:solidFill>
+                <a:latin typeface="Calibri"/>
+              </a:rPr>
+              <a:t>Physical data center security (Singapore ap-southeast-1)</a:t>
+            </a:r>
+          </a:p>
+        </p:txBody>
+      </p:sp>
+      <p:sp>
+        <p:nvSpPr>
+          <p:cNvPr id="57" name="TextBox 56"/>
+          <p:cNvSpPr txBox="1"/>
+          <p:nvPr/>
+        </p:nvSpPr>
+        <p:spPr>
+          <a:xfrm>
+            <a:off x="594360" y="4050792"/>
+            <a:ext cx="5029200" cy="237744"/>
+          </a:xfrm>
+          <a:prstGeom prst="rect">
+            <a:avLst/>
+          </a:prstGeom>
+          <a:noFill/>
+        </p:spPr>
+        <p:txBody>
+          <a:bodyPr wrap="none">
+            <a:spAutoFit/>
+          </a:bodyPr>
+          <a:lstStyle/>
+          <a:p>
+            <a:r>
+              <a:rPr sz="1000" b="1">
+                <a:solidFill>
+                  <a:srgbClr val="FF6B35"/>
+                </a:solidFill>
+                <a:latin typeface="Calibri"/>
+              </a:rPr>
+              <a:t>▸ </a:t>
+            </a:r>
+            <a:r>
+              <a:rPr sz="950">
+                <a:solidFill>
+                  <a:srgbClr val="2C3E50"/>
+                </a:solidFill>
+                <a:latin typeface="Calibri"/>
+              </a:rPr>
+              <a:t>Hardware, network, hypervisor infrastructure</a:t>
+            </a:r>
+          </a:p>
+        </p:txBody>
+      </p:sp>
+      <p:sp>
+        <p:nvSpPr>
+          <p:cNvPr id="58" name="TextBox 57"/>
+          <p:cNvSpPr txBox="1"/>
+          <p:nvPr/>
+        </p:nvSpPr>
+        <p:spPr>
+          <a:xfrm>
+            <a:off x="594360" y="4297680"/>
+            <a:ext cx="5029200" cy="237744"/>
+          </a:xfrm>
+          <a:prstGeom prst="rect">
+            <a:avLst/>
+          </a:prstGeom>
+          <a:noFill/>
+        </p:spPr>
+        <p:txBody>
+          <a:bodyPr wrap="none">
+            <a:spAutoFit/>
+          </a:bodyPr>
+          <a:lstStyle/>
+          <a:p>
+            <a:r>
+              <a:rPr sz="1000" b="1">
+                <a:solidFill>
+                  <a:srgbClr val="FF6B35"/>
+                </a:solidFill>
+                <a:latin typeface="Calibri"/>
+              </a:rPr>
+              <a:t>▸ </a:t>
+            </a:r>
+            <a:r>
+              <a:rPr sz="950">
+                <a:solidFill>
+                  <a:srgbClr val="2C3E50"/>
+                </a:solidFill>
+                <a:latin typeface="Calibri"/>
+              </a:rPr>
+              <a:t>Managed service availability (Bedrock, OpenSearch, Neptune)</a:t>
+            </a:r>
+          </a:p>
+        </p:txBody>
+      </p:sp>
+      <p:sp>
+        <p:nvSpPr>
+          <p:cNvPr id="59" name="TextBox 58"/>
+          <p:cNvSpPr txBox="1"/>
+          <p:nvPr/>
+        </p:nvSpPr>
+        <p:spPr>
+          <a:xfrm>
+            <a:off x="594360" y="4544568"/>
+            <a:ext cx="5029200" cy="237744"/>
+          </a:xfrm>
+          <a:prstGeom prst="rect">
+            <a:avLst/>
+          </a:prstGeom>
+          <a:noFill/>
+        </p:spPr>
+        <p:txBody>
+          <a:bodyPr wrap="none">
+            <a:spAutoFit/>
+          </a:bodyPr>
+          <a:lstStyle/>
+          <a:p>
+            <a:r>
+              <a:rPr sz="1000" b="1">
+                <a:solidFill>
+                  <a:srgbClr val="FF6B35"/>
+                </a:solidFill>
+                <a:latin typeface="Calibri"/>
+              </a:rPr>
+              <a:t>▸ </a:t>
+            </a:r>
+            <a:r>
+              <a:rPr sz="950">
+                <a:solidFill>
+                  <a:srgbClr val="2C3E50"/>
+                </a:solidFill>
+                <a:latin typeface="Calibri"/>
+              </a:rPr>
+              <a:t>ISO 27001, SOC 2, PCI-DSS certifications</a:t>
+            </a:r>
+          </a:p>
+        </p:txBody>
+      </p:sp>
+      <p:sp>
+        <p:nvSpPr>
+          <p:cNvPr id="60" name="TextBox 59"/>
+          <p:cNvSpPr txBox="1"/>
+          <p:nvPr/>
+        </p:nvSpPr>
+        <p:spPr>
+          <a:xfrm>
+            <a:off x="594360" y="4791456"/>
+            <a:ext cx="5029200" cy="237744"/>
+          </a:xfrm>
+          <a:prstGeom prst="rect">
+            <a:avLst/>
+          </a:prstGeom>
+          <a:noFill/>
+        </p:spPr>
+        <p:txBody>
+          <a:bodyPr wrap="none">
+            <a:spAutoFit/>
+          </a:bodyPr>
+          <a:lstStyle/>
+          <a:p>
+            <a:r>
+              <a:rPr sz="1000" b="1">
+                <a:solidFill>
+                  <a:srgbClr val="FF6B35"/>
+                </a:solidFill>
+                <a:latin typeface="Calibri"/>
+              </a:rPr>
+              <a:t>▸ </a:t>
+            </a:r>
+            <a:r>
+              <a:rPr sz="950">
+                <a:solidFill>
+                  <a:srgbClr val="2C3E50"/>
+                </a:solidFill>
+                <a:latin typeface="Calibri"/>
+              </a:rPr>
+              <a:t>Compliance with Singapore data residency requirements</a:t>
+            </a:r>
+          </a:p>
+        </p:txBody>
+      </p:sp>
+      <p:sp>
+        <p:nvSpPr>
+          <p:cNvPr id="61" name="Rounded Rectangle 60"/>
+          <p:cNvSpPr/>
+          <p:nvPr/>
+        </p:nvSpPr>
+        <p:spPr>
+          <a:xfrm>
+            <a:off x="5989320" y="3383280"/>
+            <a:ext cx="2743200" cy="1691640"/>
+          </a:xfrm>
+          <a:prstGeom prst="roundRect">
+            <a:avLst>
+              <a:gd name="adj" fmla="val 6000"/>
+            </a:avLst>
+          </a:prstGeom>
+          <a:solidFill>
+            <a:srgbClr val="F3E5F5"/>
+          </a:solidFill>
+          <a:ln w="19050">
+            <a:solidFill>
+              <a:srgbClr val="7B1FA2"/>
+            </a:solidFill>
+          </a:ln>
+        </p:spPr>
+        <p:style>
+          <a:lnRef idx="1">
+            <a:schemeClr val="accent1"/>
+          </a:lnRef>
+          <a:fillRef idx="3">
+            <a:schemeClr val="accent1"/>
+          </a:fillRef>
+          <a:effectRef idx="2">
+            <a:schemeClr val="accent1"/>
+          </a:effectRef>
+          <a:fontRef idx="minor">
+            <a:schemeClr val="lt1"/>
+          </a:fontRef>
+        </p:style>
+        <p:txBody>
+          <a:bodyPr rtlCol="0" anchor="ctr"/>
+          <a:lstStyle/>
+          <a:p>
+            <a:pPr algn="ctr"/>
+          </a:p>
+        </p:txBody>
+      </p:sp>
+      <p:sp>
+        <p:nvSpPr>
+          <p:cNvPr id="62" name="Rectangle 61"/>
+          <p:cNvSpPr/>
+          <p:nvPr/>
+        </p:nvSpPr>
+        <p:spPr>
+          <a:xfrm>
+            <a:off x="5989320" y="3383280"/>
+            <a:ext cx="2743200" cy="347472"/>
+          </a:xfrm>
+          <a:prstGeom prst="rect">
+            <a:avLst/>
+          </a:prstGeom>
+          <a:solidFill>
+            <a:srgbClr val="7B1FA2"/>
+          </a:solidFill>
+          <a:ln>
+            <a:noFill/>
+          </a:ln>
+        </p:spPr>
+        <p:style>
+          <a:lnRef idx="1">
+            <a:schemeClr val="accent1"/>
+          </a:lnRef>
+          <a:fillRef idx="3">
+            <a:schemeClr val="accent1"/>
+          </a:fillRef>
+          <a:effectRef idx="2">
+            <a:schemeClr val="accent1"/>
+          </a:effectRef>
+          <a:fontRef idx="minor">
+            <a:schemeClr val="lt1"/>
+          </a:fontRef>
+        </p:style>
+        <p:txBody>
+          <a:bodyPr rtlCol="0" anchor="ctr"/>
+          <a:lstStyle/>
+          <a:p>
+            <a:pPr algn="ctr"/>
+          </a:p>
+        </p:txBody>
+      </p:sp>
+      <p:sp>
+        <p:nvSpPr>
+          <p:cNvPr id="63" name="TextBox 62"/>
+          <p:cNvSpPr txBox="1"/>
+          <p:nvPr/>
+        </p:nvSpPr>
+        <p:spPr>
+          <a:xfrm>
+            <a:off x="5989320" y="3383280"/>
+            <a:ext cx="2743200" cy="347472"/>
+          </a:xfrm>
+          <a:prstGeom prst="rect">
+            <a:avLst/>
+          </a:prstGeom>
+          <a:noFill/>
+        </p:spPr>
+        <p:txBody>
+          <a:bodyPr wrap="square">
+            <a:spAutoFit/>
+          </a:bodyPr>
+          <a:lstStyle/>
+          <a:p>
+            <a:pPr algn="ctr"/>
+            <a:r>
+              <a:rPr sz="1100" b="1" i="0">
+                <a:solidFill>
+                  <a:srgbClr val="FFFFFF"/>
+                </a:solidFill>
+                <a:latin typeface="Calibri"/>
+              </a:rPr>
+              <a:t>Nova Responsibility</a:t>
+            </a:r>
+          </a:p>
+        </p:txBody>
+      </p:sp>
+      <p:sp>
+        <p:nvSpPr>
+          <p:cNvPr id="64" name="TextBox 63"/>
+          <p:cNvSpPr txBox="1"/>
+          <p:nvPr/>
+        </p:nvSpPr>
+        <p:spPr>
+          <a:xfrm>
+            <a:off x="6126480" y="3803904"/>
+            <a:ext cx="2468880" cy="237744"/>
+          </a:xfrm>
+          <a:prstGeom prst="rect">
+            <a:avLst/>
+          </a:prstGeom>
+          <a:noFill/>
+        </p:spPr>
+        <p:txBody>
+          <a:bodyPr wrap="none">
+            <a:spAutoFit/>
+          </a:bodyPr>
+          <a:lstStyle/>
+          <a:p>
+            <a:r>
+              <a:rPr sz="1000" b="1">
+                <a:solidFill>
+                  <a:srgbClr val="7B1FA2"/>
+                </a:solidFill>
+                <a:latin typeface="Calibri"/>
+              </a:rPr>
+              <a:t>▸ </a:t>
+            </a:r>
+            <a:r>
+              <a:rPr sz="950">
+                <a:solidFill>
+                  <a:srgbClr val="2C3E50"/>
+                </a:solidFill>
+                <a:latin typeface="Calibri"/>
+              </a:rPr>
+              <a:t>PHI masking (Comprehend Medical)</a:t>
+            </a:r>
+          </a:p>
+        </p:txBody>
+      </p:sp>
+      <p:sp>
+        <p:nvSpPr>
+          <p:cNvPr id="65" name="TextBox 64"/>
+          <p:cNvSpPr txBox="1"/>
+          <p:nvPr/>
+        </p:nvSpPr>
+        <p:spPr>
+          <a:xfrm>
+            <a:off x="6126480" y="4050792"/>
+            <a:ext cx="2468880" cy="237744"/>
+          </a:xfrm>
+          <a:prstGeom prst="rect">
+            <a:avLst/>
+          </a:prstGeom>
+          <a:noFill/>
+        </p:spPr>
+        <p:txBody>
+          <a:bodyPr wrap="none">
+            <a:spAutoFit/>
+          </a:bodyPr>
+          <a:lstStyle/>
+          <a:p>
+            <a:r>
+              <a:rPr sz="1000" b="1">
+                <a:solidFill>
+                  <a:srgbClr val="7B1FA2"/>
+                </a:solidFill>
+                <a:latin typeface="Calibri"/>
+              </a:rPr>
+              <a:t>▸ </a:t>
+            </a:r>
+            <a:r>
+              <a:rPr sz="950">
+                <a:solidFill>
+                  <a:srgbClr val="2C3E50"/>
+                </a:solidFill>
+                <a:latin typeface="Calibri"/>
+              </a:rPr>
+              <a:t>Application security + PDPA</a:t>
+            </a:r>
+          </a:p>
+        </p:txBody>
+      </p:sp>
+      <p:sp>
+        <p:nvSpPr>
+          <p:cNvPr id="66" name="TextBox 65"/>
+          <p:cNvSpPr txBox="1"/>
+          <p:nvPr/>
+        </p:nvSpPr>
+        <p:spPr>
+          <a:xfrm>
+            <a:off x="6126480" y="4297680"/>
+            <a:ext cx="2468880" cy="237744"/>
+          </a:xfrm>
+          <a:prstGeom prst="rect">
+            <a:avLst/>
+          </a:prstGeom>
+          <a:noFill/>
+        </p:spPr>
+        <p:txBody>
+          <a:bodyPr wrap="none">
+            <a:spAutoFit/>
+          </a:bodyPr>
+          <a:lstStyle/>
+          <a:p>
+            <a:r>
+              <a:rPr sz="1000" b="1">
+                <a:solidFill>
+                  <a:srgbClr val="7B1FA2"/>
+                </a:solidFill>
+                <a:latin typeface="Calibri"/>
+              </a:rPr>
+              <a:t>▸ </a:t>
+            </a:r>
+            <a:r>
+              <a:rPr sz="950">
+                <a:solidFill>
+                  <a:srgbClr val="2C3E50"/>
+                </a:solidFill>
+                <a:latin typeface="Calibri"/>
+              </a:rPr>
+              <a:t>HCSA license + audit trail</a:t>
+            </a:r>
+          </a:p>
+        </p:txBody>
+      </p:sp>
+      <p:sp>
+        <p:nvSpPr>
+          <p:cNvPr id="67" name="TextBox 66"/>
+          <p:cNvSpPr txBox="1"/>
+          <p:nvPr/>
+        </p:nvSpPr>
+        <p:spPr>
+          <a:xfrm>
+            <a:off x="6126480" y="4544568"/>
+            <a:ext cx="2468880" cy="237744"/>
+          </a:xfrm>
+          <a:prstGeom prst="rect">
+            <a:avLst/>
+          </a:prstGeom>
+          <a:noFill/>
+        </p:spPr>
+        <p:txBody>
+          <a:bodyPr wrap="none">
+            <a:spAutoFit/>
+          </a:bodyPr>
+          <a:lstStyle/>
+          <a:p>
+            <a:r>
+              <a:rPr sz="1000" b="1">
+                <a:solidFill>
+                  <a:srgbClr val="7B1FA2"/>
+                </a:solidFill>
+                <a:latin typeface="Calibri"/>
+              </a:rPr>
+              <a:t>▸ </a:t>
+            </a:r>
+            <a:r>
+              <a:rPr sz="950">
+                <a:solidFill>
+                  <a:srgbClr val="2C3E50"/>
+                </a:solidFill>
+                <a:latin typeface="Calibri"/>
+              </a:rPr>
+              <a:t>Guardrails + citation validator</a:t>
+            </a:r>
+          </a:p>
+        </p:txBody>
+      </p:sp>
+      <p:sp>
+        <p:nvSpPr>
+          <p:cNvPr id="68" name="TextBox 67"/>
+          <p:cNvSpPr txBox="1"/>
+          <p:nvPr/>
+        </p:nvSpPr>
+        <p:spPr>
+          <a:xfrm>
+            <a:off x="6126480" y="4791456"/>
+            <a:ext cx="2468880" cy="237744"/>
+          </a:xfrm>
+          <a:prstGeom prst="rect">
+            <a:avLst/>
+          </a:prstGeom>
+          <a:noFill/>
+        </p:spPr>
+        <p:txBody>
+          <a:bodyPr wrap="none">
+            <a:spAutoFit/>
+          </a:bodyPr>
+          <a:lstStyle/>
+          <a:p>
+            <a:r>
+              <a:rPr sz="1000" b="1">
+                <a:solidFill>
+                  <a:srgbClr val="7B1FA2"/>
+                </a:solidFill>
+                <a:latin typeface="Calibri"/>
+              </a:rPr>
+              <a:t>▸ </a:t>
+            </a:r>
+            <a:r>
+              <a:rPr sz="950">
+                <a:solidFill>
+                  <a:srgbClr val="2C3E50"/>
+                </a:solidFill>
+                <a:latin typeface="Calibri"/>
+              </a:rPr>
+              <a:t>Incident response + DPO</a:t>
+            </a:r>
+          </a:p>
+        </p:txBody>
+      </p:sp>
+      <p:sp>
+        <p:nvSpPr>
+          <p:cNvPr id="69" name="Rounded Rectangle 68"/>
+          <p:cNvSpPr/>
+          <p:nvPr/>
+        </p:nvSpPr>
+        <p:spPr>
+          <a:xfrm>
+            <a:off x="8961120" y="3383280"/>
+            <a:ext cx="2743200" cy="1691640"/>
+          </a:xfrm>
+          <a:prstGeom prst="roundRect">
+            <a:avLst>
+              <a:gd name="adj" fmla="val 6000"/>
+            </a:avLst>
+          </a:prstGeom>
+          <a:solidFill>
+            <a:srgbClr val="FFF8E1"/>
+          </a:solidFill>
+          <a:ln w="19050">
+            <a:solidFill>
+              <a:srgbClr val="FF8F00"/>
+            </a:solidFill>
+          </a:ln>
+        </p:spPr>
+        <p:style>
+          <a:lnRef idx="1">
+            <a:schemeClr val="accent1"/>
+          </a:lnRef>
+          <a:fillRef idx="3">
+            <a:schemeClr val="accent1"/>
+          </a:fillRef>
+          <a:effectRef idx="2">
+            <a:schemeClr val="accent1"/>
+          </a:effectRef>
+          <a:fontRef idx="minor">
+            <a:schemeClr val="lt1"/>
+          </a:fontRef>
+        </p:style>
+        <p:txBody>
+          <a:bodyPr rtlCol="0" anchor="ctr"/>
+          <a:lstStyle/>
+          <a:p>
+            <a:pPr algn="ctr"/>
+          </a:p>
+        </p:txBody>
+      </p:sp>
+      <p:sp>
+        <p:nvSpPr>
+          <p:cNvPr id="70" name="Rectangle 69"/>
+          <p:cNvSpPr/>
+          <p:nvPr/>
+        </p:nvSpPr>
+        <p:spPr>
+          <a:xfrm>
+            <a:off x="8961120" y="3383280"/>
+            <a:ext cx="2743200" cy="347472"/>
+          </a:xfrm>
+          <a:prstGeom prst="rect">
+            <a:avLst/>
+          </a:prstGeom>
+          <a:solidFill>
+            <a:srgbClr val="FF8F00"/>
+          </a:solidFill>
+          <a:ln>
+            <a:noFill/>
+          </a:ln>
+        </p:spPr>
+        <p:style>
+          <a:lnRef idx="1">
+            <a:schemeClr val="accent1"/>
+          </a:lnRef>
+          <a:fillRef idx="3">
+            <a:schemeClr val="accent1"/>
+          </a:fillRef>
+          <a:effectRef idx="2">
+            <a:schemeClr val="accent1"/>
+          </a:effectRef>
+          <a:fontRef idx="minor">
+            <a:schemeClr val="lt1"/>
+          </a:fontRef>
+        </p:style>
+        <p:txBody>
+          <a:bodyPr rtlCol="0" anchor="ctr"/>
+          <a:lstStyle/>
+          <a:p>
+            <a:pPr algn="ctr"/>
+          </a:p>
+        </p:txBody>
+      </p:sp>
+      <p:sp>
+        <p:nvSpPr>
+          <p:cNvPr id="71" name="TextBox 70"/>
+          <p:cNvSpPr txBox="1"/>
+          <p:nvPr/>
+        </p:nvSpPr>
+        <p:spPr>
+          <a:xfrm>
+            <a:off x="8961120" y="3383280"/>
+            <a:ext cx="2743200" cy="347472"/>
+          </a:xfrm>
+          <a:prstGeom prst="rect">
+            <a:avLst/>
+          </a:prstGeom>
+          <a:noFill/>
+        </p:spPr>
+        <p:txBody>
+          <a:bodyPr wrap="square">
+            <a:spAutoFit/>
+          </a:bodyPr>
+          <a:lstStyle/>
+          <a:p>
+            <a:pPr algn="ctr"/>
+            <a:r>
+              <a:rPr sz="1100" b="1" i="0">
+                <a:solidFill>
+                  <a:srgbClr val="FFFFFF"/>
+                </a:solidFill>
+                <a:latin typeface="Calibri"/>
+              </a:rPr>
+              <a:t>Hospital Responsibility</a:t>
+            </a:r>
+          </a:p>
+        </p:txBody>
+      </p:sp>
+      <p:sp>
+        <p:nvSpPr>
+          <p:cNvPr id="72" name="TextBox 71"/>
+          <p:cNvSpPr txBox="1"/>
+          <p:nvPr/>
+        </p:nvSpPr>
+        <p:spPr>
+          <a:xfrm>
+            <a:off x="9098280" y="3803904"/>
+            <a:ext cx="2468880" cy="237744"/>
+          </a:xfrm>
+          <a:prstGeom prst="rect">
+            <a:avLst/>
+          </a:prstGeom>
+          <a:noFill/>
+        </p:spPr>
+        <p:txBody>
+          <a:bodyPr wrap="none">
+            <a:spAutoFit/>
+          </a:bodyPr>
+          <a:lstStyle/>
+          <a:p>
+            <a:r>
+              <a:rPr sz="1000" b="1">
+                <a:solidFill>
+                  <a:srgbClr val="FF8F00"/>
+                </a:solidFill>
+                <a:latin typeface="Calibri"/>
+              </a:rPr>
+              <a:t>▸ </a:t>
+            </a:r>
+            <a:r>
+              <a:rPr sz="950">
+                <a:solidFill>
+                  <a:srgbClr val="2C3E50"/>
+                </a:solidFill>
+                <a:latin typeface="Calibri"/>
+              </a:rPr>
+              <a:t>Clinical decisions (physician)</a:t>
+            </a:r>
+          </a:p>
+        </p:txBody>
+      </p:sp>
+      <p:sp>
+        <p:nvSpPr>
+          <p:cNvPr id="73" name="TextBox 72"/>
+          <p:cNvSpPr txBox="1"/>
+          <p:nvPr/>
+        </p:nvSpPr>
+        <p:spPr>
+          <a:xfrm>
+            <a:off x="9098280" y="4050792"/>
+            <a:ext cx="2468880" cy="237744"/>
+          </a:xfrm>
+          <a:prstGeom prst="rect">
+            <a:avLst/>
+          </a:prstGeom>
+          <a:noFill/>
+        </p:spPr>
+        <p:txBody>
+          <a:bodyPr wrap="none">
+            <a:spAutoFit/>
+          </a:bodyPr>
+          <a:lstStyle/>
+          <a:p>
+            <a:r>
+              <a:rPr sz="1000" b="1">
+                <a:solidFill>
+                  <a:srgbClr val="FF8F00"/>
+                </a:solidFill>
+                <a:latin typeface="Calibri"/>
+              </a:rPr>
+              <a:t>▸ </a:t>
+            </a:r>
+            <a:r>
+              <a:rPr sz="950">
+                <a:solidFill>
+                  <a:srgbClr val="2C3E50"/>
+                </a:solidFill>
+                <a:latin typeface="Calibri"/>
+              </a:rPr>
+              <a:t>HCSA license (deployer)</a:t>
+            </a:r>
+          </a:p>
+        </p:txBody>
+      </p:sp>
+      <p:sp>
+        <p:nvSpPr>
+          <p:cNvPr id="74" name="TextBox 73"/>
+          <p:cNvSpPr txBox="1"/>
+          <p:nvPr/>
+        </p:nvSpPr>
+        <p:spPr>
+          <a:xfrm>
+            <a:off x="9098280" y="4297680"/>
+            <a:ext cx="2468880" cy="237744"/>
+          </a:xfrm>
+          <a:prstGeom prst="rect">
+            <a:avLst/>
+          </a:prstGeom>
+          <a:noFill/>
+        </p:spPr>
+        <p:txBody>
+          <a:bodyPr wrap="none">
+            <a:spAutoFit/>
+          </a:bodyPr>
+          <a:lstStyle/>
+          <a:p>
+            <a:r>
+              <a:rPr sz="1000" b="1">
+                <a:solidFill>
+                  <a:srgbClr val="FF8F00"/>
+                </a:solidFill>
+                <a:latin typeface="Calibri"/>
+              </a:rPr>
+              <a:t>▸ </a:t>
+            </a:r>
+            <a:r>
+              <a:rPr sz="950">
+                <a:solidFill>
+                  <a:srgbClr val="2C3E50"/>
+                </a:solidFill>
+                <a:latin typeface="Calibri"/>
+              </a:rPr>
+              <a:t>Staff training + consent</a:t>
+            </a:r>
+          </a:p>
+        </p:txBody>
+      </p:sp>
+      <p:sp>
+        <p:nvSpPr>
+          <p:cNvPr id="75" name="TextBox 74"/>
+          <p:cNvSpPr txBox="1"/>
+          <p:nvPr/>
+        </p:nvSpPr>
+        <p:spPr>
+          <a:xfrm>
+            <a:off x="9098280" y="4544568"/>
+            <a:ext cx="2468880" cy="237744"/>
+          </a:xfrm>
+          <a:prstGeom prst="rect">
+            <a:avLst/>
+          </a:prstGeom>
+          <a:noFill/>
+        </p:spPr>
+        <p:txBody>
+          <a:bodyPr wrap="none">
+            <a:spAutoFit/>
+          </a:bodyPr>
+          <a:lstStyle/>
+          <a:p>
+            <a:r>
+              <a:rPr sz="1000" b="1">
+                <a:solidFill>
+                  <a:srgbClr val="FF8F00"/>
+                </a:solidFill>
+                <a:latin typeface="Calibri"/>
+              </a:rPr>
+              <a:t>▸ </a:t>
+            </a:r>
+            <a:r>
+              <a:rPr sz="950">
+                <a:solidFill>
+                  <a:srgbClr val="2C3E50"/>
+                </a:solidFill>
+                <a:latin typeface="Calibri"/>
+              </a:rPr>
+              <a:t>EHR access controls</a:t>
+            </a:r>
+          </a:p>
+        </p:txBody>
+      </p:sp>
+      <p:sp>
+        <p:nvSpPr>
+          <p:cNvPr id="76" name="TextBox 75"/>
+          <p:cNvSpPr txBox="1"/>
+          <p:nvPr/>
+        </p:nvSpPr>
+        <p:spPr>
+          <a:xfrm>
+            <a:off x="9098280" y="4791456"/>
+            <a:ext cx="2468880" cy="237744"/>
+          </a:xfrm>
+          <a:prstGeom prst="rect">
+            <a:avLst/>
+          </a:prstGeom>
+          <a:noFill/>
+        </p:spPr>
+        <p:txBody>
+          <a:bodyPr wrap="none">
+            <a:spAutoFit/>
+          </a:bodyPr>
+          <a:lstStyle/>
+          <a:p>
+            <a:r>
+              <a:rPr sz="1000" b="1">
+                <a:solidFill>
+                  <a:srgbClr val="FF8F00"/>
+                </a:solidFill>
+                <a:latin typeface="Calibri"/>
+              </a:rPr>
+              <a:t>▸ </a:t>
+            </a:r>
+            <a:r>
+              <a:rPr sz="950">
+                <a:solidFill>
+                  <a:srgbClr val="2C3E50"/>
+                </a:solidFill>
+                <a:latin typeface="Calibri"/>
+              </a:rPr>
+              <a:t>Adverse event reporting</a:t>
+            </a:r>
+          </a:p>
+        </p:txBody>
+      </p:sp>
+      <p:sp>
+        <p:nvSpPr>
+          <p:cNvPr id="77" name="Rectangle 76"/>
+          <p:cNvSpPr/>
+          <p:nvPr/>
+        </p:nvSpPr>
+        <p:spPr>
+          <a:xfrm>
+            <a:off x="457200" y="4919472"/>
+            <a:ext cx="11247120" cy="347472"/>
+          </a:xfrm>
+          <a:prstGeom prst="rect">
+            <a:avLst/>
+          </a:prstGeom>
+          <a:solidFill>
+            <a:srgbClr val="2C3E50"/>
+          </a:solidFill>
+          <a:ln>
+            <a:noFill/>
+          </a:ln>
+        </p:spPr>
+        <p:style>
+          <a:lnRef idx="1">
+            <a:schemeClr val="accent1"/>
+          </a:lnRef>
+          <a:fillRef idx="3">
+            <a:schemeClr val="accent1"/>
+          </a:fillRef>
+          <a:effectRef idx="2">
+            <a:schemeClr val="accent1"/>
+          </a:effectRef>
+          <a:fontRef idx="minor">
+            <a:schemeClr val="lt1"/>
+          </a:fontRef>
+        </p:style>
+        <p:txBody>
+          <a:bodyPr rtlCol="0" anchor="ctr"/>
+          <a:lstStyle/>
+          <a:p>
+            <a:pPr algn="ctr"/>
+          </a:p>
+        </p:txBody>
+      </p:sp>
+      <p:sp>
+        <p:nvSpPr>
+          <p:cNvPr id="78" name="TextBox 77"/>
+          <p:cNvSpPr txBox="1"/>
+          <p:nvPr/>
+        </p:nvSpPr>
+        <p:spPr>
+          <a:xfrm>
+            <a:off x="457200" y="4919472"/>
+            <a:ext cx="11247120" cy="347472"/>
+          </a:xfrm>
+          <a:prstGeom prst="rect">
+            <a:avLst/>
+          </a:prstGeom>
+          <a:noFill/>
+        </p:spPr>
+        <p:txBody>
+          <a:bodyPr wrap="square">
+            <a:spAutoFit/>
+          </a:bodyPr>
+          <a:lstStyle/>
+          <a:p>
+            <a:pPr algn="ctr"/>
+            <a:r>
+              <a:rPr sz="1200" b="1" i="0">
+                <a:solidFill>
+                  <a:srgbClr val="FFFFFF"/>
+                </a:solidFill>
+                <a:latin typeface="Calibri"/>
+              </a:rPr>
+              <a:t>Security Controls in the Solution</a:t>
+            </a:r>
+          </a:p>
+        </p:txBody>
+      </p:sp>
+      <p:sp>
+        <p:nvSpPr>
+          <p:cNvPr id="79" name="Rounded Rectangle 78"/>
+          <p:cNvSpPr/>
+          <p:nvPr/>
+        </p:nvSpPr>
+        <p:spPr>
+          <a:xfrm>
+            <a:off x="457200" y="5303520"/>
+            <a:ext cx="1783080" cy="804672"/>
+          </a:xfrm>
+          <a:prstGeom prst="roundRect">
+            <a:avLst>
+              <a:gd name="adj" fmla="val 10000"/>
+            </a:avLst>
+          </a:prstGeom>
+          <a:solidFill>
+            <a:srgbClr val="FFE8DA"/>
+          </a:solidFill>
+          <a:ln w="15240">
+            <a:solidFill>
+              <a:srgbClr val="FF6B35"/>
+            </a:solidFill>
+          </a:ln>
+        </p:spPr>
+        <p:style>
+          <a:lnRef idx="1">
+            <a:schemeClr val="accent1"/>
+          </a:lnRef>
+          <a:fillRef idx="3">
+            <a:schemeClr val="accent1"/>
+          </a:fillRef>
+          <a:effectRef idx="2">
+            <a:schemeClr val="accent1"/>
+          </a:effectRef>
+          <a:fontRef idx="minor">
+            <a:schemeClr val="lt1"/>
+          </a:fontRef>
+        </p:style>
+        <p:txBody>
+          <a:bodyPr rtlCol="0" anchor="ctr"/>
+          <a:lstStyle/>
+          <a:p>
+            <a:pPr algn="ctr"/>
+          </a:p>
+        </p:txBody>
+      </p:sp>
+      <p:sp>
+        <p:nvSpPr>
+          <p:cNvPr id="80" name="TextBox 79"/>
+          <p:cNvSpPr txBox="1"/>
+          <p:nvPr/>
+        </p:nvSpPr>
+        <p:spPr>
+          <a:xfrm>
+            <a:off x="457200" y="5340096"/>
+            <a:ext cx="1783080" cy="347472"/>
+          </a:xfrm>
+          <a:prstGeom prst="rect">
+            <a:avLst/>
+          </a:prstGeom>
+          <a:noFill/>
+        </p:spPr>
+        <p:txBody>
+          <a:bodyPr wrap="none">
+            <a:spAutoFit/>
+          </a:bodyPr>
+          <a:lstStyle/>
+          <a:p>
+            <a:pPr algn="ctr"/>
+            <a:r>
+              <a:rPr sz="2000">
+                <a:latin typeface="Segoe UI Emoji"/>
+              </a:rPr>
+              <a:t>🔒</a:t>
+            </a:r>
+          </a:p>
+        </p:txBody>
+      </p:sp>
+      <p:sp>
+        <p:nvSpPr>
+          <p:cNvPr id="81" name="TextBox 80"/>
+          <p:cNvSpPr txBox="1"/>
+          <p:nvPr/>
+        </p:nvSpPr>
+        <p:spPr>
+          <a:xfrm>
+            <a:off x="457200" y="5687568"/>
+            <a:ext cx="1783080" cy="182880"/>
+          </a:xfrm>
+          <a:prstGeom prst="rect">
+            <a:avLst/>
+          </a:prstGeom>
+          <a:noFill/>
+        </p:spPr>
+        <p:txBody>
+          <a:bodyPr wrap="square">
+            <a:spAutoFit/>
+          </a:bodyPr>
+          <a:lstStyle/>
+          <a:p>
+            <a:pPr algn="ctr"/>
+            <a:r>
+              <a:rPr sz="950" b="1" i="0">
+                <a:solidFill>
+                  <a:srgbClr val="CC4F1F"/>
+                </a:solidFill>
+                <a:latin typeface="Calibri"/>
+              </a:rPr>
+              <a:t>PHI Masking</a:t>
+            </a:r>
+          </a:p>
+        </p:txBody>
+      </p:sp>
+      <p:sp>
+        <p:nvSpPr>
+          <p:cNvPr id="82" name="TextBox 81"/>
+          <p:cNvSpPr txBox="1"/>
+          <p:nvPr/>
+        </p:nvSpPr>
+        <p:spPr>
+          <a:xfrm>
+            <a:off x="457200" y="5870448"/>
+            <a:ext cx="1783080" cy="219456"/>
+          </a:xfrm>
+          <a:prstGeom prst="rect">
+            <a:avLst/>
+          </a:prstGeom>
+          <a:noFill/>
+        </p:spPr>
+        <p:txBody>
+          <a:bodyPr wrap="square">
+            <a:spAutoFit/>
+          </a:bodyPr>
+          <a:lstStyle/>
+          <a:p>
+            <a:pPr algn="ctr"/>
+            <a:r>
+              <a:rPr sz="800" b="0" i="1">
+                <a:solidFill>
+                  <a:srgbClr val="646464"/>
+                </a:solidFill>
+                <a:latin typeface="Calibri"/>
+              </a:rPr>
+              <a:t>Comprehend Medical
+tokenizes before model</a:t>
+            </a:r>
+          </a:p>
+        </p:txBody>
+      </p:sp>
+      <p:sp>
+        <p:nvSpPr>
+          <p:cNvPr id="83" name="Rounded Rectangle 82"/>
+          <p:cNvSpPr/>
+          <p:nvPr/>
+        </p:nvSpPr>
+        <p:spPr>
+          <a:xfrm>
+            <a:off x="2331720" y="5303520"/>
+            <a:ext cx="1783080" cy="804672"/>
+          </a:xfrm>
+          <a:prstGeom prst="roundRect">
+            <a:avLst>
+              <a:gd name="adj" fmla="val 10000"/>
+            </a:avLst>
+          </a:prstGeom>
+          <a:solidFill>
+            <a:srgbClr val="FFFFFF"/>
+          </a:solidFill>
+          <a:ln w="15240">
+            <a:solidFill>
+              <a:srgbClr val="FF6B35"/>
+            </a:solidFill>
+          </a:ln>
+        </p:spPr>
+        <p:style>
+          <a:lnRef idx="1">
+            <a:schemeClr val="accent1"/>
+          </a:lnRef>
+          <a:fillRef idx="3">
+            <a:schemeClr val="accent1"/>
+          </a:fillRef>
+          <a:effectRef idx="2">
+            <a:schemeClr val="accent1"/>
+          </a:effectRef>
+          <a:fontRef idx="minor">
+            <a:schemeClr val="lt1"/>
+          </a:fontRef>
+        </p:style>
+        <p:txBody>
+          <a:bodyPr rtlCol="0" anchor="ctr"/>
+          <a:lstStyle/>
+          <a:p>
+            <a:pPr algn="ctr"/>
+          </a:p>
+        </p:txBody>
+      </p:sp>
+      <p:sp>
+        <p:nvSpPr>
+          <p:cNvPr id="84" name="TextBox 83"/>
+          <p:cNvSpPr txBox="1"/>
+          <p:nvPr/>
+        </p:nvSpPr>
+        <p:spPr>
+          <a:xfrm>
+            <a:off x="2331720" y="5340096"/>
+            <a:ext cx="1783080" cy="347472"/>
+          </a:xfrm>
+          <a:prstGeom prst="rect">
+            <a:avLst/>
+          </a:prstGeom>
+          <a:noFill/>
+        </p:spPr>
+        <p:txBody>
+          <a:bodyPr wrap="none">
+            <a:spAutoFit/>
+          </a:bodyPr>
+          <a:lstStyle/>
+          <a:p>
+            <a:pPr algn="ctr"/>
+            <a:r>
+              <a:rPr sz="2000">
+                <a:latin typeface="Segoe UI Emoji"/>
+              </a:rPr>
+              <a:t>🗝️</a:t>
+            </a:r>
+          </a:p>
+        </p:txBody>
+      </p:sp>
+      <p:sp>
+        <p:nvSpPr>
+          <p:cNvPr id="85" name="TextBox 84"/>
+          <p:cNvSpPr txBox="1"/>
+          <p:nvPr/>
+        </p:nvSpPr>
+        <p:spPr>
+          <a:xfrm>
+            <a:off x="2331720" y="5687568"/>
+            <a:ext cx="1783080" cy="182880"/>
+          </a:xfrm>
+          <a:prstGeom prst="rect">
+            <a:avLst/>
+          </a:prstGeom>
+          <a:noFill/>
+        </p:spPr>
+        <p:txBody>
+          <a:bodyPr wrap="square">
+            <a:spAutoFit/>
+          </a:bodyPr>
+          <a:lstStyle/>
+          <a:p>
+            <a:pPr algn="ctr"/>
+            <a:r>
+              <a:rPr sz="950" b="1" i="0">
+                <a:solidFill>
+                  <a:srgbClr val="CC4F1F"/>
+                </a:solidFill>
+                <a:latin typeface="Calibri"/>
+              </a:rPr>
+              <a:t>KMS BYOK</a:t>
+            </a:r>
+          </a:p>
+        </p:txBody>
+      </p:sp>
+      <p:sp>
+        <p:nvSpPr>
+          <p:cNvPr id="86" name="TextBox 85"/>
+          <p:cNvSpPr txBox="1"/>
+          <p:nvPr/>
+        </p:nvSpPr>
+        <p:spPr>
+          <a:xfrm>
+            <a:off x="2331720" y="5870448"/>
+            <a:ext cx="1783080" cy="219456"/>
+          </a:xfrm>
+          <a:prstGeom prst="rect">
+            <a:avLst/>
+          </a:prstGeom>
+          <a:noFill/>
+        </p:spPr>
+        <p:txBody>
+          <a:bodyPr wrap="square">
+            <a:spAutoFit/>
+          </a:bodyPr>
+          <a:lstStyle/>
+          <a:p>
+            <a:pPr algn="ctr"/>
+            <a:r>
+              <a:rPr sz="800" b="0" i="1">
+                <a:solidFill>
+                  <a:srgbClr val="646464"/>
+                </a:solidFill>
+                <a:latin typeface="Calibri"/>
+              </a:rPr>
+              <a:t>Hospital controls
+encryption keys</a:t>
+            </a:r>
+          </a:p>
+        </p:txBody>
+      </p:sp>
+      <p:sp>
+        <p:nvSpPr>
+          <p:cNvPr id="87" name="Rounded Rectangle 86"/>
+          <p:cNvSpPr/>
+          <p:nvPr/>
+        </p:nvSpPr>
+        <p:spPr>
+          <a:xfrm>
+            <a:off x="4206240" y="5303520"/>
+            <a:ext cx="1783080" cy="804672"/>
+          </a:xfrm>
+          <a:prstGeom prst="roundRect">
+            <a:avLst>
+              <a:gd name="adj" fmla="val 10000"/>
+            </a:avLst>
+          </a:prstGeom>
+          <a:solidFill>
+            <a:srgbClr val="FFE8DA"/>
+          </a:solidFill>
+          <a:ln w="15240">
+            <a:solidFill>
+              <a:srgbClr val="FF6B35"/>
+            </a:solidFill>
+          </a:ln>
+        </p:spPr>
+        <p:style>
+          <a:lnRef idx="1">
+            <a:schemeClr val="accent1"/>
+          </a:lnRef>
+          <a:fillRef idx="3">
+            <a:schemeClr val="accent1"/>
+          </a:fillRef>
+          <a:effectRef idx="2">
+            <a:schemeClr val="accent1"/>
+          </a:effectRef>
+          <a:fontRef idx="minor">
+            <a:schemeClr val="lt1"/>
+          </a:fontRef>
+        </p:style>
+        <p:txBody>
+          <a:bodyPr rtlCol="0" anchor="ctr"/>
+          <a:lstStyle/>
+          <a:p>
+            <a:pPr algn="ctr"/>
+          </a:p>
+        </p:txBody>
+      </p:sp>
+      <p:sp>
+        <p:nvSpPr>
+          <p:cNvPr id="88" name="TextBox 87"/>
+          <p:cNvSpPr txBox="1"/>
+          <p:nvPr/>
+        </p:nvSpPr>
+        <p:spPr>
+          <a:xfrm>
+            <a:off x="4206240" y="5340096"/>
+            <a:ext cx="1783080" cy="347472"/>
+          </a:xfrm>
+          <a:prstGeom prst="rect">
+            <a:avLst/>
+          </a:prstGeom>
+          <a:noFill/>
+        </p:spPr>
+        <p:txBody>
+          <a:bodyPr wrap="none">
+            <a:spAutoFit/>
+          </a:bodyPr>
+          <a:lstStyle/>
+          <a:p>
+            <a:pPr algn="ctr"/>
+            <a:r>
+              <a:rPr sz="2000">
+                <a:latin typeface="Segoe UI Emoji"/>
+              </a:rPr>
+              <a:t>📋</a:t>
+            </a:r>
+          </a:p>
+        </p:txBody>
+      </p:sp>
+      <p:sp>
+        <p:nvSpPr>
+          <p:cNvPr id="89" name="TextBox 88"/>
+          <p:cNvSpPr txBox="1"/>
+          <p:nvPr/>
+        </p:nvSpPr>
+        <p:spPr>
+          <a:xfrm>
+            <a:off x="4206240" y="5687568"/>
+            <a:ext cx="1783080" cy="182880"/>
+          </a:xfrm>
+          <a:prstGeom prst="rect">
+            <a:avLst/>
+          </a:prstGeom>
+          <a:noFill/>
+        </p:spPr>
+        <p:txBody>
+          <a:bodyPr wrap="square">
+            <a:spAutoFit/>
+          </a:bodyPr>
+          <a:lstStyle/>
+          <a:p>
+            <a:pPr algn="ctr"/>
+            <a:r>
+              <a:rPr sz="950" b="1" i="0">
+                <a:solidFill>
+                  <a:srgbClr val="CC4F1F"/>
+                </a:solidFill>
+                <a:latin typeface="Calibri"/>
+              </a:rPr>
+              <a:t>Audit Trail</a:t>
+            </a:r>
+          </a:p>
+        </p:txBody>
+      </p:sp>
+      <p:sp>
+        <p:nvSpPr>
+          <p:cNvPr id="90" name="TextBox 89"/>
+          <p:cNvSpPr txBox="1"/>
+          <p:nvPr/>
+        </p:nvSpPr>
+        <p:spPr>
+          <a:xfrm>
+            <a:off x="4206240" y="5870448"/>
+            <a:ext cx="1783080" cy="219456"/>
+          </a:xfrm>
+          <a:prstGeom prst="rect">
+            <a:avLst/>
+          </a:prstGeom>
+          <a:noFill/>
+        </p:spPr>
+        <p:txBody>
+          <a:bodyPr wrap="square">
+            <a:spAutoFit/>
+          </a:bodyPr>
+          <a:lstStyle/>
+          <a:p>
+            <a:pPr algn="ctr"/>
+            <a:r>
+              <a:rPr sz="800" b="0" i="1">
+                <a:solidFill>
+                  <a:srgbClr val="646464"/>
+                </a:solidFill>
+                <a:latin typeface="Calibri"/>
+              </a:rPr>
+              <a:t>S3 Object Lock
+6-year WORM retention</a:t>
+            </a:r>
+          </a:p>
+        </p:txBody>
+      </p:sp>
+      <p:sp>
+        <p:nvSpPr>
+          <p:cNvPr id="91" name="Rounded Rectangle 90"/>
+          <p:cNvSpPr/>
+          <p:nvPr/>
+        </p:nvSpPr>
+        <p:spPr>
+          <a:xfrm>
+            <a:off x="6080760" y="5303520"/>
+            <a:ext cx="1783080" cy="804672"/>
+          </a:xfrm>
+          <a:prstGeom prst="roundRect">
+            <a:avLst>
+              <a:gd name="adj" fmla="val 10000"/>
+            </a:avLst>
+          </a:prstGeom>
+          <a:solidFill>
+            <a:srgbClr val="FFFFFF"/>
+          </a:solidFill>
+          <a:ln w="15240">
+            <a:solidFill>
+              <a:srgbClr val="FF6B35"/>
+            </a:solidFill>
+          </a:ln>
+        </p:spPr>
+        <p:style>
+          <a:lnRef idx="1">
+            <a:schemeClr val="accent1"/>
+          </a:lnRef>
+          <a:fillRef idx="3">
+            <a:schemeClr val="accent1"/>
+          </a:fillRef>
+          <a:effectRef idx="2">
+            <a:schemeClr val="accent1"/>
+          </a:effectRef>
+          <a:fontRef idx="minor">
+            <a:schemeClr val="lt1"/>
+          </a:fontRef>
+        </p:style>
+        <p:txBody>
+          <a:bodyPr rtlCol="0" anchor="ctr"/>
+          <a:lstStyle/>
+          <a:p>
+            <a:pPr algn="ctr"/>
+          </a:p>
+        </p:txBody>
+      </p:sp>
+      <p:sp>
+        <p:nvSpPr>
+          <p:cNvPr id="92" name="TextBox 91"/>
+          <p:cNvSpPr txBox="1"/>
+          <p:nvPr/>
+        </p:nvSpPr>
+        <p:spPr>
+          <a:xfrm>
+            <a:off x="6080760" y="5340096"/>
+            <a:ext cx="1783080" cy="347472"/>
+          </a:xfrm>
+          <a:prstGeom prst="rect">
+            <a:avLst/>
+          </a:prstGeom>
+          <a:noFill/>
+        </p:spPr>
+        <p:txBody>
+          <a:bodyPr wrap="none">
+            <a:spAutoFit/>
+          </a:bodyPr>
+          <a:lstStyle/>
+          <a:p>
+            <a:pPr algn="ctr"/>
+            <a:r>
+              <a:rPr sz="2000">
+                <a:latin typeface="Segoe UI Emoji"/>
+              </a:rPr>
+              <a:t>🛡️</a:t>
+            </a:r>
+          </a:p>
+        </p:txBody>
+      </p:sp>
+      <p:sp>
+        <p:nvSpPr>
+          <p:cNvPr id="93" name="TextBox 92"/>
+          <p:cNvSpPr txBox="1"/>
+          <p:nvPr/>
+        </p:nvSpPr>
+        <p:spPr>
+          <a:xfrm>
+            <a:off x="6080760" y="5687568"/>
+            <a:ext cx="1783080" cy="182880"/>
+          </a:xfrm>
+          <a:prstGeom prst="rect">
+            <a:avLst/>
+          </a:prstGeom>
+          <a:noFill/>
+        </p:spPr>
+        <p:txBody>
+          <a:bodyPr wrap="square">
+            <a:spAutoFit/>
+          </a:bodyPr>
+          <a:lstStyle/>
+          <a:p>
+            <a:pPr algn="ctr"/>
+            <a:r>
+              <a:rPr sz="950" b="1" i="0">
+                <a:solidFill>
+                  <a:srgbClr val="CC4F1F"/>
+                </a:solidFill>
+                <a:latin typeface="Calibri"/>
+              </a:rPr>
+              <a:t>Guardrails</a:t>
+            </a:r>
+          </a:p>
+        </p:txBody>
+      </p:sp>
+      <p:sp>
+        <p:nvSpPr>
+          <p:cNvPr id="94" name="TextBox 93"/>
+          <p:cNvSpPr txBox="1"/>
+          <p:nvPr/>
+        </p:nvSpPr>
+        <p:spPr>
+          <a:xfrm>
+            <a:off x="6080760" y="5870448"/>
+            <a:ext cx="1783080" cy="219456"/>
+          </a:xfrm>
+          <a:prstGeom prst="rect">
+            <a:avLst/>
+          </a:prstGeom>
+          <a:noFill/>
+        </p:spPr>
+        <p:txBody>
+          <a:bodyPr wrap="square">
+            <a:spAutoFit/>
+          </a:bodyPr>
+          <a:lstStyle/>
+          <a:p>
+            <a:pPr algn="ctr"/>
+            <a:r>
+              <a:rPr sz="800" b="0" i="1">
+                <a:solidFill>
+                  <a:srgbClr val="646464"/>
+                </a:solidFill>
+                <a:latin typeface="Calibri"/>
+              </a:rPr>
+              <a:t>Bedrock Guardrails
+grounding + PHI filter</a:t>
+            </a:r>
+          </a:p>
+        </p:txBody>
+      </p:sp>
+      <p:sp>
+        <p:nvSpPr>
+          <p:cNvPr id="95" name="Rounded Rectangle 94"/>
+          <p:cNvSpPr/>
+          <p:nvPr/>
+        </p:nvSpPr>
+        <p:spPr>
+          <a:xfrm>
+            <a:off x="7955280" y="5303520"/>
+            <a:ext cx="1783080" cy="804672"/>
+          </a:xfrm>
+          <a:prstGeom prst="roundRect">
+            <a:avLst>
+              <a:gd name="adj" fmla="val 10000"/>
+            </a:avLst>
+          </a:prstGeom>
+          <a:solidFill>
+            <a:srgbClr val="FFE8DA"/>
+          </a:solidFill>
+          <a:ln w="15240">
+            <a:solidFill>
+              <a:srgbClr val="FF6B35"/>
+            </a:solidFill>
+          </a:ln>
+        </p:spPr>
+        <p:style>
+          <a:lnRef idx="1">
+            <a:schemeClr val="accent1"/>
+          </a:lnRef>
+          <a:fillRef idx="3">
+            <a:schemeClr val="accent1"/>
+          </a:fillRef>
+          <a:effectRef idx="2">
+            <a:schemeClr val="accent1"/>
+          </a:effectRef>
+          <a:fontRef idx="minor">
+            <a:schemeClr val="lt1"/>
+          </a:fontRef>
+        </p:style>
+        <p:txBody>
+          <a:bodyPr rtlCol="0" anchor="ctr"/>
+          <a:lstStyle/>
+          <a:p>
+            <a:pPr algn="ctr"/>
+          </a:p>
+        </p:txBody>
+      </p:sp>
+      <p:sp>
+        <p:nvSpPr>
+          <p:cNvPr id="96" name="TextBox 95"/>
+          <p:cNvSpPr txBox="1"/>
+          <p:nvPr/>
+        </p:nvSpPr>
+        <p:spPr>
+          <a:xfrm>
+            <a:off x="7955280" y="5340096"/>
+            <a:ext cx="1783080" cy="347472"/>
+          </a:xfrm>
+          <a:prstGeom prst="rect">
+            <a:avLst/>
+          </a:prstGeom>
+          <a:noFill/>
+        </p:spPr>
+        <p:txBody>
+          <a:bodyPr wrap="none">
+            <a:spAutoFit/>
+          </a:bodyPr>
+          <a:lstStyle/>
+          <a:p>
+            <a:pPr algn="ctr"/>
+            <a:r>
+              <a:rPr sz="2000">
+                <a:latin typeface="Segoe UI Emoji"/>
+              </a:rPr>
+              <a:t>🌐</a:t>
+            </a:r>
+          </a:p>
+        </p:txBody>
+      </p:sp>
+      <p:sp>
+        <p:nvSpPr>
+          <p:cNvPr id="97" name="TextBox 96"/>
+          <p:cNvSpPr txBox="1"/>
+          <p:nvPr/>
+        </p:nvSpPr>
+        <p:spPr>
+          <a:xfrm>
+            <a:off x="7955280" y="5687568"/>
+            <a:ext cx="1783080" cy="182880"/>
+          </a:xfrm>
+          <a:prstGeom prst="rect">
+            <a:avLst/>
+          </a:prstGeom>
+          <a:noFill/>
+        </p:spPr>
+        <p:txBody>
+          <a:bodyPr wrap="square">
+            <a:spAutoFit/>
+          </a:bodyPr>
+          <a:lstStyle/>
+          <a:p>
+            <a:pPr algn="ctr"/>
+            <a:r>
+              <a:rPr sz="950" b="1" i="0">
+                <a:solidFill>
+                  <a:srgbClr val="CC4F1F"/>
+                </a:solidFill>
+                <a:latin typeface="Calibri"/>
+              </a:rPr>
+              <a:t>Data Residency</a:t>
+            </a:r>
+          </a:p>
+        </p:txBody>
+      </p:sp>
+      <p:sp>
+        <p:nvSpPr>
+          <p:cNvPr id="98" name="TextBox 97"/>
+          <p:cNvSpPr txBox="1"/>
+          <p:nvPr/>
+        </p:nvSpPr>
+        <p:spPr>
+          <a:xfrm>
+            <a:off x="7955280" y="5870448"/>
+            <a:ext cx="1783080" cy="219456"/>
+          </a:xfrm>
+          <a:prstGeom prst="rect">
+            <a:avLst/>
+          </a:prstGeom>
+          <a:noFill/>
+        </p:spPr>
+        <p:txBody>
+          <a:bodyPr wrap="square">
+            <a:spAutoFit/>
+          </a:bodyPr>
+          <a:lstStyle/>
+          <a:p>
+            <a:pPr algn="ctr"/>
+            <a:r>
+              <a:rPr sz="800" b="0" i="1">
+                <a:solidFill>
+                  <a:srgbClr val="646464"/>
+                </a:solidFill>
+                <a:latin typeface="Calibri"/>
+              </a:rPr>
+              <a:t>100% ap-southeast-1
+zero cross-border</a:t>
+            </a:r>
+          </a:p>
+        </p:txBody>
+      </p:sp>
+      <p:sp>
+        <p:nvSpPr>
+          <p:cNvPr id="99" name="Rounded Rectangle 98"/>
+          <p:cNvSpPr/>
+          <p:nvPr/>
+        </p:nvSpPr>
+        <p:spPr>
+          <a:xfrm>
+            <a:off x="9829800" y="5303520"/>
+            <a:ext cx="1783080" cy="804672"/>
+          </a:xfrm>
+          <a:prstGeom prst="roundRect">
+            <a:avLst>
+              <a:gd name="adj" fmla="val 10000"/>
+            </a:avLst>
+          </a:prstGeom>
+          <a:solidFill>
+            <a:srgbClr val="FFFFFF"/>
+          </a:solidFill>
+          <a:ln w="15240">
+            <a:solidFill>
+              <a:srgbClr val="FF6B35"/>
+            </a:solidFill>
+          </a:ln>
+        </p:spPr>
+        <p:style>
+          <a:lnRef idx="1">
+            <a:schemeClr val="accent1"/>
+          </a:lnRef>
+          <a:fillRef idx="3">
+            <a:schemeClr val="accent1"/>
+          </a:fillRef>
+          <a:effectRef idx="2">
+            <a:schemeClr val="accent1"/>
+          </a:effectRef>
+          <a:fontRef idx="minor">
+            <a:schemeClr val="lt1"/>
+          </a:fontRef>
+        </p:style>
+        <p:txBody>
+          <a:bodyPr rtlCol="0" anchor="ctr"/>
+          <a:lstStyle/>
+          <a:p>
+            <a:pPr algn="ctr"/>
+          </a:p>
+        </p:txBody>
+      </p:sp>
+      <p:sp>
+        <p:nvSpPr>
+          <p:cNvPr id="100" name="TextBox 99"/>
+          <p:cNvSpPr txBox="1"/>
+          <p:nvPr/>
+        </p:nvSpPr>
+        <p:spPr>
+          <a:xfrm>
+            <a:off x="9829800" y="5340096"/>
+            <a:ext cx="1783080" cy="347472"/>
+          </a:xfrm>
+          <a:prstGeom prst="rect">
+            <a:avLst/>
+          </a:prstGeom>
+          <a:noFill/>
+        </p:spPr>
+        <p:txBody>
+          <a:bodyPr wrap="none">
+            <a:spAutoFit/>
+          </a:bodyPr>
+          <a:lstStyle/>
+          <a:p>
+            <a:pPr algn="ctr"/>
+            <a:r>
+              <a:rPr sz="2000">
+                <a:latin typeface="Segoe UI Emoji"/>
+              </a:rPr>
+              <a:t>👥</a:t>
+            </a:r>
+          </a:p>
+        </p:txBody>
+      </p:sp>
+      <p:sp>
+        <p:nvSpPr>
+          <p:cNvPr id="101" name="TextBox 100"/>
+          <p:cNvSpPr txBox="1"/>
+          <p:nvPr/>
+        </p:nvSpPr>
+        <p:spPr>
+          <a:xfrm>
+            <a:off x="9829800" y="5687568"/>
+            <a:ext cx="1783080" cy="182880"/>
+          </a:xfrm>
+          <a:prstGeom prst="rect">
+            <a:avLst/>
+          </a:prstGeom>
+          <a:noFill/>
+        </p:spPr>
+        <p:txBody>
+          <a:bodyPr wrap="square">
+            <a:spAutoFit/>
+          </a:bodyPr>
+          <a:lstStyle/>
+          <a:p>
+            <a:pPr algn="ctr"/>
+            <a:r>
+              <a:rPr sz="950" b="1" i="0">
+                <a:solidFill>
+                  <a:srgbClr val="CC4F1F"/>
+                </a:solidFill>
+                <a:latin typeface="Calibri"/>
+              </a:rPr>
+              <a:t>Access Control</a:t>
+            </a:r>
+          </a:p>
+        </p:txBody>
+      </p:sp>
+      <p:sp>
+        <p:nvSpPr>
+          <p:cNvPr id="102" name="TextBox 101"/>
+          <p:cNvSpPr txBox="1"/>
+          <p:nvPr/>
+        </p:nvSpPr>
+        <p:spPr>
+          <a:xfrm>
+            <a:off x="9829800" y="5870448"/>
+            <a:ext cx="1783080" cy="219456"/>
+          </a:xfrm>
+          <a:prstGeom prst="rect">
+            <a:avLst/>
+          </a:prstGeom>
+          <a:noFill/>
+        </p:spPr>
+        <p:txBody>
+          <a:bodyPr wrap="square">
+            <a:spAutoFit/>
+          </a:bodyPr>
+          <a:lstStyle/>
+          <a:p>
+            <a:pPr algn="ctr"/>
+            <a:r>
+              <a:rPr sz="800" b="0" i="1">
+                <a:solidFill>
+                  <a:srgbClr val="646464"/>
+                </a:solidFill>
+                <a:latin typeface="Calibri"/>
+              </a:rPr>
+              <a:t>Cognito + ABAC
+tenant isolation</a:t>
+            </a:r>
+          </a:p>
+        </p:txBody>
+      </p:sp>
+      <p:sp>
+        <p:nvSpPr>
+          <p:cNvPr id="103" name="Rounded Rectangle 102"/>
+          <p:cNvSpPr/>
+          <p:nvPr/>
+        </p:nvSpPr>
+        <p:spPr>
+          <a:xfrm>
+            <a:off x="457200" y="6080760"/>
+            <a:ext cx="11247120" cy="347472"/>
+          </a:xfrm>
+          <a:prstGeom prst="roundRect">
+            <a:avLst>
+              <a:gd name="adj" fmla="val 20000"/>
+            </a:avLst>
+          </a:prstGeom>
+          <a:solidFill>
+            <a:srgbClr val="FF6B35"/>
+          </a:solidFill>
+          <a:ln>
+            <a:noFill/>
+          </a:ln>
+        </p:spPr>
+        <p:style>
+          <a:lnRef idx="1">
+            <a:schemeClr val="accent1"/>
+          </a:lnRef>
+          <a:fillRef idx="3">
+            <a:schemeClr val="accent1"/>
+          </a:fillRef>
+          <a:effectRef idx="2">
+            <a:schemeClr val="accent1"/>
+          </a:effectRef>
+          <a:fontRef idx="minor">
+            <a:schemeClr val="lt1"/>
+          </a:fontRef>
+        </p:style>
+        <p:txBody>
+          <a:bodyPr rtlCol="0" anchor="ctr"/>
+          <a:lstStyle/>
+          <a:p>
+            <a:pPr algn="ctr"/>
+          </a:p>
+        </p:txBody>
+      </p:sp>
+      <p:sp>
+        <p:nvSpPr>
+          <p:cNvPr id="104" name="TextBox 103"/>
+          <p:cNvSpPr txBox="1"/>
+          <p:nvPr/>
+        </p:nvSpPr>
+        <p:spPr>
+          <a:xfrm>
+            <a:off x="640080" y="6117336"/>
+            <a:ext cx="10881360" cy="292608"/>
+          </a:xfrm>
+          <a:prstGeom prst="rect">
+            <a:avLst/>
+          </a:prstGeom>
+          <a:noFill/>
+        </p:spPr>
+        <p:txBody>
+          <a:bodyPr wrap="square">
+            <a:spAutoFit/>
+          </a:bodyPr>
+          <a:lstStyle/>
+          <a:p>
+            <a:pPr algn="ctr"/>
+            <a:r>
+              <a:rPr sz="1100" b="1" i="0">
+                <a:solidFill>
+                  <a:srgbClr val="FFFFFF"/>
+                </a:solidFill>
+                <a:latin typeface="Calibri"/>
+              </a:rPr>
+              <a:t>AWS secures the cloud infrastructure.  Nova secures the application + data.  Hospital secures clinical decisions + staff.</a:t>
             </a:r>
           </a:p>
         </p:txBody>

</xml_diff>